<commit_message>
update: se actualizo el notebook 4 y 5 del proyecto-integradorV3
</commit_message>
<xml_diff>
--- a/proyecto-integradorV3/06-Documentacion/Presentacion_Final_AndinaLog_03B.pptx
+++ b/proyecto-integradorV3/06-Documentacion/Presentacion_Final_AndinaLog_03B.pptx
@@ -1891,7 +1891,7 @@
         </p:nvSpPr>
         <p:spPr>
           <a:xfrm>
-            <a:off x="0" y="0"/>
+            <a:off x="-171450" y="0"/>
             <a:ext cx="7239000" cy="6858000"/>
           </a:xfrm>
           <a:prstGeom prst="rect">
@@ -2233,6 +2233,17 @@
               </a:defRPr>
             </a:pPr>
             <a:r>
+              <a:rPr sz="1350" b="0" i="0" dirty="0" err="1">
+                <a:solidFill>
+                  <a:srgbClr val="EDF2F7"/>
+                </a:solidFill>
+                <a:latin typeface="Arial"/>
+                <a:ea typeface="Arial"/>
+                <a:cs typeface="Arial"/>
+              </a:rPr>
+              <a:t>Integrantes</a:t>
+            </a:r>
+            <a:r>
               <a:rPr sz="1350" b="0" i="0">
                 <a:solidFill>
                   <a:srgbClr val="EDF2F7"/>
@@ -2241,8 +2252,16 @@
                 <a:ea typeface="Arial"/>
                 <a:cs typeface="Arial"/>
               </a:rPr>
-              <a:t>Integrantes: completar antes de exponer</a:t>
-            </a:r>
+              <a:t>:</a:t>
+            </a:r>
+            <a:endParaRPr sz="1350" b="0" i="0" dirty="0">
+              <a:solidFill>
+                <a:srgbClr val="EDF2F7"/>
+              </a:solidFill>
+              <a:latin typeface="Arial"/>
+              <a:ea typeface="Arial"/>
+              <a:cs typeface="Arial"/>
+            </a:endParaRPr>
           </a:p>
         </p:txBody>
       </p:sp>
@@ -2389,16 +2408,46 @@
               </a:defRPr>
             </a:pPr>
             <a:r>
-              <a:rPr sz="1200" b="1" i="0">
-                <a:solidFill>
-                  <a:srgbClr val="1F3864"/>
-                </a:solidFill>
-                <a:latin typeface="Arial"/>
-                <a:ea typeface="Arial"/>
-                <a:cs typeface="Arial"/>
-              </a:rPr>
-              <a:t>Pregunta de negocio</a:t>
-            </a:r>
+              <a:rPr sz="1200" b="1" i="0" dirty="0" err="1">
+                <a:solidFill>
+                  <a:srgbClr val="1F3864"/>
+                </a:solidFill>
+                <a:latin typeface="Arial"/>
+                <a:ea typeface="Arial"/>
+                <a:cs typeface="Arial"/>
+              </a:rPr>
+              <a:t>Pregunta</a:t>
+            </a:r>
+            <a:r>
+              <a:rPr sz="1200" b="1" i="0" dirty="0">
+                <a:solidFill>
+                  <a:srgbClr val="1F3864"/>
+                </a:solidFill>
+                <a:latin typeface="Arial"/>
+                <a:ea typeface="Arial"/>
+                <a:cs typeface="Arial"/>
+              </a:rPr>
+              <a:t> de </a:t>
+            </a:r>
+            <a:r>
+              <a:rPr sz="1200" b="1" i="0" dirty="0" err="1">
+                <a:solidFill>
+                  <a:srgbClr val="1F3864"/>
+                </a:solidFill>
+                <a:latin typeface="Arial"/>
+                <a:ea typeface="Arial"/>
+                <a:cs typeface="Arial"/>
+              </a:rPr>
+              <a:t>negocio</a:t>
+            </a:r>
+            <a:endParaRPr sz="1200" b="1" i="0" dirty="0">
+              <a:solidFill>
+                <a:srgbClr val="1F3864"/>
+              </a:solidFill>
+              <a:latin typeface="Arial"/>
+              <a:ea typeface="Arial"/>
+              <a:cs typeface="Arial"/>
+            </a:endParaRPr>
           </a:p>
         </p:txBody>
       </p:sp>
@@ -4898,7 +4947,7 @@
               </a:defRPr>
             </a:pPr>
             <a:r>
-              <a:rPr sz="1050" b="1" i="0">
+              <a:rPr sz="1050" b="1" i="0" dirty="0">
                 <a:solidFill>
                   <a:srgbClr val="2E5B8A"/>
                 </a:solidFill>
@@ -4956,15 +5005,59 @@
               </a:defRPr>
             </a:pPr>
             <a:r>
-              <a:rPr sz="1275" b="0" i="0">
-                <a:solidFill>
-                  <a:srgbClr val="1F3864"/>
-                </a:solidFill>
-                <a:latin typeface="Arial"/>
-                <a:ea typeface="Arial"/>
-                <a:cs typeface="Arial"/>
-              </a:rPr>
-              <a:t>• Dashboard: prevalencia, recall, precisión y PR AUC</a:t>
+              <a:rPr sz="1275" b="0" i="0" dirty="0">
+                <a:solidFill>
+                  <a:srgbClr val="1F3864"/>
+                </a:solidFill>
+                <a:latin typeface="Arial"/>
+                <a:ea typeface="Arial"/>
+                <a:cs typeface="Arial"/>
+              </a:rPr>
+              <a:t>• Dashboard: </a:t>
+            </a:r>
+            <a:r>
+              <a:rPr sz="1275" b="0" i="0" dirty="0" err="1">
+                <a:solidFill>
+                  <a:srgbClr val="1F3864"/>
+                </a:solidFill>
+                <a:latin typeface="Arial"/>
+                <a:ea typeface="Arial"/>
+                <a:cs typeface="Arial"/>
+              </a:rPr>
+              <a:t>prevalencia</a:t>
+            </a:r>
+            <a:r>
+              <a:rPr sz="1275" b="0" i="0" dirty="0">
+                <a:solidFill>
+                  <a:srgbClr val="1F3864"/>
+                </a:solidFill>
+                <a:latin typeface="Arial"/>
+                <a:ea typeface="Arial"/>
+                <a:cs typeface="Arial"/>
+              </a:rPr>
+              <a:t>, recall, </a:t>
+            </a:r>
+            <a:r>
+              <a:rPr sz="1275" b="0" i="0" dirty="0" err="1">
+                <a:solidFill>
+                  <a:srgbClr val="1F3864"/>
+                </a:solidFill>
+                <a:latin typeface="Arial"/>
+                <a:ea typeface="Arial"/>
+                <a:cs typeface="Arial"/>
+              </a:rPr>
+              <a:t>precisión</a:t>
+            </a:r>
+            <a:r>
+              <a:rPr sz="1275" b="0" i="0" dirty="0">
+                <a:solidFill>
+                  <a:srgbClr val="1F3864"/>
+                </a:solidFill>
+                <a:latin typeface="Arial"/>
+                <a:ea typeface="Arial"/>
+                <a:cs typeface="Arial"/>
+              </a:rPr>
+              <a:t> y PR AUC</a:t>
             </a:r>
           </a:p>
           <a:p>
@@ -4980,16 +5073,101 @@
               </a:defRPr>
             </a:pPr>
             <a:r>
-              <a:rPr sz="1275" b="0" i="0">
-                <a:solidFill>
-                  <a:srgbClr val="1F3864"/>
-                </a:solidFill>
-                <a:latin typeface="Arial"/>
-                <a:ea typeface="Arial"/>
-                <a:cs typeface="Arial"/>
-              </a:rPr>
-              <a:t>• Seguimiento por viaje y periodo</a:t>
-            </a:r>
+              <a:rPr sz="1275" b="0" i="0" dirty="0">
+                <a:solidFill>
+                  <a:srgbClr val="1F3864"/>
+                </a:solidFill>
+                <a:latin typeface="Arial"/>
+                <a:ea typeface="Arial"/>
+                <a:cs typeface="Arial"/>
+              </a:rPr>
+              <a:t>• </a:t>
+            </a:r>
+            <a:r>
+              <a:rPr sz="1275" b="0" i="0" dirty="0" err="1">
+                <a:solidFill>
+                  <a:srgbClr val="1F3864"/>
+                </a:solidFill>
+                <a:latin typeface="Arial"/>
+                <a:ea typeface="Arial"/>
+                <a:cs typeface="Arial"/>
+              </a:rPr>
+              <a:t>Seguimiento</a:t>
+            </a:r>
+            <a:r>
+              <a:rPr sz="1275" b="0" i="0" dirty="0">
+                <a:solidFill>
+                  <a:srgbClr val="1F3864"/>
+                </a:solidFill>
+                <a:latin typeface="Arial"/>
+                <a:ea typeface="Arial"/>
+                <a:cs typeface="Arial"/>
+              </a:rPr>
+              <a:t> </a:t>
+            </a:r>
+            <a:r>
+              <a:rPr sz="1275" b="0" i="0" dirty="0" err="1">
+                <a:solidFill>
+                  <a:srgbClr val="1F3864"/>
+                </a:solidFill>
+                <a:latin typeface="Arial"/>
+                <a:ea typeface="Arial"/>
+                <a:cs typeface="Arial"/>
+              </a:rPr>
+              <a:t>por</a:t>
+            </a:r>
+            <a:r>
+              <a:rPr sz="1275" b="0" i="0" dirty="0">
+                <a:solidFill>
+                  <a:srgbClr val="1F3864"/>
+                </a:solidFill>
+                <a:latin typeface="Arial"/>
+                <a:ea typeface="Arial"/>
+                <a:cs typeface="Arial"/>
+              </a:rPr>
+              <a:t> </a:t>
+            </a:r>
+            <a:r>
+              <a:rPr sz="1275" b="0" i="0" dirty="0" err="1">
+                <a:solidFill>
+                  <a:srgbClr val="1F3864"/>
+                </a:solidFill>
+                <a:latin typeface="Arial"/>
+                <a:ea typeface="Arial"/>
+                <a:cs typeface="Arial"/>
+              </a:rPr>
+              <a:t>viaje</a:t>
+            </a:r>
+            <a:r>
+              <a:rPr sz="1275" b="0" i="0" dirty="0">
+                <a:solidFill>
+                  <a:srgbClr val="1F3864"/>
+                </a:solidFill>
+                <a:latin typeface="Arial"/>
+                <a:ea typeface="Arial"/>
+                <a:cs typeface="Arial"/>
+              </a:rPr>
+              <a:t> y </a:t>
+            </a:r>
+            <a:r>
+              <a:rPr sz="1275" b="0" i="0" dirty="0" err="1">
+                <a:solidFill>
+                  <a:srgbClr val="1F3864"/>
+                </a:solidFill>
+                <a:latin typeface="Arial"/>
+                <a:ea typeface="Arial"/>
+                <a:cs typeface="Arial"/>
+              </a:rPr>
+              <a:t>periodo</a:t>
+            </a:r>
+            <a:endParaRPr sz="1275" b="0" i="0" dirty="0">
+              <a:solidFill>
+                <a:srgbClr val="1F3864"/>
+              </a:solidFill>
+              <a:latin typeface="Arial"/>
+              <a:ea typeface="Arial"/>
+              <a:cs typeface="Arial"/>
+            </a:endParaRPr>
           </a:p>
           <a:p>
             <a:pPr algn="l">
@@ -5004,16 +5182,101 @@
               </a:defRPr>
             </a:pPr>
             <a:r>
-              <a:rPr sz="1275" b="0" i="0">
-                <a:solidFill>
-                  <a:srgbClr val="1F3864"/>
-                </a:solidFill>
-                <a:latin typeface="Arial"/>
-                <a:ea typeface="Arial"/>
-                <a:cs typeface="Arial"/>
-              </a:rPr>
-              <a:t>• Incorporar nuevos datos de operación</a:t>
-            </a:r>
+              <a:rPr sz="1275" b="0" i="0" dirty="0">
+                <a:solidFill>
+                  <a:srgbClr val="1F3864"/>
+                </a:solidFill>
+                <a:latin typeface="Arial"/>
+                <a:ea typeface="Arial"/>
+                <a:cs typeface="Arial"/>
+              </a:rPr>
+              <a:t>• </a:t>
+            </a:r>
+            <a:r>
+              <a:rPr sz="1275" b="0" i="0" dirty="0" err="1">
+                <a:solidFill>
+                  <a:srgbClr val="1F3864"/>
+                </a:solidFill>
+                <a:latin typeface="Arial"/>
+                <a:ea typeface="Arial"/>
+                <a:cs typeface="Arial"/>
+              </a:rPr>
+              <a:t>Incorporar</a:t>
+            </a:r>
+            <a:r>
+              <a:rPr sz="1275" b="0" i="0" dirty="0">
+                <a:solidFill>
+                  <a:srgbClr val="1F3864"/>
+                </a:solidFill>
+                <a:latin typeface="Arial"/>
+                <a:ea typeface="Arial"/>
+                <a:cs typeface="Arial"/>
+              </a:rPr>
+              <a:t> </a:t>
+            </a:r>
+            <a:r>
+              <a:rPr sz="1275" b="0" i="0" dirty="0" err="1">
+                <a:solidFill>
+                  <a:srgbClr val="1F3864"/>
+                </a:solidFill>
+                <a:latin typeface="Arial"/>
+                <a:ea typeface="Arial"/>
+                <a:cs typeface="Arial"/>
+              </a:rPr>
+              <a:t>nuevos</a:t>
+            </a:r>
+            <a:r>
+              <a:rPr sz="1275" b="0" i="0" dirty="0">
+                <a:solidFill>
+                  <a:srgbClr val="1F3864"/>
+                </a:solidFill>
+                <a:latin typeface="Arial"/>
+                <a:ea typeface="Arial"/>
+                <a:cs typeface="Arial"/>
+              </a:rPr>
+              <a:t> </a:t>
+            </a:r>
+            <a:r>
+              <a:rPr sz="1275" b="0" i="0" dirty="0" err="1">
+                <a:solidFill>
+                  <a:srgbClr val="1F3864"/>
+                </a:solidFill>
+                <a:latin typeface="Arial"/>
+                <a:ea typeface="Arial"/>
+                <a:cs typeface="Arial"/>
+              </a:rPr>
+              <a:t>datos</a:t>
+            </a:r>
+            <a:r>
+              <a:rPr sz="1275" b="0" i="0" dirty="0">
+                <a:solidFill>
+                  <a:srgbClr val="1F3864"/>
+                </a:solidFill>
+                <a:latin typeface="Arial"/>
+                <a:ea typeface="Arial"/>
+                <a:cs typeface="Arial"/>
+              </a:rPr>
+              <a:t> de </a:t>
+            </a:r>
+            <a:r>
+              <a:rPr sz="1275" b="0" i="0" dirty="0" err="1">
+                <a:solidFill>
+                  <a:srgbClr val="1F3864"/>
+                </a:solidFill>
+                <a:latin typeface="Arial"/>
+                <a:ea typeface="Arial"/>
+                <a:cs typeface="Arial"/>
+              </a:rPr>
+              <a:t>operación</a:t>
+            </a:r>
+            <a:endParaRPr sz="1275" b="0" i="0" dirty="0">
+              <a:solidFill>
+                <a:srgbClr val="1F3864"/>
+              </a:solidFill>
+              <a:latin typeface="Arial"/>
+              <a:ea typeface="Arial"/>
+              <a:cs typeface="Arial"/>
+            </a:endParaRPr>
           </a:p>
           <a:p>
             <a:pPr algn="l">
@@ -5028,16 +5291,57 @@
               </a:defRPr>
             </a:pPr>
             <a:r>
-              <a:rPr sz="1275" b="0" i="0">
-                <a:solidFill>
-                  <a:srgbClr val="1F3864"/>
-                </a:solidFill>
-                <a:latin typeface="Arial"/>
-                <a:ea typeface="Arial"/>
-                <a:cs typeface="Arial"/>
-              </a:rPr>
-              <a:t>• Revalidar el umbral antes del despliegue</a:t>
-            </a:r>
+              <a:rPr sz="1275" b="0" i="0" dirty="0">
+                <a:solidFill>
+                  <a:srgbClr val="1F3864"/>
+                </a:solidFill>
+                <a:latin typeface="Arial"/>
+                <a:ea typeface="Arial"/>
+                <a:cs typeface="Arial"/>
+              </a:rPr>
+              <a:t>• </a:t>
+            </a:r>
+            <a:r>
+              <a:rPr sz="1275" b="0" i="0" dirty="0" err="1">
+                <a:solidFill>
+                  <a:srgbClr val="1F3864"/>
+                </a:solidFill>
+                <a:latin typeface="Arial"/>
+                <a:ea typeface="Arial"/>
+                <a:cs typeface="Arial"/>
+              </a:rPr>
+              <a:t>Revalidar</a:t>
+            </a:r>
+            <a:r>
+              <a:rPr sz="1275" b="0" i="0" dirty="0">
+                <a:solidFill>
+                  <a:srgbClr val="1F3864"/>
+                </a:solidFill>
+                <a:latin typeface="Arial"/>
+                <a:ea typeface="Arial"/>
+                <a:cs typeface="Arial"/>
+              </a:rPr>
+              <a:t> el umbral antes del </a:t>
+            </a:r>
+            <a:r>
+              <a:rPr sz="1275" b="0" i="0" dirty="0" err="1">
+                <a:solidFill>
+                  <a:srgbClr val="1F3864"/>
+                </a:solidFill>
+                <a:latin typeface="Arial"/>
+                <a:ea typeface="Arial"/>
+                <a:cs typeface="Arial"/>
+              </a:rPr>
+              <a:t>despliegue</a:t>
+            </a:r>
+            <a:endParaRPr sz="1275" b="0" i="0" dirty="0">
+              <a:solidFill>
+                <a:srgbClr val="1F3864"/>
+              </a:solidFill>
+              <a:latin typeface="Arial"/>
+              <a:ea typeface="Arial"/>
+              <a:cs typeface="Arial"/>
+            </a:endParaRPr>
           </a:p>
         </p:txBody>
       </p:sp>
@@ -7251,7 +7555,7 @@
               </a:defRPr>
             </a:pPr>
             <a:r>
-              <a:rPr sz="1125" b="0" i="0">
+              <a:rPr sz="1125" b="0" i="0" dirty="0">
                 <a:solidFill>
                   <a:srgbClr val="1F3864"/>
                 </a:solidFill>
@@ -7447,16 +7751,134 @@
               </a:defRPr>
             </a:pPr>
             <a:r>
-              <a:rPr sz="1125" b="0" i="0">
-                <a:solidFill>
-                  <a:srgbClr val="1F3864"/>
-                </a:solidFill>
-                <a:latin typeface="Arial"/>
-                <a:ea typeface="Arial"/>
-                <a:cs typeface="Arial"/>
-              </a:rPr>
-              <a:t>Temperatura y humedad actuales, desviación actual y dos antecedentes térmicos</a:t>
-            </a:r>
+              <a:rPr sz="1125" b="0" i="0" dirty="0" err="1">
+                <a:solidFill>
+                  <a:srgbClr val="1F3864"/>
+                </a:solidFill>
+                <a:latin typeface="Arial"/>
+                <a:ea typeface="Arial"/>
+                <a:cs typeface="Arial"/>
+              </a:rPr>
+              <a:t>Temperatura</a:t>
+            </a:r>
+            <a:r>
+              <a:rPr sz="1125" b="0" i="0" dirty="0">
+                <a:solidFill>
+                  <a:srgbClr val="1F3864"/>
+                </a:solidFill>
+                <a:latin typeface="Arial"/>
+                <a:ea typeface="Arial"/>
+                <a:cs typeface="Arial"/>
+              </a:rPr>
+              <a:t> y </a:t>
+            </a:r>
+            <a:r>
+              <a:rPr sz="1125" b="0" i="0" dirty="0" err="1">
+                <a:solidFill>
+                  <a:srgbClr val="1F3864"/>
+                </a:solidFill>
+                <a:latin typeface="Arial"/>
+                <a:ea typeface="Arial"/>
+                <a:cs typeface="Arial"/>
+              </a:rPr>
+              <a:t>humedad</a:t>
+            </a:r>
+            <a:r>
+              <a:rPr sz="1125" b="0" i="0" dirty="0">
+                <a:solidFill>
+                  <a:srgbClr val="1F3864"/>
+                </a:solidFill>
+                <a:latin typeface="Arial"/>
+                <a:ea typeface="Arial"/>
+                <a:cs typeface="Arial"/>
+              </a:rPr>
+              <a:t> </a:t>
+            </a:r>
+            <a:r>
+              <a:rPr sz="1125" b="0" i="0" dirty="0" err="1">
+                <a:solidFill>
+                  <a:srgbClr val="1F3864"/>
+                </a:solidFill>
+                <a:latin typeface="Arial"/>
+                <a:ea typeface="Arial"/>
+                <a:cs typeface="Arial"/>
+              </a:rPr>
+              <a:t>actuales</a:t>
+            </a:r>
+            <a:r>
+              <a:rPr sz="1125" b="0" i="0" dirty="0">
+                <a:solidFill>
+                  <a:srgbClr val="1F3864"/>
+                </a:solidFill>
+                <a:latin typeface="Arial"/>
+                <a:ea typeface="Arial"/>
+                <a:cs typeface="Arial"/>
+              </a:rPr>
+              <a:t>, </a:t>
+            </a:r>
+            <a:r>
+              <a:rPr sz="1125" b="0" i="0" dirty="0" err="1">
+                <a:solidFill>
+                  <a:srgbClr val="1F3864"/>
+                </a:solidFill>
+                <a:latin typeface="Arial"/>
+                <a:ea typeface="Arial"/>
+                <a:cs typeface="Arial"/>
+              </a:rPr>
+              <a:t>desviación</a:t>
+            </a:r>
+            <a:r>
+              <a:rPr sz="1125" b="0" i="0" dirty="0">
+                <a:solidFill>
+                  <a:srgbClr val="1F3864"/>
+                </a:solidFill>
+                <a:latin typeface="Arial"/>
+                <a:ea typeface="Arial"/>
+                <a:cs typeface="Arial"/>
+              </a:rPr>
+              <a:t> actual y dos </a:t>
+            </a:r>
+            <a:r>
+              <a:rPr sz="1125" b="0" i="0" dirty="0" err="1">
+                <a:solidFill>
+                  <a:srgbClr val="1F3864"/>
+                </a:solidFill>
+                <a:latin typeface="Arial"/>
+                <a:ea typeface="Arial"/>
+                <a:cs typeface="Arial"/>
+              </a:rPr>
+              <a:t>antecedentes</a:t>
+            </a:r>
+            <a:r>
+              <a:rPr sz="1125" b="0" i="0" dirty="0">
+                <a:solidFill>
+                  <a:srgbClr val="1F3864"/>
+                </a:solidFill>
+                <a:latin typeface="Arial"/>
+                <a:ea typeface="Arial"/>
+                <a:cs typeface="Arial"/>
+              </a:rPr>
+              <a:t> </a:t>
+            </a:r>
+            <a:r>
+              <a:rPr sz="1125" b="0" i="0" dirty="0" err="1">
+                <a:solidFill>
+                  <a:srgbClr val="1F3864"/>
+                </a:solidFill>
+                <a:latin typeface="Arial"/>
+                <a:ea typeface="Arial"/>
+                <a:cs typeface="Arial"/>
+              </a:rPr>
+              <a:t>térmicos</a:t>
+            </a:r>
+            <a:endParaRPr sz="1125" b="0" i="0" dirty="0">
+              <a:solidFill>
+                <a:srgbClr val="1F3864"/>
+              </a:solidFill>
+              <a:latin typeface="Arial"/>
+              <a:ea typeface="Arial"/>
+              <a:cs typeface="Arial"/>
+            </a:endParaRPr>
           </a:p>
         </p:txBody>
       </p:sp>
@@ -8729,7 +9151,7 @@
               </a:defRPr>
             </a:pPr>
             <a:r>
-              <a:rPr sz="900" b="1" i="0">
+              <a:rPr sz="900" b="1" i="0" dirty="0">
                 <a:solidFill>
                   <a:srgbClr val="2E5B8A"/>
                 </a:solidFill>
@@ -8787,15 +9209,37 @@
               </a:defRPr>
             </a:pPr>
             <a:r>
-              <a:rPr sz="1575" b="1" i="0">
-                <a:solidFill>
-                  <a:srgbClr val="1F3864"/>
-                </a:solidFill>
-                <a:latin typeface="Arial"/>
-                <a:ea typeface="Arial"/>
-                <a:cs typeface="Arial"/>
-              </a:rPr>
-              <a:t>28.920 lecturas Bronze</a:t>
+              <a:rPr sz="1575" b="1" i="0" dirty="0">
+                <a:solidFill>
+                  <a:srgbClr val="1F3864"/>
+                </a:solidFill>
+                <a:latin typeface="Arial"/>
+                <a:ea typeface="Arial"/>
+                <a:cs typeface="Arial"/>
+              </a:rPr>
+              <a:t>28.920 </a:t>
+            </a:r>
+            <a:r>
+              <a:rPr sz="1575" b="1" i="0" dirty="0" err="1">
+                <a:solidFill>
+                  <a:srgbClr val="1F3864"/>
+                </a:solidFill>
+                <a:latin typeface="Arial"/>
+                <a:ea typeface="Arial"/>
+                <a:cs typeface="Arial"/>
+              </a:rPr>
+              <a:t>lecturas</a:t>
+            </a:r>
+            <a:r>
+              <a:rPr sz="1575" b="1" i="0" dirty="0">
+                <a:solidFill>
+                  <a:srgbClr val="1F3864"/>
+                </a:solidFill>
+                <a:latin typeface="Arial"/>
+                <a:ea typeface="Arial"/>
+                <a:cs typeface="Arial"/>
+              </a:rPr>
+              <a:t> Bronze</a:t>
             </a:r>
           </a:p>
         </p:txBody>
@@ -8885,16 +9329,35 @@
               </a:defRPr>
             </a:pPr>
             <a:r>
-              <a:rPr sz="1425" b="1" i="0">
-                <a:solidFill>
-                  <a:srgbClr val="1F3864"/>
-                </a:solidFill>
-                <a:latin typeface="Arial"/>
-                <a:ea typeface="Arial"/>
-                <a:cs typeface="Arial"/>
-              </a:rPr>
-              <a:t>Fuentes y alcance</a:t>
-            </a:r>
+              <a:rPr sz="1425" b="1" i="0" dirty="0">
+                <a:solidFill>
+                  <a:srgbClr val="1F3864"/>
+                </a:solidFill>
+                <a:latin typeface="Arial"/>
+                <a:ea typeface="Arial"/>
+                <a:cs typeface="Arial"/>
+              </a:rPr>
+              <a:t>Fuentes y </a:t>
+            </a:r>
+            <a:r>
+              <a:rPr sz="1425" b="1" i="0" dirty="0" err="1">
+                <a:solidFill>
+                  <a:srgbClr val="1F3864"/>
+                </a:solidFill>
+                <a:latin typeface="Arial"/>
+                <a:ea typeface="Arial"/>
+                <a:cs typeface="Arial"/>
+              </a:rPr>
+              <a:t>alcance</a:t>
+            </a:r>
+            <a:endParaRPr sz="1425" b="1" i="0" dirty="0">
+              <a:solidFill>
+                <a:srgbClr val="1F3864"/>
+              </a:solidFill>
+              <a:latin typeface="Arial"/>
+              <a:ea typeface="Arial"/>
+              <a:cs typeface="Arial"/>
+            </a:endParaRPr>
           </a:p>
         </p:txBody>
       </p:sp>
@@ -8943,16 +9406,57 @@
               </a:defRPr>
             </a:pPr>
             <a:r>
-              <a:rPr sz="1275" b="0" i="0">
-                <a:solidFill>
-                  <a:srgbClr val="1F3864"/>
-                </a:solidFill>
-                <a:latin typeface="Arial"/>
-                <a:ea typeface="Arial"/>
-                <a:cs typeface="Arial"/>
-              </a:rPr>
-              <a:t>• Fuente: telemetría IoT de AndinaLog</a:t>
-            </a:r>
+              <a:rPr sz="1275" b="0" i="0" dirty="0">
+                <a:solidFill>
+                  <a:srgbClr val="1F3864"/>
+                </a:solidFill>
+                <a:latin typeface="Arial"/>
+                <a:ea typeface="Arial"/>
+                <a:cs typeface="Arial"/>
+              </a:rPr>
+              <a:t>• Fuente: </a:t>
+            </a:r>
+            <a:r>
+              <a:rPr sz="1275" b="0" i="0" dirty="0" err="1">
+                <a:solidFill>
+                  <a:srgbClr val="1F3864"/>
+                </a:solidFill>
+                <a:latin typeface="Arial"/>
+                <a:ea typeface="Arial"/>
+                <a:cs typeface="Arial"/>
+              </a:rPr>
+              <a:t>telemetría</a:t>
+            </a:r>
+            <a:r>
+              <a:rPr sz="1275" b="0" i="0" dirty="0">
+                <a:solidFill>
+                  <a:srgbClr val="1F3864"/>
+                </a:solidFill>
+                <a:latin typeface="Arial"/>
+                <a:ea typeface="Arial"/>
+                <a:cs typeface="Arial"/>
+              </a:rPr>
+              <a:t> IoT de </a:t>
+            </a:r>
+            <a:r>
+              <a:rPr sz="1275" b="0" i="0" dirty="0" err="1">
+                <a:solidFill>
+                  <a:srgbClr val="1F3864"/>
+                </a:solidFill>
+                <a:latin typeface="Arial"/>
+                <a:ea typeface="Arial"/>
+                <a:cs typeface="Arial"/>
+              </a:rPr>
+              <a:t>AndinaLog</a:t>
+            </a:r>
+            <a:endParaRPr sz="1275" b="0" i="0" dirty="0">
+              <a:solidFill>
+                <a:srgbClr val="1F3864"/>
+              </a:solidFill>
+              <a:latin typeface="Arial"/>
+              <a:ea typeface="Arial"/>
+              <a:cs typeface="Arial"/>
+            </a:endParaRPr>
           </a:p>
           <a:p>
             <a:pPr algn="l">
@@ -8967,16 +9471,101 @@
               </a:defRPr>
             </a:pPr>
             <a:r>
-              <a:rPr sz="1275" b="0" i="0">
-                <a:solidFill>
-                  <a:srgbClr val="1F3864"/>
-                </a:solidFill>
-                <a:latin typeface="Arial"/>
-                <a:ea typeface="Arial"/>
-                <a:cs typeface="Arial"/>
-              </a:rPr>
-              <a:t>• Una lectura por viaje y momento</a:t>
-            </a:r>
+              <a:rPr sz="1275" b="0" i="0" dirty="0">
+                <a:solidFill>
+                  <a:srgbClr val="1F3864"/>
+                </a:solidFill>
+                <a:latin typeface="Arial"/>
+                <a:ea typeface="Arial"/>
+                <a:cs typeface="Arial"/>
+              </a:rPr>
+              <a:t>• Una </a:t>
+            </a:r>
+            <a:r>
+              <a:rPr sz="1275" b="0" i="0" dirty="0" err="1">
+                <a:solidFill>
+                  <a:srgbClr val="1F3864"/>
+                </a:solidFill>
+                <a:latin typeface="Arial"/>
+                <a:ea typeface="Arial"/>
+                <a:cs typeface="Arial"/>
+              </a:rPr>
+              <a:t>lectura</a:t>
+            </a:r>
+            <a:r>
+              <a:rPr sz="1275" b="0" i="0" dirty="0">
+                <a:solidFill>
+                  <a:srgbClr val="1F3864"/>
+                </a:solidFill>
+                <a:latin typeface="Arial"/>
+                <a:ea typeface="Arial"/>
+                <a:cs typeface="Arial"/>
+              </a:rPr>
+              <a:t> </a:t>
+            </a:r>
+            <a:r>
+              <a:rPr sz="1275" b="0" i="0" dirty="0" err="1">
+                <a:solidFill>
+                  <a:srgbClr val="1F3864"/>
+                </a:solidFill>
+                <a:latin typeface="Arial"/>
+                <a:ea typeface="Arial"/>
+                <a:cs typeface="Arial"/>
+              </a:rPr>
+              <a:t>por</a:t>
+            </a:r>
+            <a:r>
+              <a:rPr sz="1275" b="0" i="0" dirty="0">
+                <a:solidFill>
+                  <a:srgbClr val="1F3864"/>
+                </a:solidFill>
+                <a:latin typeface="Arial"/>
+                <a:ea typeface="Arial"/>
+                <a:cs typeface="Arial"/>
+              </a:rPr>
+              <a:t> </a:t>
+            </a:r>
+            <a:r>
+              <a:rPr sz="1275" b="0" i="0" dirty="0" err="1">
+                <a:solidFill>
+                  <a:srgbClr val="1F3864"/>
+                </a:solidFill>
+                <a:latin typeface="Arial"/>
+                <a:ea typeface="Arial"/>
+                <a:cs typeface="Arial"/>
+              </a:rPr>
+              <a:t>viaje</a:t>
+            </a:r>
+            <a:r>
+              <a:rPr sz="1275" b="0" i="0" dirty="0">
+                <a:solidFill>
+                  <a:srgbClr val="1F3864"/>
+                </a:solidFill>
+                <a:latin typeface="Arial"/>
+                <a:ea typeface="Arial"/>
+                <a:cs typeface="Arial"/>
+              </a:rPr>
+              <a:t> y </a:t>
+            </a:r>
+            <a:r>
+              <a:rPr sz="1275" b="0" i="0" dirty="0" err="1">
+                <a:solidFill>
+                  <a:srgbClr val="1F3864"/>
+                </a:solidFill>
+                <a:latin typeface="Arial"/>
+                <a:ea typeface="Arial"/>
+                <a:cs typeface="Arial"/>
+              </a:rPr>
+              <a:t>momento</a:t>
+            </a:r>
+            <a:endParaRPr sz="1275" b="0" i="0" dirty="0">
+              <a:solidFill>
+                <a:srgbClr val="1F3864"/>
+              </a:solidFill>
+              <a:latin typeface="Arial"/>
+              <a:ea typeface="Arial"/>
+              <a:cs typeface="Arial"/>
+            </a:endParaRPr>
           </a:p>
           <a:p>
             <a:pPr algn="l">
@@ -8991,16 +9580,57 @@
               </a:defRPr>
             </a:pPr>
             <a:r>
-              <a:rPr sz="1275" b="0" i="0">
-                <a:solidFill>
-                  <a:srgbClr val="1F3864"/>
-                </a:solidFill>
-                <a:latin typeface="Arial"/>
-                <a:ea typeface="Arial"/>
-                <a:cs typeface="Arial"/>
-              </a:rPr>
-              <a:t>• 1.200 viajes observados</a:t>
-            </a:r>
+              <a:rPr sz="1275" b="0" i="0" dirty="0">
+                <a:solidFill>
+                  <a:srgbClr val="1F3864"/>
+                </a:solidFill>
+                <a:latin typeface="Arial"/>
+                <a:ea typeface="Arial"/>
+                <a:cs typeface="Arial"/>
+              </a:rPr>
+              <a:t>• 1.200 </a:t>
+            </a:r>
+            <a:r>
+              <a:rPr sz="1275" b="0" i="0" dirty="0" err="1">
+                <a:solidFill>
+                  <a:srgbClr val="1F3864"/>
+                </a:solidFill>
+                <a:latin typeface="Arial"/>
+                <a:ea typeface="Arial"/>
+                <a:cs typeface="Arial"/>
+              </a:rPr>
+              <a:t>viajes</a:t>
+            </a:r>
+            <a:r>
+              <a:rPr sz="1275" b="0" i="0" dirty="0">
+                <a:solidFill>
+                  <a:srgbClr val="1F3864"/>
+                </a:solidFill>
+                <a:latin typeface="Arial"/>
+                <a:ea typeface="Arial"/>
+                <a:cs typeface="Arial"/>
+              </a:rPr>
+              <a:t> </a:t>
+            </a:r>
+            <a:r>
+              <a:rPr sz="1275" b="0" i="0" dirty="0" err="1">
+                <a:solidFill>
+                  <a:srgbClr val="1F3864"/>
+                </a:solidFill>
+                <a:latin typeface="Arial"/>
+                <a:ea typeface="Arial"/>
+                <a:cs typeface="Arial"/>
+              </a:rPr>
+              <a:t>observados</a:t>
+            </a:r>
+            <a:endParaRPr sz="1275" b="0" i="0" dirty="0">
+              <a:solidFill>
+                <a:srgbClr val="1F3864"/>
+              </a:solidFill>
+              <a:latin typeface="Arial"/>
+              <a:ea typeface="Arial"/>
+              <a:cs typeface="Arial"/>
+            </a:endParaRPr>
           </a:p>
           <a:p>
             <a:pPr algn="l">
@@ -9015,16 +9645,79 @@
               </a:defRPr>
             </a:pPr>
             <a:r>
-              <a:rPr sz="1275" b="0" i="0">
-                <a:solidFill>
-                  <a:srgbClr val="1F3864"/>
-                </a:solidFill>
-                <a:latin typeface="Arial"/>
-                <a:ea typeface="Arial"/>
-                <a:cs typeface="Arial"/>
-              </a:rPr>
-              <a:t>• Temperatura y humedad de cabina</a:t>
-            </a:r>
+              <a:rPr sz="1275" b="0" i="0" dirty="0">
+                <a:solidFill>
+                  <a:srgbClr val="1F3864"/>
+                </a:solidFill>
+                <a:latin typeface="Arial"/>
+                <a:ea typeface="Arial"/>
+                <a:cs typeface="Arial"/>
+              </a:rPr>
+              <a:t>• </a:t>
+            </a:r>
+            <a:r>
+              <a:rPr sz="1275" b="0" i="0" dirty="0" err="1">
+                <a:solidFill>
+                  <a:srgbClr val="1F3864"/>
+                </a:solidFill>
+                <a:latin typeface="Arial"/>
+                <a:ea typeface="Arial"/>
+                <a:cs typeface="Arial"/>
+              </a:rPr>
+              <a:t>Temperatura</a:t>
+            </a:r>
+            <a:r>
+              <a:rPr sz="1275" b="0" i="0" dirty="0">
+                <a:solidFill>
+                  <a:srgbClr val="1F3864"/>
+                </a:solidFill>
+                <a:latin typeface="Arial"/>
+                <a:ea typeface="Arial"/>
+                <a:cs typeface="Arial"/>
+              </a:rPr>
+              <a:t> y </a:t>
+            </a:r>
+            <a:r>
+              <a:rPr sz="1275" b="0" i="0" dirty="0" err="1">
+                <a:solidFill>
+                  <a:srgbClr val="1F3864"/>
+                </a:solidFill>
+                <a:latin typeface="Arial"/>
+                <a:ea typeface="Arial"/>
+                <a:cs typeface="Arial"/>
+              </a:rPr>
+              <a:t>humedad</a:t>
+            </a:r>
+            <a:r>
+              <a:rPr sz="1275" b="0" i="0" dirty="0">
+                <a:solidFill>
+                  <a:srgbClr val="1F3864"/>
+                </a:solidFill>
+                <a:latin typeface="Arial"/>
+                <a:ea typeface="Arial"/>
+                <a:cs typeface="Arial"/>
+              </a:rPr>
+              <a:t> de </a:t>
+            </a:r>
+            <a:r>
+              <a:rPr sz="1275" b="0" i="0" dirty="0" err="1">
+                <a:solidFill>
+                  <a:srgbClr val="1F3864"/>
+                </a:solidFill>
+                <a:latin typeface="Arial"/>
+                <a:ea typeface="Arial"/>
+                <a:cs typeface="Arial"/>
+              </a:rPr>
+              <a:t>cabina</a:t>
+            </a:r>
+            <a:endParaRPr sz="1275" b="0" i="0" dirty="0">
+              <a:solidFill>
+                <a:srgbClr val="1F3864"/>
+              </a:solidFill>
+              <a:latin typeface="Arial"/>
+              <a:ea typeface="Arial"/>
+              <a:cs typeface="Arial"/>
+            </a:endParaRPr>
           </a:p>
           <a:p>
             <a:pPr algn="l">
@@ -9039,16 +9732,101 @@
               </a:defRPr>
             </a:pPr>
             <a:r>
-              <a:rPr sz="1275" b="0" i="0">
-                <a:solidFill>
-                  <a:srgbClr val="1F3864"/>
-                </a:solidFill>
-                <a:latin typeface="Arial"/>
-                <a:ea typeface="Arial"/>
-                <a:cs typeface="Arial"/>
-              </a:rPr>
-              <a:t>• Identificadores operativos, sin nombres personales</a:t>
-            </a:r>
+              <a:rPr sz="1275" b="0" i="0" dirty="0">
+                <a:solidFill>
+                  <a:srgbClr val="1F3864"/>
+                </a:solidFill>
+                <a:latin typeface="Arial"/>
+                <a:ea typeface="Arial"/>
+                <a:cs typeface="Arial"/>
+              </a:rPr>
+              <a:t>• </a:t>
+            </a:r>
+            <a:r>
+              <a:rPr sz="1275" b="0" i="0" dirty="0" err="1">
+                <a:solidFill>
+                  <a:srgbClr val="1F3864"/>
+                </a:solidFill>
+                <a:latin typeface="Arial"/>
+                <a:ea typeface="Arial"/>
+                <a:cs typeface="Arial"/>
+              </a:rPr>
+              <a:t>Identificadores</a:t>
+            </a:r>
+            <a:r>
+              <a:rPr sz="1275" b="0" i="0" dirty="0">
+                <a:solidFill>
+                  <a:srgbClr val="1F3864"/>
+                </a:solidFill>
+                <a:latin typeface="Arial"/>
+                <a:ea typeface="Arial"/>
+                <a:cs typeface="Arial"/>
+              </a:rPr>
+              <a:t> </a:t>
+            </a:r>
+            <a:r>
+              <a:rPr sz="1275" b="0" i="0" dirty="0" err="1">
+                <a:solidFill>
+                  <a:srgbClr val="1F3864"/>
+                </a:solidFill>
+                <a:latin typeface="Arial"/>
+                <a:ea typeface="Arial"/>
+                <a:cs typeface="Arial"/>
+              </a:rPr>
+              <a:t>operativos</a:t>
+            </a:r>
+            <a:r>
+              <a:rPr sz="1275" b="0" i="0" dirty="0">
+                <a:solidFill>
+                  <a:srgbClr val="1F3864"/>
+                </a:solidFill>
+                <a:latin typeface="Arial"/>
+                <a:ea typeface="Arial"/>
+                <a:cs typeface="Arial"/>
+              </a:rPr>
+              <a:t>, sin </a:t>
+            </a:r>
+            <a:r>
+              <a:rPr sz="1275" b="0" i="0" dirty="0" err="1">
+                <a:solidFill>
+                  <a:srgbClr val="1F3864"/>
+                </a:solidFill>
+                <a:latin typeface="Arial"/>
+                <a:ea typeface="Arial"/>
+                <a:cs typeface="Arial"/>
+              </a:rPr>
+              <a:t>nombres</a:t>
+            </a:r>
+            <a:r>
+              <a:rPr sz="1275" b="0" i="0" dirty="0">
+                <a:solidFill>
+                  <a:srgbClr val="1F3864"/>
+                </a:solidFill>
+                <a:latin typeface="Arial"/>
+                <a:ea typeface="Arial"/>
+                <a:cs typeface="Arial"/>
+              </a:rPr>
+              <a:t> </a:t>
+            </a:r>
+            <a:r>
+              <a:rPr sz="1275" b="0" i="0" dirty="0" err="1">
+                <a:solidFill>
+                  <a:srgbClr val="1F3864"/>
+                </a:solidFill>
+                <a:latin typeface="Arial"/>
+                <a:ea typeface="Arial"/>
+                <a:cs typeface="Arial"/>
+              </a:rPr>
+              <a:t>personales</a:t>
+            </a:r>
+            <a:endParaRPr sz="1275" b="0" i="0" dirty="0">
+              <a:solidFill>
+                <a:srgbClr val="1F3864"/>
+              </a:solidFill>
+              <a:latin typeface="Arial"/>
+              <a:ea typeface="Arial"/>
+              <a:cs typeface="Arial"/>
+            </a:endParaRPr>
           </a:p>
         </p:txBody>
       </p:sp>
@@ -9139,7 +9917,7 @@
               </a:defRPr>
             </a:pPr>
             <a:r>
-              <a:rPr sz="1050" b="1" i="0">
+              <a:rPr sz="1050" b="1" i="0" dirty="0" err="1">
                 <a:solidFill>
                   <a:srgbClr val="2E5B8A"/>
                 </a:solidFill>
@@ -9147,7 +9925,40 @@
                 <a:ea typeface="Arial"/>
                 <a:cs typeface="Arial"/>
               </a:rPr>
-              <a:t>Trazabilidad: Bronze 28.920 → Silver 28.465 + cuarentena 455 → Gold 28.465</a:t>
+              <a:t>Trazabilidad</a:t>
+            </a:r>
+            <a:r>
+              <a:rPr sz="1050" b="1" i="0" dirty="0">
+                <a:solidFill>
+                  <a:srgbClr val="2E5B8A"/>
+                </a:solidFill>
+                <a:latin typeface="Arial"/>
+                <a:ea typeface="Arial"/>
+                <a:cs typeface="Arial"/>
+              </a:rPr>
+              <a:t>: Bronze 28.920 → Silver 28.465 + </a:t>
+            </a:r>
+            <a:r>
+              <a:rPr sz="1050" b="1" i="0" dirty="0" err="1">
+                <a:solidFill>
+                  <a:srgbClr val="2E5B8A"/>
+                </a:solidFill>
+                <a:latin typeface="Arial"/>
+                <a:ea typeface="Arial"/>
+                <a:cs typeface="Arial"/>
+              </a:rPr>
+              <a:t>cuarentena</a:t>
+            </a:r>
+            <a:r>
+              <a:rPr sz="1050" b="1" i="0" dirty="0">
+                <a:solidFill>
+                  <a:srgbClr val="2E5B8A"/>
+                </a:solidFill>
+                <a:latin typeface="Arial"/>
+                <a:ea typeface="Arial"/>
+                <a:cs typeface="Arial"/>
+              </a:rPr>
+              <a:t> 455 → Gold 28.465</a:t>
             </a:r>
           </a:p>
         </p:txBody>
@@ -9275,7 +10086,7 @@
                     <a:lstStyle/>
                     <a:p>
                       <a:r>
-                        <a:rPr sz="1050">
+                        <a:rPr sz="1050" dirty="0" err="1">
                           <a:solidFill>
                             <a:srgbClr val="1F3864"/>
                           </a:solidFill>
@@ -9285,6 +10096,14 @@
                         </a:rPr>
                         <a:t>Faltantes</a:t>
                       </a:r>
+                      <a:endParaRPr sz="1050" dirty="0">
+                        <a:solidFill>
+                          <a:srgbClr val="1F3864"/>
+                        </a:solidFill>
+                        <a:latin typeface="Arial"/>
+                        <a:ea typeface="Arial"/>
+                        <a:cs typeface="Arial"/>
+                      </a:endParaRPr>
                     </a:p>
                   </a:txBody>
                   <a:tcPr marL="95250" marR="95250" marT="66675" marB="66675" anchor="ctr">
@@ -9457,7 +10276,7 @@
                     <a:lstStyle/>
                     <a:p>
                       <a:r>
-                        <a:rPr sz="1050">
+                        <a:rPr sz="1050" dirty="0">
                           <a:solidFill>
                             <a:srgbClr val="1F3864"/>
                           </a:solidFill>
@@ -9465,8 +10284,71 @@
                           <a:ea typeface="Arial"/>
                           <a:cs typeface="Arial"/>
                         </a:rPr>
-                        <a:t>120 valores -999; 15 fechas; 15 humedades</a:t>
+                        <a:t>120 </a:t>
                       </a:r>
+                      <a:r>
+                        <a:rPr sz="1050" dirty="0" err="1">
+                          <a:solidFill>
+                            <a:srgbClr val="1F3864"/>
+                          </a:solidFill>
+                          <a:latin typeface="Arial"/>
+                          <a:ea typeface="Arial"/>
+                          <a:cs typeface="Arial"/>
+                        </a:rPr>
+                        <a:t>valores</a:t>
+                      </a:r>
+                      <a:r>
+                        <a:rPr sz="1050" dirty="0">
+                          <a:solidFill>
+                            <a:srgbClr val="1F3864"/>
+                          </a:solidFill>
+                          <a:latin typeface="Arial"/>
+                          <a:ea typeface="Arial"/>
+                          <a:cs typeface="Arial"/>
+                        </a:rPr>
+                        <a:t> -999; 15 </a:t>
+                      </a:r>
+                      <a:r>
+                        <a:rPr sz="1050" dirty="0" err="1">
+                          <a:solidFill>
+                            <a:srgbClr val="1F3864"/>
+                          </a:solidFill>
+                          <a:latin typeface="Arial"/>
+                          <a:ea typeface="Arial"/>
+                          <a:cs typeface="Arial"/>
+                        </a:rPr>
+                        <a:t>fechas</a:t>
+                      </a:r>
+                      <a:r>
+                        <a:rPr sz="1050" dirty="0">
+                          <a:solidFill>
+                            <a:srgbClr val="1F3864"/>
+                          </a:solidFill>
+                          <a:latin typeface="Arial"/>
+                          <a:ea typeface="Arial"/>
+                          <a:cs typeface="Arial"/>
+                        </a:rPr>
+                        <a:t>; 15 </a:t>
+                      </a:r>
+                      <a:r>
+                        <a:rPr sz="1050" dirty="0" err="1">
+                          <a:solidFill>
+                            <a:srgbClr val="1F3864"/>
+                          </a:solidFill>
+                          <a:latin typeface="Arial"/>
+                          <a:ea typeface="Arial"/>
+                          <a:cs typeface="Arial"/>
+                        </a:rPr>
+                        <a:t>humedades</a:t>
+                      </a:r>
+                      <a:endParaRPr sz="1050" dirty="0">
+                        <a:solidFill>
+                          <a:srgbClr val="1F3864"/>
+                        </a:solidFill>
+                        <a:latin typeface="Arial"/>
+                        <a:ea typeface="Arial"/>
+                        <a:cs typeface="Arial"/>
+                      </a:endParaRPr>
                     </a:p>
                   </a:txBody>
                   <a:tcPr marL="95250" marR="95250" marT="66675" marB="66675" anchor="ctr">
@@ -9481,7 +10363,7 @@
                     <a:lstStyle/>
                     <a:p>
                       <a:r>
-                        <a:rPr sz="1050">
+                        <a:rPr sz="1050" dirty="0" err="1">
                           <a:solidFill>
                             <a:srgbClr val="1F3864"/>
                           </a:solidFill>
@@ -9489,7 +10371,84 @@
                           <a:ea typeface="Arial"/>
                           <a:cs typeface="Arial"/>
                         </a:rPr>
-                        <a:t>Convertir unidades seguras; cuarentena del resto</a:t>
+                        <a:t>Convertir</a:t>
+                      </a:r>
+                      <a:r>
+                        <a:rPr sz="1050" dirty="0">
+                          <a:solidFill>
+                            <a:srgbClr val="1F3864"/>
+                          </a:solidFill>
+                          <a:latin typeface="Arial"/>
+                          <a:ea typeface="Arial"/>
+                          <a:cs typeface="Arial"/>
+                        </a:rPr>
+                        <a:t> </a:t>
+                      </a:r>
+                      <a:r>
+                        <a:rPr sz="1050" dirty="0" err="1">
+                          <a:solidFill>
+                            <a:srgbClr val="1F3864"/>
+                          </a:solidFill>
+                          <a:latin typeface="Arial"/>
+                          <a:ea typeface="Arial"/>
+                          <a:cs typeface="Arial"/>
+                        </a:rPr>
+                        <a:t>unidades</a:t>
+                      </a:r>
+                      <a:r>
+                        <a:rPr sz="1050" dirty="0">
+                          <a:solidFill>
+                            <a:srgbClr val="1F3864"/>
+                          </a:solidFill>
+                          <a:latin typeface="Arial"/>
+                          <a:ea typeface="Arial"/>
+                          <a:cs typeface="Arial"/>
+                        </a:rPr>
+                        <a:t> </a:t>
+                      </a:r>
+                      <a:r>
+                        <a:rPr sz="1050" dirty="0" err="1">
+                          <a:solidFill>
+                            <a:srgbClr val="1F3864"/>
+                          </a:solidFill>
+                          <a:latin typeface="Arial"/>
+                          <a:ea typeface="Arial"/>
+                          <a:cs typeface="Arial"/>
+                        </a:rPr>
+                        <a:t>seguras</a:t>
+                      </a:r>
+                      <a:r>
+                        <a:rPr sz="1050" dirty="0">
+                          <a:solidFill>
+                            <a:srgbClr val="1F3864"/>
+                          </a:solidFill>
+                          <a:latin typeface="Arial"/>
+                          <a:ea typeface="Arial"/>
+                          <a:cs typeface="Arial"/>
+                        </a:rPr>
+                        <a:t>; </a:t>
+                      </a:r>
+                      <a:r>
+                        <a:rPr sz="1050" dirty="0" err="1">
+                          <a:solidFill>
+                            <a:srgbClr val="1F3864"/>
+                          </a:solidFill>
+                          <a:latin typeface="Arial"/>
+                          <a:ea typeface="Arial"/>
+                          <a:cs typeface="Arial"/>
+                        </a:rPr>
+                        <a:t>cuarentena</a:t>
+                      </a:r>
+                      <a:r>
+                        <a:rPr sz="1050" dirty="0">
+                          <a:solidFill>
+                            <a:srgbClr val="1F3864"/>
+                          </a:solidFill>
+                          <a:latin typeface="Arial"/>
+                          <a:ea typeface="Arial"/>
+                          <a:cs typeface="Arial"/>
+                        </a:rPr>
+                        <a:t> del resto</a:t>
                       </a:r>
                     </a:p>
                   </a:txBody>
@@ -9560,7 +10519,7 @@
                     <a:lstStyle/>
                     <a:p>
                       <a:r>
-                        <a:rPr sz="1050">
+                        <a:rPr sz="1050" dirty="0" err="1">
                           <a:solidFill>
                             <a:srgbClr val="1F3864"/>
                           </a:solidFill>
@@ -9568,8 +10527,104 @@
                           <a:ea typeface="Arial"/>
                           <a:cs typeface="Arial"/>
                         </a:rPr>
-                        <a:t>Conservar en Gold; excluir del objetivo y modelo</a:t>
+                        <a:t>Conservar</a:t>
                       </a:r>
+                      <a:r>
+                        <a:rPr sz="1050" dirty="0">
+                          <a:solidFill>
+                            <a:srgbClr val="1F3864"/>
+                          </a:solidFill>
+                          <a:latin typeface="Arial"/>
+                          <a:ea typeface="Arial"/>
+                          <a:cs typeface="Arial"/>
+                        </a:rPr>
+                        <a:t> </a:t>
+                      </a:r>
+                      <a:r>
+                        <a:rPr sz="1050" dirty="0" err="1">
+                          <a:solidFill>
+                            <a:srgbClr val="1F3864"/>
+                          </a:solidFill>
+                          <a:latin typeface="Arial"/>
+                          <a:ea typeface="Arial"/>
+                          <a:cs typeface="Arial"/>
+                        </a:rPr>
+                        <a:t>en</a:t>
+                      </a:r>
+                      <a:r>
+                        <a:rPr sz="1050" dirty="0">
+                          <a:solidFill>
+                            <a:srgbClr val="1F3864"/>
+                          </a:solidFill>
+                          <a:latin typeface="Arial"/>
+                          <a:ea typeface="Arial"/>
+                          <a:cs typeface="Arial"/>
+                        </a:rPr>
+                        <a:t> Gold; </a:t>
+                      </a:r>
+                      <a:r>
+                        <a:rPr sz="1050" dirty="0" err="1">
+                          <a:solidFill>
+                            <a:srgbClr val="1F3864"/>
+                          </a:solidFill>
+                          <a:latin typeface="Arial"/>
+                          <a:ea typeface="Arial"/>
+                          <a:cs typeface="Arial"/>
+                        </a:rPr>
+                        <a:t>excluir</a:t>
+                      </a:r>
+                      <a:r>
+                        <a:rPr sz="1050" dirty="0">
+                          <a:solidFill>
+                            <a:srgbClr val="1F3864"/>
+                          </a:solidFill>
+                          <a:latin typeface="Arial"/>
+                          <a:ea typeface="Arial"/>
+                          <a:cs typeface="Arial"/>
+                        </a:rPr>
+                        <a:t> del </a:t>
+                      </a:r>
+                      <a:r>
+                        <a:rPr sz="1050" dirty="0" err="1">
+                          <a:solidFill>
+                            <a:srgbClr val="1F3864"/>
+                          </a:solidFill>
+                          <a:latin typeface="Arial"/>
+                          <a:ea typeface="Arial"/>
+                          <a:cs typeface="Arial"/>
+                        </a:rPr>
+                        <a:t>objetivo</a:t>
+                      </a:r>
+                      <a:r>
+                        <a:rPr sz="1050" dirty="0">
+                          <a:solidFill>
+                            <a:srgbClr val="1F3864"/>
+                          </a:solidFill>
+                          <a:latin typeface="Arial"/>
+                          <a:ea typeface="Arial"/>
+                          <a:cs typeface="Arial"/>
+                        </a:rPr>
+                        <a:t> y </a:t>
+                      </a:r>
+                      <a:r>
+                        <a:rPr sz="1050" dirty="0" err="1">
+                          <a:solidFill>
+                            <a:srgbClr val="1F3864"/>
+                          </a:solidFill>
+                          <a:latin typeface="Arial"/>
+                          <a:ea typeface="Arial"/>
+                          <a:cs typeface="Arial"/>
+                        </a:rPr>
+                        <a:t>modelo</a:t>
+                      </a:r>
+                      <a:endParaRPr sz="1050" dirty="0">
+                        <a:solidFill>
+                          <a:srgbClr val="1F3864"/>
+                        </a:solidFill>
+                        <a:latin typeface="Arial"/>
+                        <a:ea typeface="Arial"/>
+                        <a:cs typeface="Arial"/>
+                      </a:endParaRPr>
                     </a:p>
                   </a:txBody>
                   <a:tcPr marL="95250" marR="95250" marT="66675" marB="66675" anchor="ctr">
@@ -10281,16 +11336,35 @@
               </a:defRPr>
             </a:pPr>
             <a:r>
-              <a:rPr sz="1200" b="1" i="0">
-                <a:solidFill>
-                  <a:srgbClr val="1F3864"/>
-                </a:solidFill>
-                <a:latin typeface="Arial"/>
-                <a:ea typeface="Arial"/>
-                <a:cs typeface="Arial"/>
-              </a:rPr>
-              <a:t>Dato recibido</a:t>
-            </a:r>
+              <a:rPr sz="1200" b="1" i="0" dirty="0">
+                <a:solidFill>
+                  <a:srgbClr val="1F3864"/>
+                </a:solidFill>
+                <a:latin typeface="Arial"/>
+                <a:ea typeface="Arial"/>
+                <a:cs typeface="Arial"/>
+              </a:rPr>
+              <a:t>Dato </a:t>
+            </a:r>
+            <a:r>
+              <a:rPr sz="1200" b="1" i="0" dirty="0" err="1">
+                <a:solidFill>
+                  <a:srgbClr val="1F3864"/>
+                </a:solidFill>
+                <a:latin typeface="Arial"/>
+                <a:ea typeface="Arial"/>
+                <a:cs typeface="Arial"/>
+              </a:rPr>
+              <a:t>recibido</a:t>
+            </a:r>
+            <a:endParaRPr sz="1200" b="1" i="0" dirty="0">
+              <a:solidFill>
+                <a:srgbClr val="1F3864"/>
+              </a:solidFill>
+              <a:latin typeface="Arial"/>
+              <a:ea typeface="Arial"/>
+              <a:cs typeface="Arial"/>
+            </a:endParaRPr>
           </a:p>
         </p:txBody>
       </p:sp>
@@ -10419,7 +11493,7 @@
               </a:defRPr>
             </a:pPr>
             <a:r>
-              <a:rPr sz="900" b="1" i="0">
+              <a:rPr sz="900" b="1" i="0" dirty="0">
                 <a:solidFill>
                   <a:srgbClr val="2E5B8A"/>
                 </a:solidFill>
@@ -10615,7 +11689,7 @@
               </a:defRPr>
             </a:pPr>
             <a:r>
-              <a:rPr sz="900" b="1" i="0">
+              <a:rPr sz="900" b="1" i="0" dirty="0">
                 <a:solidFill>
                   <a:srgbClr val="2E5B8A"/>
                 </a:solidFill>
@@ -10673,16 +11747,57 @@
               </a:defRPr>
             </a:pPr>
             <a:r>
-              <a:rPr sz="1200" b="1" i="0">
-                <a:solidFill>
-                  <a:srgbClr val="1F3864"/>
-                </a:solidFill>
-                <a:latin typeface="Arial"/>
-                <a:ea typeface="Arial"/>
-                <a:cs typeface="Arial"/>
-              </a:rPr>
-              <a:t>Variables y objetivo futuro</a:t>
-            </a:r>
+              <a:rPr sz="1200" b="1" i="0" dirty="0">
+                <a:solidFill>
+                  <a:srgbClr val="1F3864"/>
+                </a:solidFill>
+                <a:latin typeface="Arial"/>
+                <a:ea typeface="Arial"/>
+                <a:cs typeface="Arial"/>
+              </a:rPr>
+              <a:t>Variables y </a:t>
+            </a:r>
+            <a:r>
+              <a:rPr sz="1200" b="1" i="0" dirty="0" err="1">
+                <a:solidFill>
+                  <a:srgbClr val="1F3864"/>
+                </a:solidFill>
+                <a:latin typeface="Arial"/>
+                <a:ea typeface="Arial"/>
+                <a:cs typeface="Arial"/>
+              </a:rPr>
+              <a:t>objetivo</a:t>
+            </a:r>
+            <a:r>
+              <a:rPr sz="1200" b="1" i="0" dirty="0">
+                <a:solidFill>
+                  <a:srgbClr val="1F3864"/>
+                </a:solidFill>
+                <a:latin typeface="Arial"/>
+                <a:ea typeface="Arial"/>
+                <a:cs typeface="Arial"/>
+              </a:rPr>
+              <a:t> </a:t>
+            </a:r>
+            <a:r>
+              <a:rPr sz="1200" b="1" i="0" dirty="0" err="1">
+                <a:solidFill>
+                  <a:srgbClr val="1F3864"/>
+                </a:solidFill>
+                <a:latin typeface="Arial"/>
+                <a:ea typeface="Arial"/>
+                <a:cs typeface="Arial"/>
+              </a:rPr>
+              <a:t>futuro</a:t>
+            </a:r>
+            <a:endParaRPr sz="1200" b="1" i="0" dirty="0">
+              <a:solidFill>
+                <a:srgbClr val="1F3864"/>
+              </a:solidFill>
+              <a:latin typeface="Arial"/>
+              <a:ea typeface="Arial"/>
+              <a:cs typeface="Arial"/>
+            </a:endParaRPr>
           </a:p>
         </p:txBody>
       </p:sp>
@@ -10825,16 +11940,68 @@
               </a:defRPr>
             </a:pPr>
             <a:r>
-              <a:rPr sz="1275" b="1" i="0">
-                <a:solidFill>
-                  <a:srgbClr val="1F3864"/>
-                </a:solidFill>
-                <a:latin typeface="Arial"/>
-                <a:ea typeface="Arial"/>
-                <a:cs typeface="Arial"/>
-              </a:rPr>
-              <a:t>Gráfico 1 · Frecuencia del objetivo</a:t>
-            </a:r>
+              <a:rPr sz="1275" b="1" i="0" dirty="0" err="1">
+                <a:solidFill>
+                  <a:srgbClr val="1F3864"/>
+                </a:solidFill>
+                <a:latin typeface="Arial"/>
+                <a:ea typeface="Arial"/>
+                <a:cs typeface="Arial"/>
+              </a:rPr>
+              <a:t>Gráfico</a:t>
+            </a:r>
+            <a:r>
+              <a:rPr sz="1275" b="1" i="0" dirty="0">
+                <a:solidFill>
+                  <a:srgbClr val="1F3864"/>
+                </a:solidFill>
+                <a:latin typeface="Arial"/>
+                <a:ea typeface="Arial"/>
+                <a:cs typeface="Arial"/>
+              </a:rPr>
+              <a:t> 1 · </a:t>
+            </a:r>
+            <a:r>
+              <a:rPr sz="1275" b="1" i="0" dirty="0" err="1">
+                <a:solidFill>
+                  <a:srgbClr val="1F3864"/>
+                </a:solidFill>
+                <a:latin typeface="Arial"/>
+                <a:ea typeface="Arial"/>
+                <a:cs typeface="Arial"/>
+              </a:rPr>
+              <a:t>Frecuencia</a:t>
+            </a:r>
+            <a:r>
+              <a:rPr sz="1275" b="1" i="0" dirty="0">
+                <a:solidFill>
+                  <a:srgbClr val="1F3864"/>
+                </a:solidFill>
+                <a:latin typeface="Arial"/>
+                <a:ea typeface="Arial"/>
+                <a:cs typeface="Arial"/>
+              </a:rPr>
+              <a:t> del </a:t>
+            </a:r>
+            <a:r>
+              <a:rPr sz="1275" b="1" i="0" dirty="0" err="1">
+                <a:solidFill>
+                  <a:srgbClr val="1F3864"/>
+                </a:solidFill>
+                <a:latin typeface="Arial"/>
+                <a:ea typeface="Arial"/>
+                <a:cs typeface="Arial"/>
+              </a:rPr>
+              <a:t>objetivo</a:t>
+            </a:r>
+            <a:endParaRPr sz="1275" b="1" i="0" dirty="0">
+              <a:solidFill>
+                <a:srgbClr val="1F3864"/>
+              </a:solidFill>
+              <a:latin typeface="Arial"/>
+              <a:ea typeface="Arial"/>
+              <a:cs typeface="Arial"/>
+            </a:endParaRPr>
           </a:p>
         </p:txBody>
       </p:sp>
@@ -11179,16 +12346,90 @@
               </a:defRPr>
             </a:pPr>
             <a:r>
-              <a:rPr sz="1125" b="0" i="0">
-                <a:solidFill>
-                  <a:srgbClr val="1F3864"/>
-                </a:solidFill>
-                <a:latin typeface="Arial"/>
-                <a:ea typeface="Arial"/>
-                <a:cs typeface="Arial"/>
-              </a:rPr>
-              <a:t>Eventos futuros: 5,02% de las ventanas evaluables</a:t>
-            </a:r>
+              <a:rPr sz="1125" b="0" i="0" dirty="0" err="1">
+                <a:solidFill>
+                  <a:srgbClr val="1F3864"/>
+                </a:solidFill>
+                <a:latin typeface="Arial"/>
+                <a:ea typeface="Arial"/>
+                <a:cs typeface="Arial"/>
+              </a:rPr>
+              <a:t>Eventos</a:t>
+            </a:r>
+            <a:r>
+              <a:rPr sz="1125" b="0" i="0" dirty="0">
+                <a:solidFill>
+                  <a:srgbClr val="1F3864"/>
+                </a:solidFill>
+                <a:latin typeface="Arial"/>
+                <a:ea typeface="Arial"/>
+                <a:cs typeface="Arial"/>
+              </a:rPr>
+              <a:t> </a:t>
+            </a:r>
+            <a:r>
+              <a:rPr sz="1125" b="0" i="0" dirty="0" err="1">
+                <a:solidFill>
+                  <a:srgbClr val="1F3864"/>
+                </a:solidFill>
+                <a:latin typeface="Arial"/>
+                <a:ea typeface="Arial"/>
+                <a:cs typeface="Arial"/>
+              </a:rPr>
+              <a:t>futuros</a:t>
+            </a:r>
+            <a:r>
+              <a:rPr sz="1125" b="0" i="0" dirty="0">
+                <a:solidFill>
+                  <a:srgbClr val="1F3864"/>
+                </a:solidFill>
+                <a:latin typeface="Arial"/>
+                <a:ea typeface="Arial"/>
+                <a:cs typeface="Arial"/>
+              </a:rPr>
+              <a:t>: 5,02% de las </a:t>
+            </a:r>
+            <a:r>
+              <a:rPr sz="1125" b="0" i="0" dirty="0" err="1">
+                <a:solidFill>
+                  <a:srgbClr val="1F3864"/>
+                </a:solidFill>
+                <a:latin typeface="Arial"/>
+                <a:ea typeface="Arial"/>
+                <a:cs typeface="Arial"/>
+              </a:rPr>
+              <a:t>ventanas</a:t>
+            </a:r>
+            <a:r>
+              <a:rPr sz="1125" b="0" i="0" dirty="0">
+                <a:solidFill>
+                  <a:srgbClr val="1F3864"/>
+                </a:solidFill>
+                <a:latin typeface="Arial"/>
+                <a:ea typeface="Arial"/>
+                <a:cs typeface="Arial"/>
+              </a:rPr>
+              <a:t> </a:t>
+            </a:r>
+            <a:r>
+              <a:rPr sz="1125" b="0" i="0" dirty="0" err="1">
+                <a:solidFill>
+                  <a:srgbClr val="1F3864"/>
+                </a:solidFill>
+                <a:latin typeface="Arial"/>
+                <a:ea typeface="Arial"/>
+                <a:cs typeface="Arial"/>
+              </a:rPr>
+              <a:t>evaluables</a:t>
+            </a:r>
+            <a:endParaRPr sz="1125" b="0" i="0" dirty="0">
+              <a:solidFill>
+                <a:srgbClr val="1F3864"/>
+              </a:solidFill>
+              <a:latin typeface="Arial"/>
+              <a:ea typeface="Arial"/>
+              <a:cs typeface="Arial"/>
+            </a:endParaRPr>
           </a:p>
         </p:txBody>
       </p:sp>
@@ -11375,15 +12616,103 @@
               </a:defRPr>
             </a:pPr>
             <a:r>
-              <a:rPr sz="1125" b="0" i="0">
-                <a:solidFill>
-                  <a:srgbClr val="1F3864"/>
-                </a:solidFill>
-                <a:latin typeface="Arial"/>
-                <a:ea typeface="Arial"/>
-                <a:cs typeface="Arial"/>
-              </a:rPr>
-              <a:t>Con desviación actual, el riesgo futuro sube a 59,41%</a:t>
+              <a:rPr sz="1125" b="0" i="0" dirty="0">
+                <a:solidFill>
+                  <a:srgbClr val="1F3864"/>
+                </a:solidFill>
+                <a:latin typeface="Arial"/>
+                <a:ea typeface="Arial"/>
+                <a:cs typeface="Arial"/>
+              </a:rPr>
+              <a:t>Con </a:t>
+            </a:r>
+            <a:r>
+              <a:rPr sz="1125" b="0" i="0" dirty="0" err="1">
+                <a:solidFill>
+                  <a:srgbClr val="1F3864"/>
+                </a:solidFill>
+                <a:latin typeface="Arial"/>
+                <a:ea typeface="Arial"/>
+                <a:cs typeface="Arial"/>
+              </a:rPr>
+              <a:t>desviación</a:t>
+            </a:r>
+            <a:r>
+              <a:rPr sz="1125" b="0" i="0" dirty="0">
+                <a:solidFill>
+                  <a:srgbClr val="1F3864"/>
+                </a:solidFill>
+                <a:latin typeface="Arial"/>
+                <a:ea typeface="Arial"/>
+                <a:cs typeface="Arial"/>
+              </a:rPr>
+              <a:t> actual, el </a:t>
+            </a:r>
+            <a:r>
+              <a:rPr sz="1125" b="0" i="0" dirty="0" err="1">
+                <a:solidFill>
+                  <a:srgbClr val="1F3864"/>
+                </a:solidFill>
+                <a:latin typeface="Arial"/>
+                <a:ea typeface="Arial"/>
+                <a:cs typeface="Arial"/>
+              </a:rPr>
+              <a:t>riesgo</a:t>
+            </a:r>
+            <a:r>
+              <a:rPr sz="1125" b="0" i="0" dirty="0">
+                <a:solidFill>
+                  <a:srgbClr val="1F3864"/>
+                </a:solidFill>
+                <a:latin typeface="Arial"/>
+                <a:ea typeface="Arial"/>
+                <a:cs typeface="Arial"/>
+              </a:rPr>
+              <a:t> </a:t>
+            </a:r>
+            <a:r>
+              <a:rPr sz="1125" b="0" i="0" dirty="0" err="1">
+                <a:solidFill>
+                  <a:srgbClr val="1F3864"/>
+                </a:solidFill>
+                <a:latin typeface="Arial"/>
+                <a:ea typeface="Arial"/>
+                <a:cs typeface="Arial"/>
+              </a:rPr>
+              <a:t>futuro</a:t>
+            </a:r>
+            <a:r>
+              <a:rPr sz="1125" b="0" i="0" dirty="0">
+                <a:solidFill>
+                  <a:srgbClr val="1F3864"/>
+                </a:solidFill>
+                <a:latin typeface="Arial"/>
+                <a:ea typeface="Arial"/>
+                <a:cs typeface="Arial"/>
+              </a:rPr>
+              <a:t> </a:t>
+            </a:r>
+            <a:r>
+              <a:rPr sz="1125" b="0" i="0" dirty="0" err="1">
+                <a:solidFill>
+                  <a:srgbClr val="1F3864"/>
+                </a:solidFill>
+                <a:latin typeface="Arial"/>
+                <a:ea typeface="Arial"/>
+                <a:cs typeface="Arial"/>
+              </a:rPr>
+              <a:t>sube</a:t>
+            </a:r>
+            <a:r>
+              <a:rPr sz="1125" b="0" i="0" dirty="0">
+                <a:solidFill>
+                  <a:srgbClr val="1F3864"/>
+                </a:solidFill>
+                <a:latin typeface="Arial"/>
+                <a:ea typeface="Arial"/>
+                <a:cs typeface="Arial"/>
+              </a:rPr>
+              <a:t> a 59,41%</a:t>
             </a:r>
           </a:p>
         </p:txBody>
@@ -19884,7 +21213,13 @@
         <p:nvGraphicFramePr>
           <p:cNvPr id="25" name="Table 22"/>
           <p:cNvGraphicFramePr/>
-          <p:nvPr/>
+          <p:nvPr>
+            <p:extLst>
+              <p:ext uri="{D42A27DB-BD31-4B8C-83A1-F6EECF244321}">
+                <p14:modId xmlns:p14="http://schemas.microsoft.com/office/powerpoint/2010/main" val="2666022863"/>
+              </p:ext>
+            </p:extLst>
+          </p:nvPr>
         </p:nvGraphicFramePr>
         <p:xfrm>
           <a:off x="533400" y="2381250"/>
@@ -19955,7 +21290,7 @@
                     <a:lstStyle/>
                     <a:p>
                       <a:r>
-                        <a:rPr sz="1125" b="1">
+                        <a:rPr sz="1125" b="1" dirty="0" err="1">
                           <a:solidFill>
                             <a:srgbClr val="FFFFFF"/>
                           </a:solidFill>
@@ -19963,8 +21298,38 @@
                           <a:ea typeface="Arial"/>
                           <a:cs typeface="Arial"/>
                         </a:rPr>
-                        <a:t>Acción recomendada</a:t>
+                        <a:t>Acción</a:t>
                       </a:r>
+                      <a:r>
+                        <a:rPr sz="1125" b="1" dirty="0">
+                          <a:solidFill>
+                            <a:srgbClr val="FFFFFF"/>
+                          </a:solidFill>
+                          <a:latin typeface="Arial"/>
+                          <a:ea typeface="Arial"/>
+                          <a:cs typeface="Arial"/>
+                        </a:rPr>
+                        <a:t> </a:t>
+                      </a:r>
+                      <a:r>
+                        <a:rPr sz="1125" b="1" dirty="0" err="1">
+                          <a:solidFill>
+                            <a:srgbClr val="FFFFFF"/>
+                          </a:solidFill>
+                          <a:latin typeface="Arial"/>
+                          <a:ea typeface="Arial"/>
+                          <a:cs typeface="Arial"/>
+                        </a:rPr>
+                        <a:t>recomendada</a:t>
+                      </a:r>
+                      <a:endParaRPr sz="1125" b="1" dirty="0">
+                        <a:solidFill>
+                          <a:srgbClr val="FFFFFF"/>
+                        </a:solidFill>
+                        <a:latin typeface="Arial"/>
+                        <a:ea typeface="Arial"/>
+                        <a:cs typeface="Arial"/>
+                      </a:endParaRPr>
                     </a:p>
                   </a:txBody>
                   <a:tcPr marL="95250" marR="95250" marT="66675" marB="66675" anchor="ctr">
@@ -20264,7 +21629,7 @@
                     <a:lstStyle/>
                     <a:p>
                       <a:r>
-                        <a:rPr sz="1125">
+                        <a:rPr sz="1125" dirty="0" err="1">
                           <a:solidFill>
                             <a:srgbClr val="1F3864"/>
                           </a:solidFill>
@@ -20272,7 +21637,40 @@
                           <a:ea typeface="Arial"/>
                           <a:cs typeface="Arial"/>
                         </a:rPr>
-                        <a:t>Monitorear recall, precisión y PR AUC</a:t>
+                        <a:t>Monitorear</a:t>
+                      </a:r>
+                      <a:r>
+                        <a:rPr sz="1125" dirty="0">
+                          <a:solidFill>
+                            <a:srgbClr val="1F3864"/>
+                          </a:solidFill>
+                          <a:latin typeface="Arial"/>
+                          <a:ea typeface="Arial"/>
+                          <a:cs typeface="Arial"/>
+                        </a:rPr>
+                        <a:t> recall, </a:t>
+                      </a:r>
+                      <a:r>
+                        <a:rPr sz="1125" dirty="0" err="1">
+                          <a:solidFill>
+                            <a:srgbClr val="1F3864"/>
+                          </a:solidFill>
+                          <a:latin typeface="Arial"/>
+                          <a:ea typeface="Arial"/>
+                          <a:cs typeface="Arial"/>
+                        </a:rPr>
+                        <a:t>precisión</a:t>
+                      </a:r>
+                      <a:r>
+                        <a:rPr sz="1125" dirty="0">
+                          <a:solidFill>
+                            <a:srgbClr val="1F3864"/>
+                          </a:solidFill>
+                          <a:latin typeface="Arial"/>
+                          <a:ea typeface="Arial"/>
+                          <a:cs typeface="Arial"/>
+                        </a:rPr>
+                        <a:t> y PR AUC</a:t>
                       </a:r>
                     </a:p>
                   </a:txBody>
@@ -20312,7 +21710,7 @@
                     <a:lstStyle/>
                     <a:p>
                       <a:r>
-                        <a:rPr sz="1125">
+                        <a:rPr sz="1125" dirty="0">
                           <a:solidFill>
                             <a:srgbClr val="1F3864"/>
                           </a:solidFill>
@@ -20320,8 +21718,71 @@
                           <a:ea typeface="Arial"/>
                           <a:cs typeface="Arial"/>
                         </a:rPr>
-                        <a:t>Equipo analítico por periodo</a:t>
+                        <a:t>Equipo </a:t>
                       </a:r>
+                      <a:r>
+                        <a:rPr sz="1125" dirty="0" err="1">
+                          <a:solidFill>
+                            <a:srgbClr val="1F3864"/>
+                          </a:solidFill>
+                          <a:latin typeface="Arial"/>
+                          <a:ea typeface="Arial"/>
+                          <a:cs typeface="Arial"/>
+                        </a:rPr>
+                        <a:t>analítico</a:t>
+                      </a:r>
+                      <a:r>
+                        <a:rPr sz="1125" dirty="0">
+                          <a:solidFill>
+                            <a:srgbClr val="1F3864"/>
+                          </a:solidFill>
+                          <a:latin typeface="Arial"/>
+                          <a:ea typeface="Arial"/>
+                          <a:cs typeface="Arial"/>
+                        </a:rPr>
+                        <a:t> </a:t>
+                      </a:r>
+                      <a:r>
+                        <a:rPr sz="1125" dirty="0" err="1">
+                          <a:solidFill>
+                            <a:srgbClr val="1F3864"/>
+                          </a:solidFill>
+                          <a:latin typeface="Arial"/>
+                          <a:ea typeface="Arial"/>
+                          <a:cs typeface="Arial"/>
+                        </a:rPr>
+                        <a:t>por</a:t>
+                      </a:r>
+                      <a:r>
+                        <a:rPr sz="1125" dirty="0">
+                          <a:solidFill>
+                            <a:srgbClr val="1F3864"/>
+                          </a:solidFill>
+                          <a:latin typeface="Arial"/>
+                          <a:ea typeface="Arial"/>
+                          <a:cs typeface="Arial"/>
+                        </a:rPr>
+                        <a:t> </a:t>
+                      </a:r>
+                      <a:r>
+                        <a:rPr sz="1125" dirty="0" err="1">
+                          <a:solidFill>
+                            <a:srgbClr val="1F3864"/>
+                          </a:solidFill>
+                          <a:latin typeface="Arial"/>
+                          <a:ea typeface="Arial"/>
+                          <a:cs typeface="Arial"/>
+                        </a:rPr>
+                        <a:t>periodo</a:t>
+                      </a:r>
+                      <a:endParaRPr sz="1125" dirty="0">
+                        <a:solidFill>
+                          <a:srgbClr val="1F3864"/>
+                        </a:solidFill>
+                        <a:latin typeface="Arial"/>
+                        <a:ea typeface="Arial"/>
+                        <a:cs typeface="Arial"/>
+                      </a:endParaRPr>
                     </a:p>
                   </a:txBody>
                   <a:tcPr marL="95250" marR="95250" marT="66675" marB="66675" anchor="ctr">

</xml_diff>

<commit_message>
add: se agrego el zip de la entrega final
</commit_message>
<xml_diff>
--- a/proyecto-integradorV3/06-Documentacion/Presentacion_Final_AndinaLog_03B.pptx
+++ b/proyecto-integradorV3/06-Documentacion/Presentacion_Final_AndinaLog_03B.pptx
@@ -223,7 +223,7 @@
               </c14:invertSolidFillFmt>
             </c:ext>
             <c:ext xmlns:c16="http://schemas.microsoft.com/office/drawing/2014/chart" uri="{C3380CC4-5D6E-409C-BE32-E72D297353CC}">
-              <c16:uniqueId val="{00000000-CF76-481E-812C-BF4C5AA1407F}"/>
+              <c16:uniqueId val="{00000000-2A34-4EF4-A0ED-DD2AEEE70510}"/>
             </c:ext>
           </c:extLst>
         </c:ser>
@@ -417,24 +417,30 @@
           </c:dLbls>
           <c:cat>
             <c:strLit>
-              <c:ptCount val="2"/>
+              <c:ptCount val="3"/>
               <c:pt idx="0">
-                <c:v>Sin desviación actual</c:v>
+                <c:v>Menor a 0 °C</c:v>
               </c:pt>
               <c:pt idx="1">
-                <c:v>Con desviación actual</c:v>
+                <c:v>0 a 10 °C</c:v>
+              </c:pt>
+              <c:pt idx="2">
+                <c:v>10 °C o más</c:v>
               </c:pt>
             </c:strLit>
           </c:cat>
           <c:val>
             <c:numLit>
               <c:formatCode>0.00%</c:formatCode>
-              <c:ptCount val="2"/>
+              <c:ptCount val="3"/>
               <c:pt idx="0">
-                <c:v>3.0300000000000001E-2</c:v>
+                <c:v>7.4399999999999994E-2</c:v>
               </c:pt>
               <c:pt idx="1">
-                <c:v>0.59409999999999996</c:v>
+                <c:v>7.85E-2</c:v>
+              </c:pt>
+              <c:pt idx="2">
+                <c:v>2.3900000000000001E-2</c:v>
               </c:pt>
             </c:numLit>
           </c:val>
@@ -449,7 +455,7 @@
               </c14:invertSolidFillFmt>
             </c:ext>
             <c:ext xmlns:c16="http://schemas.microsoft.com/office/drawing/2014/chart" uri="{C3380CC4-5D6E-409C-BE32-E72D297353CC}">
-              <c16:uniqueId val="{00000000-9E80-4D29-A3B3-36915C40E1EC}"/>
+              <c16:uniqueId val="{00000000-4CF5-4BAE-AFAE-6C6AC844814A}"/>
             </c:ext>
           </c:extLst>
         </c:ser>
@@ -792,7 +798,164 @@
           <a:lstStyle/>
           <a:p>
             <a:r>
-              <a:t>Presente el problema en términos operativos. AndinaLog necesita anticipar una desviación térmica durante la siguiente hora. El modelo apoya la priorización de revisiones humanas y no toma decisiones automáticas.</a:t>
+              <a:rPr dirty="0" err="1"/>
+              <a:t>Presente</a:t>
+            </a:r>
+            <a:r>
+              <a:rPr dirty="0"/>
+              <a:t> el </a:t>
+            </a:r>
+            <a:r>
+              <a:rPr dirty="0" err="1"/>
+              <a:t>problema</a:t>
+            </a:r>
+            <a:r>
+              <a:rPr dirty="0"/>
+              <a:t> </a:t>
+            </a:r>
+            <a:r>
+              <a:rPr dirty="0" err="1"/>
+              <a:t>en</a:t>
+            </a:r>
+            <a:r>
+              <a:rPr dirty="0"/>
+              <a:t> </a:t>
+            </a:r>
+            <a:r>
+              <a:rPr dirty="0" err="1"/>
+              <a:t>términos</a:t>
+            </a:r>
+            <a:r>
+              <a:rPr dirty="0"/>
+              <a:t> </a:t>
+            </a:r>
+            <a:r>
+              <a:rPr dirty="0" err="1"/>
+              <a:t>operativos</a:t>
+            </a:r>
+            <a:r>
+              <a:rPr dirty="0"/>
+              <a:t>. </a:t>
+            </a:r>
+            <a:r>
+              <a:rPr dirty="0" err="1"/>
+              <a:t>AndinaLog</a:t>
+            </a:r>
+            <a:r>
+              <a:rPr dirty="0"/>
+              <a:t> </a:t>
+            </a:r>
+            <a:r>
+              <a:rPr dirty="0" err="1"/>
+              <a:t>necesita</a:t>
+            </a:r>
+            <a:r>
+              <a:rPr dirty="0"/>
+              <a:t> </a:t>
+            </a:r>
+            <a:r>
+              <a:rPr dirty="0" err="1"/>
+              <a:t>anticipar</a:t>
+            </a:r>
+            <a:r>
+              <a:rPr dirty="0"/>
+              <a:t> una </a:t>
+            </a:r>
+            <a:r>
+              <a:rPr dirty="0" err="1"/>
+              <a:t>desviación</a:t>
+            </a:r>
+            <a:r>
+              <a:rPr dirty="0"/>
+              <a:t> </a:t>
+            </a:r>
+            <a:r>
+              <a:rPr dirty="0" err="1"/>
+              <a:t>térmica</a:t>
+            </a:r>
+            <a:r>
+              <a:rPr dirty="0"/>
+              <a:t> </a:t>
+            </a:r>
+            <a:r>
+              <a:rPr dirty="0" err="1"/>
+              <a:t>durante</a:t>
+            </a:r>
+            <a:r>
+              <a:rPr dirty="0"/>
+              <a:t> la </a:t>
+            </a:r>
+            <a:r>
+              <a:rPr dirty="0" err="1"/>
+              <a:t>siguiente</a:t>
+            </a:r>
+            <a:r>
+              <a:rPr dirty="0"/>
+              <a:t> hora. El </a:t>
+            </a:r>
+            <a:r>
+              <a:rPr dirty="0" err="1"/>
+              <a:t>modelo</a:t>
+            </a:r>
+            <a:r>
+              <a:rPr dirty="0"/>
+              <a:t> </a:t>
+            </a:r>
+            <a:r>
+              <a:rPr dirty="0" err="1"/>
+              <a:t>apoya</a:t>
+            </a:r>
+            <a:r>
+              <a:rPr dirty="0"/>
+              <a:t> la </a:t>
+            </a:r>
+            <a:r>
+              <a:rPr dirty="0" err="1"/>
+              <a:t>priorización</a:t>
+            </a:r>
+            <a:r>
+              <a:rPr dirty="0"/>
+              <a:t> de </a:t>
+            </a:r>
+            <a:r>
+              <a:rPr dirty="0" err="1"/>
+              <a:t>revisiones</a:t>
+            </a:r>
+            <a:r>
+              <a:rPr dirty="0"/>
+              <a:t> </a:t>
+            </a:r>
+            <a:r>
+              <a:rPr dirty="0" err="1"/>
+              <a:t>humanas</a:t>
+            </a:r>
+            <a:r>
+              <a:rPr dirty="0"/>
+              <a:t> y no </a:t>
+            </a:r>
+            <a:r>
+              <a:rPr dirty="0" err="1"/>
+              <a:t>toma</a:t>
+            </a:r>
+            <a:r>
+              <a:rPr dirty="0"/>
+              <a:t> </a:t>
+            </a:r>
+            <a:r>
+              <a:rPr dirty="0" err="1"/>
+              <a:t>decisiones</a:t>
+            </a:r>
+            <a:r>
+              <a:rPr dirty="0"/>
+              <a:t> </a:t>
+            </a:r>
+            <a:r>
+              <a:rPr dirty="0" err="1"/>
+              <a:t>automáticas</a:t>
+            </a:r>
+            <a:r>
+              <a:rPr dirty="0"/>
+              <a:t>.</a:t>
             </a:r>
           </a:p>
         </p:txBody>
@@ -1100,7 +1263,7 @@
           <a:lstStyle/>
           <a:p>
             <a:r>
-              <a:t>Empiece por el desbalance. Después compare el riesgo según la desviación actual. Cierre aclarando que las diferencias de temperatura y humedad ayudan a predecir, pero no prueban causas.</a:t>
+              <a:t>Explique primero el desbalance. Después aclare que la temperatura general mezcla productos con necesidades distintas. Los grupos son descriptivos: no sustituyen una tabla oficial de rangos permitidos por producto.</a:t>
             </a:r>
           </a:p>
         </p:txBody>
@@ -1408,7 +1571,7 @@
           <a:lstStyle/>
           <a:p>
             <a:r>
-              <a:t>Explique que el proyecto mantiene la trazabilidad. Los 455 registros en cuarentena no desaparecen. Las 2.668 ventanas sin futuro completo permanecen en Gold, aunque no participan en el entrenamiento.</a:t>
+              <a:t>Esta es la principal limitación del modelo. Cuando el estado actual es normal solo detecta 10 de 158 eventos. El desempeño también baja en productos cercanos a 20 grados. producto_id no se añadió como predictor; se utilizó para auditar el resultado.</a:t>
             </a:r>
           </a:p>
         </p:txBody>
@@ -1891,7 +2054,7 @@
         </p:nvSpPr>
         <p:spPr>
           <a:xfrm>
-            <a:off x="-171450" y="0"/>
+            <a:off x="0" y="0"/>
             <a:ext cx="7239000" cy="6858000"/>
           </a:xfrm>
           <a:prstGeom prst="rect">
@@ -2009,7 +2172,7 @@
                 <a:ea typeface="Arial"/>
                 <a:cs typeface="Arial"/>
               </a:rPr>
-              <a:t>PRESENTACIÓN FINAL</a:t>
+              <a:t>01 · PROBLEMA</a:t>
             </a:r>
           </a:p>
         </p:txBody>
@@ -2233,7 +2396,7 @@
               </a:defRPr>
             </a:pPr>
             <a:r>
-              <a:rPr sz="1350" b="0" i="0" dirty="0" err="1">
+              <a:rPr sz="1350" b="0" i="0">
                 <a:solidFill>
                   <a:srgbClr val="EDF2F7"/>
                 </a:solidFill>
@@ -2241,27 +2404,8 @@
                 <a:ea typeface="Arial"/>
                 <a:cs typeface="Arial"/>
               </a:rPr>
-              <a:t>Integrantes</a:t>
-            </a:r>
-            <a:r>
-              <a:rPr sz="1350" b="0" i="0">
-                <a:solidFill>
-                  <a:srgbClr val="EDF2F7"/>
-                </a:solidFill>
-                <a:latin typeface="Arial"/>
-                <a:ea typeface="Arial"/>
-                <a:cs typeface="Arial"/>
-              </a:rPr>
-              <a:t>:</a:t>
-            </a:r>
-            <a:endParaRPr sz="1350" b="0" i="0" dirty="0">
-              <a:solidFill>
-                <a:srgbClr val="EDF2F7"/>
-              </a:solidFill>
-              <a:latin typeface="Arial"/>
-              <a:ea typeface="Arial"/>
-              <a:cs typeface="Arial"/>
-            </a:endParaRPr>
+              <a:t>Integrantes: completar antes de exponer</a:t>
+            </a:r>
           </a:p>
         </p:txBody>
       </p:sp>
@@ -2408,46 +2552,16 @@
               </a:defRPr>
             </a:pPr>
             <a:r>
-              <a:rPr sz="1200" b="1" i="0" dirty="0" err="1">
-                <a:solidFill>
-                  <a:srgbClr val="1F3864"/>
-                </a:solidFill>
-                <a:latin typeface="Arial"/>
-                <a:ea typeface="Arial"/>
-                <a:cs typeface="Arial"/>
-              </a:rPr>
-              <a:t>Pregunta</a:t>
-            </a:r>
-            <a:r>
-              <a:rPr sz="1200" b="1" i="0" dirty="0">
-                <a:solidFill>
-                  <a:srgbClr val="1F3864"/>
-                </a:solidFill>
-                <a:latin typeface="Arial"/>
-                <a:ea typeface="Arial"/>
-                <a:cs typeface="Arial"/>
-              </a:rPr>
-              <a:t> de </a:t>
-            </a:r>
-            <a:r>
-              <a:rPr sz="1200" b="1" i="0" dirty="0" err="1">
-                <a:solidFill>
-                  <a:srgbClr val="1F3864"/>
-                </a:solidFill>
-                <a:latin typeface="Arial"/>
-                <a:ea typeface="Arial"/>
-                <a:cs typeface="Arial"/>
-              </a:rPr>
-              <a:t>negocio</a:t>
-            </a:r>
-            <a:endParaRPr sz="1200" b="1" i="0" dirty="0">
-              <a:solidFill>
-                <a:srgbClr val="1F3864"/>
-              </a:solidFill>
-              <a:latin typeface="Arial"/>
-              <a:ea typeface="Arial"/>
-              <a:cs typeface="Arial"/>
-            </a:endParaRPr>
+              <a:rPr sz="1200" b="1" i="0">
+                <a:solidFill>
+                  <a:srgbClr val="1F3864"/>
+                </a:solidFill>
+                <a:latin typeface="Arial"/>
+                <a:ea typeface="Arial"/>
+                <a:cs typeface="Arial"/>
+              </a:rPr>
+              <a:t>Pregunta de negocio</a:t>
+            </a:r>
           </a:p>
         </p:txBody>
       </p:sp>
@@ -2504,7 +2618,7 @@
                 <a:ea typeface="Arial"/>
                 <a:cs typeface="Arial"/>
               </a:rPr>
-              <a:t>¿Qué viajes requieren revisión preventiva durante la próxima hora?</a:t>
+              <a:t>Anticipar qué viajes pueden presentar una desviación térmica durante la próxima hora</a:t>
             </a:r>
           </a:p>
         </p:txBody>
@@ -2710,7 +2824,7 @@
               </a:defRPr>
             </a:pPr>
             <a:r>
-              <a:rPr sz="1200" b="0" i="0" dirty="0">
+              <a:rPr sz="1200" b="0" i="0">
                 <a:solidFill>
                   <a:srgbClr val="595959"/>
                 </a:solidFill>
@@ -2718,51 +2832,7 @@
                 <a:ea typeface="Arial"/>
                 <a:cs typeface="Arial"/>
               </a:rPr>
-              <a:t>1296 </a:t>
-            </a:r>
-            <a:r>
-              <a:rPr sz="1200" b="0" i="0" dirty="0" err="1">
-                <a:solidFill>
-                  <a:srgbClr val="595959"/>
-                </a:solidFill>
-                <a:latin typeface="Arial"/>
-                <a:ea typeface="Arial"/>
-                <a:cs typeface="Arial"/>
-              </a:rPr>
-              <a:t>eventos</a:t>
-            </a:r>
-            <a:r>
-              <a:rPr sz="1200" b="0" i="0" dirty="0">
-                <a:solidFill>
-                  <a:srgbClr val="595959"/>
-                </a:solidFill>
-                <a:latin typeface="Arial"/>
-                <a:ea typeface="Arial"/>
-                <a:cs typeface="Arial"/>
-              </a:rPr>
-              <a:t> </a:t>
-            </a:r>
-            <a:r>
-              <a:rPr sz="1200" b="0" i="0" dirty="0" err="1">
-                <a:solidFill>
-                  <a:srgbClr val="595959"/>
-                </a:solidFill>
-                <a:latin typeface="Arial"/>
-                <a:ea typeface="Arial"/>
-                <a:cs typeface="Arial"/>
-              </a:rPr>
-              <a:t>futuros</a:t>
-            </a:r>
-            <a:r>
-              <a:rPr sz="1200" b="0" i="0" dirty="0">
-                <a:solidFill>
-                  <a:srgbClr val="595959"/>
-                </a:solidFill>
-                <a:latin typeface="Arial"/>
-                <a:ea typeface="Arial"/>
-                <a:cs typeface="Arial"/>
-              </a:rPr>
-              <a:t>; recall 46,76% y PR AUC 37,32%</a:t>
+              <a:t>Solo 5,02% de las ventanas tiene un evento futuro, por lo que detectar esos casos es difícil</a:t>
             </a:r>
           </a:p>
         </p:txBody>
@@ -2976,7 +3046,7 @@
                 <a:ea typeface="Arial"/>
                 <a:cs typeface="Arial"/>
               </a:rPr>
-              <a:t>Priorizar la revisión humana de viajes con mayor riesgo estimado</a:t>
+              <a:t>Priorizar la revisión humana sin convertir la alerta en una decisión automática</a:t>
             </a:r>
           </a:p>
         </p:txBody>
@@ -3082,7 +3152,7 @@
           <p:cNvPr id="23" name="TextBox 22">
             <a:extLst>
               <a:ext uri="{FF2B5EF4-FFF2-40B4-BE49-F238E27FC236}">
-                <a16:creationId xmlns:a16="http://schemas.microsoft.com/office/drawing/2014/main" id="{E63F1205-53E0-41D9-97F6-B91F18AB77EB}"/>
+                <a16:creationId xmlns:a16="http://schemas.microsoft.com/office/drawing/2014/main" id="{DB8554F0-9578-4ABA-B82E-D4F0A1F375B0}"/>
               </a:ext>
             </a:extLst>
           </p:cNvPr>
@@ -3094,7 +3164,7 @@
         <p:spPr>
           <a:xfrm>
             <a:off x="7867650" y="609600"/>
-            <a:ext cx="4286250" cy="396240"/>
+            <a:ext cx="4286250" cy="381000"/>
           </a:xfrm>
           <a:prstGeom prst="rect">
             <a:avLst/>
@@ -3116,7 +3186,7 @@
                 <a:ea typeface="Arial"/>
                 <a:cs typeface="Arial"/>
               </a:rPr>
-              <a:t>HOJA DE RUTA DE LA EXPOSICIÓN (vista previa, no reemplaza las diapositivas 2–8)</a:t>
+              <a:t>PROBLEMA, EVIDENCIA Y DECISIÓN</a:t>
             </a:r>
           </a:p>
         </p:txBody>
@@ -3250,7 +3320,7 @@
                 <a:ea typeface="Arial"/>
                 <a:cs typeface="Arial"/>
               </a:rPr>
-              <a:t>09 · CIERRE</a:t>
+              <a:t>06 · LIMITACIONES, IA Y CONTINUIDAD</a:t>
             </a:r>
           </a:p>
         </p:txBody>
@@ -3702,7 +3772,7 @@
                 <a:ea typeface="Arial"/>
                 <a:cs typeface="Arial"/>
               </a:rPr>
-              <a:t>• La evaluación usa una sola división por viaje</a:t>
+              <a:t>• No hay rangos térmicos oficiales por producto</a:t>
             </a:r>
           </a:p>
           <a:p>
@@ -3726,7 +3796,7 @@
                 <a:ea typeface="Arial"/>
                 <a:cs typeface="Arial"/>
               </a:rPr>
-              <a:t>• La fuente no contiene todas las causas operativas</a:t>
+              <a:t>• Algunos productos tienen pocos positivos en prueba</a:t>
             </a:r>
           </a:p>
           <a:p>
@@ -3750,7 +3820,7 @@
                 <a:ea typeface="Arial"/>
                 <a:cs typeface="Arial"/>
               </a:rPr>
-              <a:t>• Los coeficientes no prueban causalidad</a:t>
+              <a:t>• El modelo detecta débilmente eventos nuevos</a:t>
             </a:r>
           </a:p>
         </p:txBody>
@@ -3772,7 +3842,7 @@
         <p:spPr>
           <a:xfrm>
             <a:off x="762000" y="4248150"/>
-            <a:ext cx="3048000" cy="533400"/>
+            <a:ext cx="3048000" cy="400050"/>
           </a:xfrm>
           <a:prstGeom prst="roundRect">
             <a:avLst>
@@ -3811,7 +3881,7 @@
         </p:nvSpPr>
         <p:spPr>
           <a:xfrm>
-            <a:off x="895350" y="4316349"/>
+            <a:off x="895350" y="4246793"/>
             <a:ext cx="2781300" cy="200025"/>
           </a:xfrm>
           <a:prstGeom prst="rect">
@@ -4460,18 +4530,18 @@
                 <a:ea typeface="Arial"/>
                 <a:cs typeface="Arial"/>
               </a:rPr>
-              <a:t>• OpenAI Codex</a:t>
-            </a:r>
-            <a:r>
-              <a:rPr lang="en-US" sz="1275" b="0" i="0" dirty="0">
-                <a:solidFill>
-                  <a:srgbClr val="1F3864"/>
-                </a:solidFill>
-                <a:latin typeface="Arial"/>
-                <a:ea typeface="Arial"/>
-                <a:cs typeface="Arial"/>
-              </a:rPr>
-              <a:t> y Open Code</a:t>
+              <a:t>• OpenAI Codex </a:t>
+            </a:r>
+            <a:r>
+              <a:rPr sz="1275" b="0" i="0" dirty="0" err="1">
+                <a:solidFill>
+                  <a:srgbClr val="1F3864"/>
+                </a:solidFill>
+                <a:latin typeface="Arial"/>
+                <a:ea typeface="Arial"/>
+                <a:cs typeface="Arial"/>
+              </a:rPr>
+              <a:t>apoyó</a:t>
             </a:r>
             <a:r>
               <a:rPr sz="1275" b="0" i="0" dirty="0">
@@ -4493,7 +4563,7 @@
                 <a:ea typeface="Arial"/>
                 <a:cs typeface="Arial"/>
               </a:rPr>
-              <a:t>apoyó</a:t>
+              <a:t>código</a:t>
             </a:r>
             <a:r>
               <a:rPr sz="1275" b="0" i="0" dirty="0">
@@ -4504,29 +4574,7 @@
                 <a:ea typeface="Arial"/>
                 <a:cs typeface="Arial"/>
               </a:rPr>
-              <a:t> </a:t>
-            </a:r>
-            <a:r>
-              <a:rPr sz="1275" b="0" i="0" dirty="0" err="1">
-                <a:solidFill>
-                  <a:srgbClr val="1F3864"/>
-                </a:solidFill>
-                <a:latin typeface="Arial"/>
-                <a:ea typeface="Arial"/>
-                <a:cs typeface="Arial"/>
-              </a:rPr>
-              <a:t>código</a:t>
-            </a:r>
-            <a:r>
-              <a:rPr sz="1275" b="0" i="0" dirty="0">
-                <a:solidFill>
-                  <a:srgbClr val="1F3864"/>
-                </a:solidFill>
-                <a:latin typeface="Arial"/>
-                <a:ea typeface="Arial"/>
-                <a:cs typeface="Arial"/>
-              </a:rPr>
-              <a:t> y el </a:t>
+              <a:t>; el </a:t>
             </a:r>
             <a:r>
               <a:rPr sz="1275" b="0" i="0" dirty="0" err="1">
@@ -4589,7 +4637,7 @@
         <p:spPr>
           <a:xfrm>
             <a:off x="4533900" y="4248150"/>
-            <a:ext cx="3048000" cy="533400"/>
+            <a:ext cx="3048000" cy="400050"/>
           </a:xfrm>
           <a:prstGeom prst="roundRect">
             <a:avLst>
@@ -4628,7 +4676,7 @@
         </p:nvSpPr>
         <p:spPr>
           <a:xfrm>
-            <a:off x="4667250" y="4316349"/>
+            <a:off x="4667250" y="4246793"/>
             <a:ext cx="2781300" cy="200025"/>
           </a:xfrm>
           <a:prstGeom prst="rect">
@@ -4657,7 +4705,7 @@
               </a:defRPr>
             </a:pPr>
             <a:r>
-              <a:rPr sz="975" b="1" i="0" dirty="0" err="1">
+              <a:rPr sz="975" b="1" i="0">
                 <a:solidFill>
                   <a:srgbClr val="595959"/>
                 </a:solidFill>
@@ -4665,148 +4713,8 @@
                 <a:ea typeface="Arial"/>
                 <a:cs typeface="Arial"/>
               </a:rPr>
-              <a:t>Conclusión</a:t>
-            </a:r>
-            <a:r>
-              <a:rPr sz="975" b="1" i="0" dirty="0">
-                <a:solidFill>
-                  <a:srgbClr val="595959"/>
-                </a:solidFill>
-                <a:latin typeface="Arial"/>
-                <a:ea typeface="Arial"/>
-                <a:cs typeface="Arial"/>
-              </a:rPr>
-              <a:t>: </a:t>
-            </a:r>
-            <a:r>
-              <a:rPr sz="975" b="1" i="0" dirty="0" err="1">
-                <a:solidFill>
-                  <a:srgbClr val="595959"/>
-                </a:solidFill>
-                <a:latin typeface="Arial"/>
-                <a:ea typeface="Arial"/>
-                <a:cs typeface="Arial"/>
-              </a:rPr>
-              <a:t>ninguna</a:t>
-            </a:r>
-            <a:r>
-              <a:rPr sz="975" b="1" i="0" dirty="0">
-                <a:solidFill>
-                  <a:srgbClr val="595959"/>
-                </a:solidFill>
-                <a:latin typeface="Arial"/>
-                <a:ea typeface="Arial"/>
-                <a:cs typeface="Arial"/>
-              </a:rPr>
-              <a:t> </a:t>
-            </a:r>
-            <a:r>
-              <a:rPr sz="975" b="1" i="0" dirty="0" err="1">
-                <a:solidFill>
-                  <a:srgbClr val="595959"/>
-                </a:solidFill>
-                <a:latin typeface="Arial"/>
-                <a:ea typeface="Arial"/>
-                <a:cs typeface="Arial"/>
-              </a:rPr>
-              <a:t>alerta</a:t>
-            </a:r>
-            <a:r>
-              <a:rPr sz="975" b="1" i="0" dirty="0">
-                <a:solidFill>
-                  <a:srgbClr val="595959"/>
-                </a:solidFill>
-                <a:latin typeface="Arial"/>
-                <a:ea typeface="Arial"/>
-                <a:cs typeface="Arial"/>
-              </a:rPr>
-              <a:t> </a:t>
-            </a:r>
-            <a:r>
-              <a:rPr sz="975" b="1" i="0" dirty="0" err="1">
-                <a:solidFill>
-                  <a:srgbClr val="595959"/>
-                </a:solidFill>
-                <a:latin typeface="Arial"/>
-                <a:ea typeface="Arial"/>
-                <a:cs typeface="Arial"/>
-              </a:rPr>
-              <a:t>debe</a:t>
-            </a:r>
-            <a:r>
-              <a:rPr sz="975" b="1" i="0" dirty="0">
-                <a:solidFill>
-                  <a:srgbClr val="595959"/>
-                </a:solidFill>
-                <a:latin typeface="Arial"/>
-                <a:ea typeface="Arial"/>
-                <a:cs typeface="Arial"/>
-              </a:rPr>
-              <a:t> </a:t>
-            </a:r>
-            <a:r>
-              <a:rPr sz="975" b="1" i="0" dirty="0" err="1">
-                <a:solidFill>
-                  <a:srgbClr val="595959"/>
-                </a:solidFill>
-                <a:latin typeface="Arial"/>
-                <a:ea typeface="Arial"/>
-                <a:cs typeface="Arial"/>
-              </a:rPr>
-              <a:t>activar</a:t>
-            </a:r>
-            <a:r>
-              <a:rPr sz="975" b="1" i="0" dirty="0">
-                <a:solidFill>
-                  <a:srgbClr val="595959"/>
-                </a:solidFill>
-                <a:latin typeface="Arial"/>
-                <a:ea typeface="Arial"/>
-                <a:cs typeface="Arial"/>
-              </a:rPr>
-              <a:t> </a:t>
-            </a:r>
-            <a:r>
-              <a:rPr sz="975" b="1" i="0" dirty="0" err="1">
-                <a:solidFill>
-                  <a:srgbClr val="595959"/>
-                </a:solidFill>
-                <a:latin typeface="Arial"/>
-                <a:ea typeface="Arial"/>
-                <a:cs typeface="Arial"/>
-              </a:rPr>
-              <a:t>sanciones</a:t>
-            </a:r>
-            <a:r>
-              <a:rPr sz="975" b="1" i="0" dirty="0">
-                <a:solidFill>
-                  <a:srgbClr val="595959"/>
-                </a:solidFill>
-                <a:latin typeface="Arial"/>
-                <a:ea typeface="Arial"/>
-                <a:cs typeface="Arial"/>
-              </a:rPr>
-              <a:t> </a:t>
-            </a:r>
-            <a:r>
-              <a:rPr sz="975" b="1" i="0" dirty="0" err="1">
-                <a:solidFill>
-                  <a:srgbClr val="595959"/>
-                </a:solidFill>
-                <a:latin typeface="Arial"/>
-                <a:ea typeface="Arial"/>
-                <a:cs typeface="Arial"/>
-              </a:rPr>
-              <a:t>automáticas</a:t>
-            </a:r>
-            <a:endParaRPr sz="975" b="1" i="0" dirty="0">
-              <a:solidFill>
-                <a:srgbClr val="595959"/>
-              </a:solidFill>
-              <a:latin typeface="Arial"/>
-              <a:ea typeface="Arial"/>
-              <a:cs typeface="Arial"/>
-            </a:endParaRPr>
+              <a:t>Conclusión: ninguna alerta debe activar sanciones automáticas</a:t>
+            </a:r>
           </a:p>
         </p:txBody>
       </p:sp>
@@ -4947,7 +4855,7 @@
               </a:defRPr>
             </a:pPr>
             <a:r>
-              <a:rPr sz="1050" b="1" i="0" dirty="0">
+              <a:rPr sz="1050" b="1" i="0">
                 <a:solidFill>
                   <a:srgbClr val="2E5B8A"/>
                 </a:solidFill>
@@ -5005,59 +4913,15 @@
               </a:defRPr>
             </a:pPr>
             <a:r>
-              <a:rPr sz="1275" b="0" i="0" dirty="0">
-                <a:solidFill>
-                  <a:srgbClr val="1F3864"/>
-                </a:solidFill>
-                <a:latin typeface="Arial"/>
-                <a:ea typeface="Arial"/>
-                <a:cs typeface="Arial"/>
-              </a:rPr>
-              <a:t>• Dashboard: </a:t>
-            </a:r>
-            <a:r>
-              <a:rPr sz="1275" b="0" i="0" dirty="0" err="1">
-                <a:solidFill>
-                  <a:srgbClr val="1F3864"/>
-                </a:solidFill>
-                <a:latin typeface="Arial"/>
-                <a:ea typeface="Arial"/>
-                <a:cs typeface="Arial"/>
-              </a:rPr>
-              <a:t>prevalencia</a:t>
-            </a:r>
-            <a:r>
-              <a:rPr sz="1275" b="0" i="0" dirty="0">
-                <a:solidFill>
-                  <a:srgbClr val="1F3864"/>
-                </a:solidFill>
-                <a:latin typeface="Arial"/>
-                <a:ea typeface="Arial"/>
-                <a:cs typeface="Arial"/>
-              </a:rPr>
-              <a:t>, recall, </a:t>
-            </a:r>
-            <a:r>
-              <a:rPr sz="1275" b="0" i="0" dirty="0" err="1">
-                <a:solidFill>
-                  <a:srgbClr val="1F3864"/>
-                </a:solidFill>
-                <a:latin typeface="Arial"/>
-                <a:ea typeface="Arial"/>
-                <a:cs typeface="Arial"/>
-              </a:rPr>
-              <a:t>precisión</a:t>
-            </a:r>
-            <a:r>
-              <a:rPr sz="1275" b="0" i="0" dirty="0">
-                <a:solidFill>
-                  <a:srgbClr val="1F3864"/>
-                </a:solidFill>
-                <a:latin typeface="Arial"/>
-                <a:ea typeface="Arial"/>
-                <a:cs typeface="Arial"/>
-              </a:rPr>
-              <a:t> y PR AUC</a:t>
+              <a:rPr sz="1275" b="0" i="0">
+                <a:solidFill>
+                  <a:srgbClr val="1F3864"/>
+                </a:solidFill>
+                <a:latin typeface="Arial"/>
+                <a:ea typeface="Arial"/>
+                <a:cs typeface="Arial"/>
+              </a:rPr>
+              <a:t>• Dashboard: prevalencia, recall, precisión y PR AUC</a:t>
             </a:r>
           </a:p>
           <a:p>
@@ -5073,101 +4937,16 @@
               </a:defRPr>
             </a:pPr>
             <a:r>
-              <a:rPr sz="1275" b="0" i="0" dirty="0">
-                <a:solidFill>
-                  <a:srgbClr val="1F3864"/>
-                </a:solidFill>
-                <a:latin typeface="Arial"/>
-                <a:ea typeface="Arial"/>
-                <a:cs typeface="Arial"/>
-              </a:rPr>
-              <a:t>• </a:t>
-            </a:r>
-            <a:r>
-              <a:rPr sz="1275" b="0" i="0" dirty="0" err="1">
-                <a:solidFill>
-                  <a:srgbClr val="1F3864"/>
-                </a:solidFill>
-                <a:latin typeface="Arial"/>
-                <a:ea typeface="Arial"/>
-                <a:cs typeface="Arial"/>
-              </a:rPr>
-              <a:t>Seguimiento</a:t>
-            </a:r>
-            <a:r>
-              <a:rPr sz="1275" b="0" i="0" dirty="0">
-                <a:solidFill>
-                  <a:srgbClr val="1F3864"/>
-                </a:solidFill>
-                <a:latin typeface="Arial"/>
-                <a:ea typeface="Arial"/>
-                <a:cs typeface="Arial"/>
-              </a:rPr>
-              <a:t> </a:t>
-            </a:r>
-            <a:r>
-              <a:rPr sz="1275" b="0" i="0" dirty="0" err="1">
-                <a:solidFill>
-                  <a:srgbClr val="1F3864"/>
-                </a:solidFill>
-                <a:latin typeface="Arial"/>
-                <a:ea typeface="Arial"/>
-                <a:cs typeface="Arial"/>
-              </a:rPr>
-              <a:t>por</a:t>
-            </a:r>
-            <a:r>
-              <a:rPr sz="1275" b="0" i="0" dirty="0">
-                <a:solidFill>
-                  <a:srgbClr val="1F3864"/>
-                </a:solidFill>
-                <a:latin typeface="Arial"/>
-                <a:ea typeface="Arial"/>
-                <a:cs typeface="Arial"/>
-              </a:rPr>
-              <a:t> </a:t>
-            </a:r>
-            <a:r>
-              <a:rPr sz="1275" b="0" i="0" dirty="0" err="1">
-                <a:solidFill>
-                  <a:srgbClr val="1F3864"/>
-                </a:solidFill>
-                <a:latin typeface="Arial"/>
-                <a:ea typeface="Arial"/>
-                <a:cs typeface="Arial"/>
-              </a:rPr>
-              <a:t>viaje</a:t>
-            </a:r>
-            <a:r>
-              <a:rPr sz="1275" b="0" i="0" dirty="0">
-                <a:solidFill>
-                  <a:srgbClr val="1F3864"/>
-                </a:solidFill>
-                <a:latin typeface="Arial"/>
-                <a:ea typeface="Arial"/>
-                <a:cs typeface="Arial"/>
-              </a:rPr>
-              <a:t> y </a:t>
-            </a:r>
-            <a:r>
-              <a:rPr sz="1275" b="0" i="0" dirty="0" err="1">
-                <a:solidFill>
-                  <a:srgbClr val="1F3864"/>
-                </a:solidFill>
-                <a:latin typeface="Arial"/>
-                <a:ea typeface="Arial"/>
-                <a:cs typeface="Arial"/>
-              </a:rPr>
-              <a:t>periodo</a:t>
-            </a:r>
-            <a:endParaRPr sz="1275" b="0" i="0" dirty="0">
-              <a:solidFill>
-                <a:srgbClr val="1F3864"/>
-              </a:solidFill>
-              <a:latin typeface="Arial"/>
-              <a:ea typeface="Arial"/>
-              <a:cs typeface="Arial"/>
-            </a:endParaRPr>
+              <a:rPr sz="1275" b="0" i="0">
+                <a:solidFill>
+                  <a:srgbClr val="1F3864"/>
+                </a:solidFill>
+                <a:latin typeface="Arial"/>
+                <a:ea typeface="Arial"/>
+                <a:cs typeface="Arial"/>
+              </a:rPr>
+              <a:t>• Filtros por producto y desviación actual</a:t>
+            </a:r>
           </a:p>
           <a:p>
             <a:pPr algn="l">
@@ -5182,101 +4961,16 @@
               </a:defRPr>
             </a:pPr>
             <a:r>
-              <a:rPr sz="1275" b="0" i="0" dirty="0">
-                <a:solidFill>
-                  <a:srgbClr val="1F3864"/>
-                </a:solidFill>
-                <a:latin typeface="Arial"/>
-                <a:ea typeface="Arial"/>
-                <a:cs typeface="Arial"/>
-              </a:rPr>
-              <a:t>• </a:t>
-            </a:r>
-            <a:r>
-              <a:rPr sz="1275" b="0" i="0" dirty="0" err="1">
-                <a:solidFill>
-                  <a:srgbClr val="1F3864"/>
-                </a:solidFill>
-                <a:latin typeface="Arial"/>
-                <a:ea typeface="Arial"/>
-                <a:cs typeface="Arial"/>
-              </a:rPr>
-              <a:t>Incorporar</a:t>
-            </a:r>
-            <a:r>
-              <a:rPr sz="1275" b="0" i="0" dirty="0">
-                <a:solidFill>
-                  <a:srgbClr val="1F3864"/>
-                </a:solidFill>
-                <a:latin typeface="Arial"/>
-                <a:ea typeface="Arial"/>
-                <a:cs typeface="Arial"/>
-              </a:rPr>
-              <a:t> </a:t>
-            </a:r>
-            <a:r>
-              <a:rPr sz="1275" b="0" i="0" dirty="0" err="1">
-                <a:solidFill>
-                  <a:srgbClr val="1F3864"/>
-                </a:solidFill>
-                <a:latin typeface="Arial"/>
-                <a:ea typeface="Arial"/>
-                <a:cs typeface="Arial"/>
-              </a:rPr>
-              <a:t>nuevos</a:t>
-            </a:r>
-            <a:r>
-              <a:rPr sz="1275" b="0" i="0" dirty="0">
-                <a:solidFill>
-                  <a:srgbClr val="1F3864"/>
-                </a:solidFill>
-                <a:latin typeface="Arial"/>
-                <a:ea typeface="Arial"/>
-                <a:cs typeface="Arial"/>
-              </a:rPr>
-              <a:t> </a:t>
-            </a:r>
-            <a:r>
-              <a:rPr sz="1275" b="0" i="0" dirty="0" err="1">
-                <a:solidFill>
-                  <a:srgbClr val="1F3864"/>
-                </a:solidFill>
-                <a:latin typeface="Arial"/>
-                <a:ea typeface="Arial"/>
-                <a:cs typeface="Arial"/>
-              </a:rPr>
-              <a:t>datos</a:t>
-            </a:r>
-            <a:r>
-              <a:rPr sz="1275" b="0" i="0" dirty="0">
-                <a:solidFill>
-                  <a:srgbClr val="1F3864"/>
-                </a:solidFill>
-                <a:latin typeface="Arial"/>
-                <a:ea typeface="Arial"/>
-                <a:cs typeface="Arial"/>
-              </a:rPr>
-              <a:t> de </a:t>
-            </a:r>
-            <a:r>
-              <a:rPr sz="1275" b="0" i="0" dirty="0" err="1">
-                <a:solidFill>
-                  <a:srgbClr val="1F3864"/>
-                </a:solidFill>
-                <a:latin typeface="Arial"/>
-                <a:ea typeface="Arial"/>
-                <a:cs typeface="Arial"/>
-              </a:rPr>
-              <a:t>operación</a:t>
-            </a:r>
-            <a:endParaRPr sz="1275" b="0" i="0" dirty="0">
-              <a:solidFill>
-                <a:srgbClr val="1F3864"/>
-              </a:solidFill>
-              <a:latin typeface="Arial"/>
-              <a:ea typeface="Arial"/>
-              <a:cs typeface="Arial"/>
-            </a:endParaRPr>
+              <a:rPr sz="1275" b="0" i="0">
+                <a:solidFill>
+                  <a:srgbClr val="1F3864"/>
+                </a:solidFill>
+                <a:latin typeface="Arial"/>
+                <a:ea typeface="Arial"/>
+                <a:cs typeface="Arial"/>
+              </a:rPr>
+              <a:t>• Incorporar rangos térmicos oficiales</a:t>
+            </a:r>
           </a:p>
           <a:p>
             <a:pPr algn="l">
@@ -5291,57 +4985,16 @@
               </a:defRPr>
             </a:pPr>
             <a:r>
-              <a:rPr sz="1275" b="0" i="0" dirty="0">
-                <a:solidFill>
-                  <a:srgbClr val="1F3864"/>
-                </a:solidFill>
-                <a:latin typeface="Arial"/>
-                <a:ea typeface="Arial"/>
-                <a:cs typeface="Arial"/>
-              </a:rPr>
-              <a:t>• </a:t>
-            </a:r>
-            <a:r>
-              <a:rPr sz="1275" b="0" i="0" dirty="0" err="1">
-                <a:solidFill>
-                  <a:srgbClr val="1F3864"/>
-                </a:solidFill>
-                <a:latin typeface="Arial"/>
-                <a:ea typeface="Arial"/>
-                <a:cs typeface="Arial"/>
-              </a:rPr>
-              <a:t>Revalidar</a:t>
-            </a:r>
-            <a:r>
-              <a:rPr sz="1275" b="0" i="0" dirty="0">
-                <a:solidFill>
-                  <a:srgbClr val="1F3864"/>
-                </a:solidFill>
-                <a:latin typeface="Arial"/>
-                <a:ea typeface="Arial"/>
-                <a:cs typeface="Arial"/>
-              </a:rPr>
-              <a:t> el umbral antes del </a:t>
-            </a:r>
-            <a:r>
-              <a:rPr sz="1275" b="0" i="0" dirty="0" err="1">
-                <a:solidFill>
-                  <a:srgbClr val="1F3864"/>
-                </a:solidFill>
-                <a:latin typeface="Arial"/>
-                <a:ea typeface="Arial"/>
-                <a:cs typeface="Arial"/>
-              </a:rPr>
-              <a:t>despliegue</a:t>
-            </a:r>
-            <a:endParaRPr sz="1275" b="0" i="0" dirty="0">
-              <a:solidFill>
-                <a:srgbClr val="1F3864"/>
-              </a:solidFill>
-              <a:latin typeface="Arial"/>
-              <a:ea typeface="Arial"/>
-              <a:cs typeface="Arial"/>
-            </a:endParaRPr>
+              <a:rPr sz="1275" b="0" i="0">
+                <a:solidFill>
+                  <a:srgbClr val="1F3864"/>
+                </a:solidFill>
+                <a:latin typeface="Arial"/>
+                <a:ea typeface="Arial"/>
+                <a:cs typeface="Arial"/>
+              </a:rPr>
+              <a:t>• Revalidar con viajes nuevos antes del despliegue</a:t>
+            </a:r>
           </a:p>
         </p:txBody>
       </p:sp>
@@ -5362,7 +5015,7 @@
         <p:spPr>
           <a:xfrm>
             <a:off x="8305800" y="4248150"/>
-            <a:ext cx="3048000" cy="533400"/>
+            <a:ext cx="3048000" cy="400050"/>
           </a:xfrm>
           <a:prstGeom prst="roundRect">
             <a:avLst>
@@ -5401,7 +5054,7 @@
         </p:nvSpPr>
         <p:spPr>
           <a:xfrm>
-            <a:off x="8439150" y="4316349"/>
+            <a:off x="8439150" y="4246793"/>
             <a:ext cx="2781300" cy="200025"/>
           </a:xfrm>
           <a:prstGeom prst="rect">
@@ -5430,7 +5083,7 @@
               </a:defRPr>
             </a:pPr>
             <a:r>
-              <a:rPr sz="975" b="1" i="0" dirty="0" err="1">
+              <a:rPr sz="975" b="1" i="0">
                 <a:solidFill>
                   <a:srgbClr val="595959"/>
                 </a:solidFill>
@@ -5438,126 +5091,8 @@
                 <a:ea typeface="Arial"/>
                 <a:cs typeface="Arial"/>
               </a:rPr>
-              <a:t>Conclusión</a:t>
-            </a:r>
-            <a:r>
-              <a:rPr sz="975" b="1" i="0" dirty="0">
-                <a:solidFill>
-                  <a:srgbClr val="595959"/>
-                </a:solidFill>
-                <a:latin typeface="Arial"/>
-                <a:ea typeface="Arial"/>
-                <a:cs typeface="Arial"/>
-              </a:rPr>
-              <a:t>: el </a:t>
-            </a:r>
-            <a:r>
-              <a:rPr sz="975" b="1" i="0" dirty="0" err="1">
-                <a:solidFill>
-                  <a:srgbClr val="595959"/>
-                </a:solidFill>
-                <a:latin typeface="Arial"/>
-                <a:ea typeface="Arial"/>
-                <a:cs typeface="Arial"/>
-              </a:rPr>
-              <a:t>Módulo</a:t>
-            </a:r>
-            <a:r>
-              <a:rPr sz="975" b="1" i="0" dirty="0">
-                <a:solidFill>
-                  <a:srgbClr val="595959"/>
-                </a:solidFill>
-                <a:latin typeface="Arial"/>
-                <a:ea typeface="Arial"/>
-                <a:cs typeface="Arial"/>
-              </a:rPr>
-              <a:t> 4 </a:t>
-            </a:r>
-            <a:r>
-              <a:rPr sz="975" b="1" i="0" dirty="0" err="1">
-                <a:solidFill>
-                  <a:srgbClr val="595959"/>
-                </a:solidFill>
-                <a:latin typeface="Arial"/>
-                <a:ea typeface="Arial"/>
-                <a:cs typeface="Arial"/>
-              </a:rPr>
-              <a:t>debe</a:t>
-            </a:r>
-            <a:r>
-              <a:rPr sz="975" b="1" i="0" dirty="0">
-                <a:solidFill>
-                  <a:srgbClr val="595959"/>
-                </a:solidFill>
-                <a:latin typeface="Arial"/>
-                <a:ea typeface="Arial"/>
-                <a:cs typeface="Arial"/>
-              </a:rPr>
-              <a:t> </a:t>
-            </a:r>
-            <a:r>
-              <a:rPr sz="975" b="1" i="0" dirty="0" err="1">
-                <a:solidFill>
-                  <a:srgbClr val="595959"/>
-                </a:solidFill>
-                <a:latin typeface="Arial"/>
-                <a:ea typeface="Arial"/>
-                <a:cs typeface="Arial"/>
-              </a:rPr>
-              <a:t>vigilar</a:t>
-            </a:r>
-            <a:r>
-              <a:rPr sz="975" b="1" i="0" dirty="0">
-                <a:solidFill>
-                  <a:srgbClr val="595959"/>
-                </a:solidFill>
-                <a:latin typeface="Arial"/>
-                <a:ea typeface="Arial"/>
-                <a:cs typeface="Arial"/>
-              </a:rPr>
-              <a:t> </a:t>
-            </a:r>
-            <a:r>
-              <a:rPr sz="975" b="1" i="0" dirty="0" err="1">
-                <a:solidFill>
-                  <a:srgbClr val="595959"/>
-                </a:solidFill>
-                <a:latin typeface="Arial"/>
-                <a:ea typeface="Arial"/>
-                <a:cs typeface="Arial"/>
-              </a:rPr>
-              <a:t>desempeño</a:t>
-            </a:r>
-            <a:r>
-              <a:rPr sz="975" b="1" i="0" dirty="0">
-                <a:solidFill>
-                  <a:srgbClr val="595959"/>
-                </a:solidFill>
-                <a:latin typeface="Arial"/>
-                <a:ea typeface="Arial"/>
-                <a:cs typeface="Arial"/>
-              </a:rPr>
-              <a:t> y </a:t>
-            </a:r>
-            <a:r>
-              <a:rPr sz="975" b="1" i="0" dirty="0" err="1">
-                <a:solidFill>
-                  <a:srgbClr val="595959"/>
-                </a:solidFill>
-                <a:latin typeface="Arial"/>
-                <a:ea typeface="Arial"/>
-                <a:cs typeface="Arial"/>
-              </a:rPr>
-              <a:t>errores</a:t>
-            </a:r>
-            <a:endParaRPr sz="975" b="1" i="0" dirty="0">
-              <a:solidFill>
-                <a:srgbClr val="595959"/>
-              </a:solidFill>
-              <a:latin typeface="Arial"/>
-              <a:ea typeface="Arial"/>
-              <a:cs typeface="Arial"/>
-            </a:endParaRPr>
+              <a:t>Conclusión: el Módulo 4 debe vigilar desempeño y errores</a:t>
+            </a:r>
           </a:p>
         </p:txBody>
       </p:sp>
@@ -5646,7 +5181,7 @@
               </a:defRPr>
             </a:pPr>
             <a:r>
-              <a:rPr sz="900" b="1" i="0">
+              <a:rPr sz="900" b="1" i="0" dirty="0">
                 <a:solidFill>
                   <a:srgbClr val="2E5B8A"/>
                 </a:solidFill>
@@ -5712,7 +5247,7 @@
                 <a:ea typeface="Arial"/>
                 <a:cs typeface="Arial"/>
               </a:rPr>
-              <a:t>Costear FP y FN con Operaciones y Analítica. Fecha por acordar.</a:t>
+              <a:t>Definir rangos por producto y costear los errores.</a:t>
             </a:r>
           </a:p>
         </p:txBody>
@@ -5733,8 +5268,8 @@
         </p:nvSpPr>
         <p:spPr>
           <a:xfrm>
-            <a:off x="7448550" y="5476875"/>
-            <a:ext cx="3829051" cy="342900"/>
+            <a:off x="7867650" y="5411562"/>
+            <a:ext cx="3409950" cy="342900"/>
           </a:xfrm>
           <a:prstGeom prst="rect">
             <a:avLst/>
@@ -5803,7 +5338,7 @@
                 <a:ea typeface="Arial"/>
                 <a:cs typeface="Arial"/>
               </a:rPr>
-              <a:t>temprana</a:t>
+              <a:t>útil</a:t>
             </a:r>
             <a:r>
               <a:rPr sz="1125" b="0" i="0" dirty="0">
@@ -5814,7 +5349,7 @@
                 <a:ea typeface="Arial"/>
                 <a:cs typeface="Arial"/>
               </a:rPr>
-              <a:t> para </a:t>
+              <a:t>, con </a:t>
             </a:r>
             <a:r>
               <a:rPr sz="1125" b="0" i="0" dirty="0" err="1">
@@ -5825,7 +5360,7 @@
                 <a:ea typeface="Arial"/>
                 <a:cs typeface="Arial"/>
               </a:rPr>
-              <a:t>priorizar</a:t>
+              <a:t>límites</a:t>
             </a:r>
             <a:r>
               <a:rPr sz="1125" b="0" i="0" dirty="0">
@@ -5836,7 +5371,7 @@
                 <a:ea typeface="Arial"/>
                 <a:cs typeface="Arial"/>
               </a:rPr>
-              <a:t> </a:t>
+              <a:t> claros y </a:t>
             </a:r>
             <a:r>
               <a:rPr sz="1125" b="0" i="0" dirty="0" err="1">
@@ -5847,7 +5382,7 @@
                 <a:ea typeface="Arial"/>
                 <a:cs typeface="Arial"/>
               </a:rPr>
-              <a:t>revisión</a:t>
+              <a:t>supervisión</a:t>
             </a:r>
             <a:r>
               <a:rPr sz="1125" b="0" i="0" dirty="0">
@@ -7555,7 +7090,7 @@
               </a:defRPr>
             </a:pPr>
             <a:r>
-              <a:rPr sz="1125" b="0" i="0" dirty="0">
+              <a:rPr sz="1125" b="0" i="0">
                 <a:solidFill>
                   <a:srgbClr val="1F3864"/>
                 </a:solidFill>
@@ -7751,134 +7286,16 @@
               </a:defRPr>
             </a:pPr>
             <a:r>
-              <a:rPr sz="1125" b="0" i="0" dirty="0" err="1">
-                <a:solidFill>
-                  <a:srgbClr val="1F3864"/>
-                </a:solidFill>
-                <a:latin typeface="Arial"/>
-                <a:ea typeface="Arial"/>
-                <a:cs typeface="Arial"/>
-              </a:rPr>
-              <a:t>Temperatura</a:t>
-            </a:r>
-            <a:r>
-              <a:rPr sz="1125" b="0" i="0" dirty="0">
-                <a:solidFill>
-                  <a:srgbClr val="1F3864"/>
-                </a:solidFill>
-                <a:latin typeface="Arial"/>
-                <a:ea typeface="Arial"/>
-                <a:cs typeface="Arial"/>
-              </a:rPr>
-              <a:t> y </a:t>
-            </a:r>
-            <a:r>
-              <a:rPr sz="1125" b="0" i="0" dirty="0" err="1">
-                <a:solidFill>
-                  <a:srgbClr val="1F3864"/>
-                </a:solidFill>
-                <a:latin typeface="Arial"/>
-                <a:ea typeface="Arial"/>
-                <a:cs typeface="Arial"/>
-              </a:rPr>
-              <a:t>humedad</a:t>
-            </a:r>
-            <a:r>
-              <a:rPr sz="1125" b="0" i="0" dirty="0">
-                <a:solidFill>
-                  <a:srgbClr val="1F3864"/>
-                </a:solidFill>
-                <a:latin typeface="Arial"/>
-                <a:ea typeface="Arial"/>
-                <a:cs typeface="Arial"/>
-              </a:rPr>
-              <a:t> </a:t>
-            </a:r>
-            <a:r>
-              <a:rPr sz="1125" b="0" i="0" dirty="0" err="1">
-                <a:solidFill>
-                  <a:srgbClr val="1F3864"/>
-                </a:solidFill>
-                <a:latin typeface="Arial"/>
-                <a:ea typeface="Arial"/>
-                <a:cs typeface="Arial"/>
-              </a:rPr>
-              <a:t>actuales</a:t>
-            </a:r>
-            <a:r>
-              <a:rPr sz="1125" b="0" i="0" dirty="0">
-                <a:solidFill>
-                  <a:srgbClr val="1F3864"/>
-                </a:solidFill>
-                <a:latin typeface="Arial"/>
-                <a:ea typeface="Arial"/>
-                <a:cs typeface="Arial"/>
-              </a:rPr>
-              <a:t>, </a:t>
-            </a:r>
-            <a:r>
-              <a:rPr sz="1125" b="0" i="0" dirty="0" err="1">
-                <a:solidFill>
-                  <a:srgbClr val="1F3864"/>
-                </a:solidFill>
-                <a:latin typeface="Arial"/>
-                <a:ea typeface="Arial"/>
-                <a:cs typeface="Arial"/>
-              </a:rPr>
-              <a:t>desviación</a:t>
-            </a:r>
-            <a:r>
-              <a:rPr sz="1125" b="0" i="0" dirty="0">
-                <a:solidFill>
-                  <a:srgbClr val="1F3864"/>
-                </a:solidFill>
-                <a:latin typeface="Arial"/>
-                <a:ea typeface="Arial"/>
-                <a:cs typeface="Arial"/>
-              </a:rPr>
-              <a:t> actual y dos </a:t>
-            </a:r>
-            <a:r>
-              <a:rPr sz="1125" b="0" i="0" dirty="0" err="1">
-                <a:solidFill>
-                  <a:srgbClr val="1F3864"/>
-                </a:solidFill>
-                <a:latin typeface="Arial"/>
-                <a:ea typeface="Arial"/>
-                <a:cs typeface="Arial"/>
-              </a:rPr>
-              <a:t>antecedentes</a:t>
-            </a:r>
-            <a:r>
-              <a:rPr sz="1125" b="0" i="0" dirty="0">
-                <a:solidFill>
-                  <a:srgbClr val="1F3864"/>
-                </a:solidFill>
-                <a:latin typeface="Arial"/>
-                <a:ea typeface="Arial"/>
-                <a:cs typeface="Arial"/>
-              </a:rPr>
-              <a:t> </a:t>
-            </a:r>
-            <a:r>
-              <a:rPr sz="1125" b="0" i="0" dirty="0" err="1">
-                <a:solidFill>
-                  <a:srgbClr val="1F3864"/>
-                </a:solidFill>
-                <a:latin typeface="Arial"/>
-                <a:ea typeface="Arial"/>
-                <a:cs typeface="Arial"/>
-              </a:rPr>
-              <a:t>térmicos</a:t>
-            </a:r>
-            <a:endParaRPr sz="1125" b="0" i="0" dirty="0">
-              <a:solidFill>
-                <a:srgbClr val="1F3864"/>
-              </a:solidFill>
-              <a:latin typeface="Arial"/>
-              <a:ea typeface="Arial"/>
-              <a:cs typeface="Arial"/>
-            </a:endParaRPr>
+              <a:rPr sz="1125" b="0" i="0">
+                <a:solidFill>
+                  <a:srgbClr val="1F3864"/>
+                </a:solidFill>
+                <a:latin typeface="Arial"/>
+                <a:ea typeface="Arial"/>
+                <a:cs typeface="Arial"/>
+              </a:rPr>
+              <a:t>Temperatura y humedad actuales, desviación actual y dos antecedentes térmicos</a:t>
+            </a:r>
           </a:p>
         </p:txBody>
       </p:sp>
@@ -7938,7 +7355,7 @@
         </p:nvSpPr>
         <p:spPr>
           <a:xfrm>
-            <a:off x="4686300" y="5375148"/>
+            <a:off x="4686300" y="5342168"/>
             <a:ext cx="2000250" cy="200025"/>
           </a:xfrm>
           <a:prstGeom prst="rect">
@@ -8026,8 +7443,8 @@
         </p:nvSpPr>
         <p:spPr>
           <a:xfrm>
-            <a:off x="4686300" y="5567553"/>
-            <a:ext cx="6457950" cy="266700"/>
+            <a:off x="4686300" y="5580293"/>
+            <a:ext cx="6334125" cy="266700"/>
           </a:xfrm>
           <a:prstGeom prst="rect">
             <a:avLst/>
@@ -8063,7 +7480,7 @@
                 <a:ea typeface="Arial"/>
                 <a:cs typeface="Arial"/>
               </a:rPr>
-              <a:t>25797 </a:t>
+              <a:t>25.797 </a:t>
             </a:r>
             <a:r>
               <a:rPr sz="1200" b="0" i="0" dirty="0" err="1">
@@ -8129,7 +7546,7 @@
                 <a:ea typeface="Arial"/>
                 <a:cs typeface="Arial"/>
               </a:rPr>
-              <a:t> 2668 sin </a:t>
+              <a:t> 2.668 sin </a:t>
             </a:r>
             <a:r>
               <a:rPr sz="1200" b="0" i="0" dirty="0" err="1">
@@ -9151,7 +8568,7 @@
               </a:defRPr>
             </a:pPr>
             <a:r>
-              <a:rPr sz="900" b="1" i="0" dirty="0">
+              <a:rPr sz="900" b="1" i="0">
                 <a:solidFill>
                   <a:srgbClr val="2E5B8A"/>
                 </a:solidFill>
@@ -9209,37 +8626,15 @@
               </a:defRPr>
             </a:pPr>
             <a:r>
-              <a:rPr sz="1575" b="1" i="0" dirty="0">
-                <a:solidFill>
-                  <a:srgbClr val="1F3864"/>
-                </a:solidFill>
-                <a:latin typeface="Arial"/>
-                <a:ea typeface="Arial"/>
-                <a:cs typeface="Arial"/>
-              </a:rPr>
-              <a:t>28.920 </a:t>
-            </a:r>
-            <a:r>
-              <a:rPr sz="1575" b="1" i="0" dirty="0" err="1">
-                <a:solidFill>
-                  <a:srgbClr val="1F3864"/>
-                </a:solidFill>
-                <a:latin typeface="Arial"/>
-                <a:ea typeface="Arial"/>
-                <a:cs typeface="Arial"/>
-              </a:rPr>
-              <a:t>lecturas</a:t>
-            </a:r>
-            <a:r>
-              <a:rPr sz="1575" b="1" i="0" dirty="0">
-                <a:solidFill>
-                  <a:srgbClr val="1F3864"/>
-                </a:solidFill>
-                <a:latin typeface="Arial"/>
-                <a:ea typeface="Arial"/>
-                <a:cs typeface="Arial"/>
-              </a:rPr>
-              <a:t> Bronze</a:t>
+              <a:rPr sz="1575" b="1" i="0">
+                <a:solidFill>
+                  <a:srgbClr val="1F3864"/>
+                </a:solidFill>
+                <a:latin typeface="Arial"/>
+                <a:ea typeface="Arial"/>
+                <a:cs typeface="Arial"/>
+              </a:rPr>
+              <a:t>28.920 lecturas Bronze</a:t>
             </a:r>
           </a:p>
         </p:txBody>
@@ -9329,35 +8724,16 @@
               </a:defRPr>
             </a:pPr>
             <a:r>
-              <a:rPr sz="1425" b="1" i="0" dirty="0">
-                <a:solidFill>
-                  <a:srgbClr val="1F3864"/>
-                </a:solidFill>
-                <a:latin typeface="Arial"/>
-                <a:ea typeface="Arial"/>
-                <a:cs typeface="Arial"/>
-              </a:rPr>
-              <a:t>Fuentes y </a:t>
-            </a:r>
-            <a:r>
-              <a:rPr sz="1425" b="1" i="0" dirty="0" err="1">
-                <a:solidFill>
-                  <a:srgbClr val="1F3864"/>
-                </a:solidFill>
-                <a:latin typeface="Arial"/>
-                <a:ea typeface="Arial"/>
-                <a:cs typeface="Arial"/>
-              </a:rPr>
-              <a:t>alcance</a:t>
-            </a:r>
-            <a:endParaRPr sz="1425" b="1" i="0" dirty="0">
-              <a:solidFill>
-                <a:srgbClr val="1F3864"/>
-              </a:solidFill>
-              <a:latin typeface="Arial"/>
-              <a:ea typeface="Arial"/>
-              <a:cs typeface="Arial"/>
-            </a:endParaRPr>
+              <a:rPr sz="1425" b="1" i="0">
+                <a:solidFill>
+                  <a:srgbClr val="1F3864"/>
+                </a:solidFill>
+                <a:latin typeface="Arial"/>
+                <a:ea typeface="Arial"/>
+                <a:cs typeface="Arial"/>
+              </a:rPr>
+              <a:t>Fuentes y alcance</a:t>
+            </a:r>
           </a:p>
         </p:txBody>
       </p:sp>
@@ -9406,57 +8782,16 @@
               </a:defRPr>
             </a:pPr>
             <a:r>
-              <a:rPr sz="1275" b="0" i="0" dirty="0">
-                <a:solidFill>
-                  <a:srgbClr val="1F3864"/>
-                </a:solidFill>
-                <a:latin typeface="Arial"/>
-                <a:ea typeface="Arial"/>
-                <a:cs typeface="Arial"/>
-              </a:rPr>
-              <a:t>• Fuente: </a:t>
-            </a:r>
-            <a:r>
-              <a:rPr sz="1275" b="0" i="0" dirty="0" err="1">
-                <a:solidFill>
-                  <a:srgbClr val="1F3864"/>
-                </a:solidFill>
-                <a:latin typeface="Arial"/>
-                <a:ea typeface="Arial"/>
-                <a:cs typeface="Arial"/>
-              </a:rPr>
-              <a:t>telemetría</a:t>
-            </a:r>
-            <a:r>
-              <a:rPr sz="1275" b="0" i="0" dirty="0">
-                <a:solidFill>
-                  <a:srgbClr val="1F3864"/>
-                </a:solidFill>
-                <a:latin typeface="Arial"/>
-                <a:ea typeface="Arial"/>
-                <a:cs typeface="Arial"/>
-              </a:rPr>
-              <a:t> IoT de </a:t>
-            </a:r>
-            <a:r>
-              <a:rPr sz="1275" b="0" i="0" dirty="0" err="1">
-                <a:solidFill>
-                  <a:srgbClr val="1F3864"/>
-                </a:solidFill>
-                <a:latin typeface="Arial"/>
-                <a:ea typeface="Arial"/>
-                <a:cs typeface="Arial"/>
-              </a:rPr>
-              <a:t>AndinaLog</a:t>
-            </a:r>
-            <a:endParaRPr sz="1275" b="0" i="0" dirty="0">
-              <a:solidFill>
-                <a:srgbClr val="1F3864"/>
-              </a:solidFill>
-              <a:latin typeface="Arial"/>
-              <a:ea typeface="Arial"/>
-              <a:cs typeface="Arial"/>
-            </a:endParaRPr>
+              <a:rPr sz="1275" b="0" i="0">
+                <a:solidFill>
+                  <a:srgbClr val="1F3864"/>
+                </a:solidFill>
+                <a:latin typeface="Arial"/>
+                <a:ea typeface="Arial"/>
+                <a:cs typeface="Arial"/>
+              </a:rPr>
+              <a:t>• Fuente: telemetría IoT de AndinaLog</a:t>
+            </a:r>
           </a:p>
           <a:p>
             <a:pPr algn="l">
@@ -9471,101 +8806,16 @@
               </a:defRPr>
             </a:pPr>
             <a:r>
-              <a:rPr sz="1275" b="0" i="0" dirty="0">
-                <a:solidFill>
-                  <a:srgbClr val="1F3864"/>
-                </a:solidFill>
-                <a:latin typeface="Arial"/>
-                <a:ea typeface="Arial"/>
-                <a:cs typeface="Arial"/>
-              </a:rPr>
-              <a:t>• Una </a:t>
-            </a:r>
-            <a:r>
-              <a:rPr sz="1275" b="0" i="0" dirty="0" err="1">
-                <a:solidFill>
-                  <a:srgbClr val="1F3864"/>
-                </a:solidFill>
-                <a:latin typeface="Arial"/>
-                <a:ea typeface="Arial"/>
-                <a:cs typeface="Arial"/>
-              </a:rPr>
-              <a:t>lectura</a:t>
-            </a:r>
-            <a:r>
-              <a:rPr sz="1275" b="0" i="0" dirty="0">
-                <a:solidFill>
-                  <a:srgbClr val="1F3864"/>
-                </a:solidFill>
-                <a:latin typeface="Arial"/>
-                <a:ea typeface="Arial"/>
-                <a:cs typeface="Arial"/>
-              </a:rPr>
-              <a:t> </a:t>
-            </a:r>
-            <a:r>
-              <a:rPr sz="1275" b="0" i="0" dirty="0" err="1">
-                <a:solidFill>
-                  <a:srgbClr val="1F3864"/>
-                </a:solidFill>
-                <a:latin typeface="Arial"/>
-                <a:ea typeface="Arial"/>
-                <a:cs typeface="Arial"/>
-              </a:rPr>
-              <a:t>por</a:t>
-            </a:r>
-            <a:r>
-              <a:rPr sz="1275" b="0" i="0" dirty="0">
-                <a:solidFill>
-                  <a:srgbClr val="1F3864"/>
-                </a:solidFill>
-                <a:latin typeface="Arial"/>
-                <a:ea typeface="Arial"/>
-                <a:cs typeface="Arial"/>
-              </a:rPr>
-              <a:t> </a:t>
-            </a:r>
-            <a:r>
-              <a:rPr sz="1275" b="0" i="0" dirty="0" err="1">
-                <a:solidFill>
-                  <a:srgbClr val="1F3864"/>
-                </a:solidFill>
-                <a:latin typeface="Arial"/>
-                <a:ea typeface="Arial"/>
-                <a:cs typeface="Arial"/>
-              </a:rPr>
-              <a:t>viaje</a:t>
-            </a:r>
-            <a:r>
-              <a:rPr sz="1275" b="0" i="0" dirty="0">
-                <a:solidFill>
-                  <a:srgbClr val="1F3864"/>
-                </a:solidFill>
-                <a:latin typeface="Arial"/>
-                <a:ea typeface="Arial"/>
-                <a:cs typeface="Arial"/>
-              </a:rPr>
-              <a:t> y </a:t>
-            </a:r>
-            <a:r>
-              <a:rPr sz="1275" b="0" i="0" dirty="0" err="1">
-                <a:solidFill>
-                  <a:srgbClr val="1F3864"/>
-                </a:solidFill>
-                <a:latin typeface="Arial"/>
-                <a:ea typeface="Arial"/>
-                <a:cs typeface="Arial"/>
-              </a:rPr>
-              <a:t>momento</a:t>
-            </a:r>
-            <a:endParaRPr sz="1275" b="0" i="0" dirty="0">
-              <a:solidFill>
-                <a:srgbClr val="1F3864"/>
-              </a:solidFill>
-              <a:latin typeface="Arial"/>
-              <a:ea typeface="Arial"/>
-              <a:cs typeface="Arial"/>
-            </a:endParaRPr>
+              <a:rPr sz="1275" b="0" i="0">
+                <a:solidFill>
+                  <a:srgbClr val="1F3864"/>
+                </a:solidFill>
+                <a:latin typeface="Arial"/>
+                <a:ea typeface="Arial"/>
+                <a:cs typeface="Arial"/>
+              </a:rPr>
+              <a:t>• Una lectura por viaje y momento</a:t>
+            </a:r>
           </a:p>
           <a:p>
             <a:pPr algn="l">
@@ -9580,57 +8830,16 @@
               </a:defRPr>
             </a:pPr>
             <a:r>
-              <a:rPr sz="1275" b="0" i="0" dirty="0">
-                <a:solidFill>
-                  <a:srgbClr val="1F3864"/>
-                </a:solidFill>
-                <a:latin typeface="Arial"/>
-                <a:ea typeface="Arial"/>
-                <a:cs typeface="Arial"/>
-              </a:rPr>
-              <a:t>• 1.200 </a:t>
-            </a:r>
-            <a:r>
-              <a:rPr sz="1275" b="0" i="0" dirty="0" err="1">
-                <a:solidFill>
-                  <a:srgbClr val="1F3864"/>
-                </a:solidFill>
-                <a:latin typeface="Arial"/>
-                <a:ea typeface="Arial"/>
-                <a:cs typeface="Arial"/>
-              </a:rPr>
-              <a:t>viajes</a:t>
-            </a:r>
-            <a:r>
-              <a:rPr sz="1275" b="0" i="0" dirty="0">
-                <a:solidFill>
-                  <a:srgbClr val="1F3864"/>
-                </a:solidFill>
-                <a:latin typeface="Arial"/>
-                <a:ea typeface="Arial"/>
-                <a:cs typeface="Arial"/>
-              </a:rPr>
-              <a:t> </a:t>
-            </a:r>
-            <a:r>
-              <a:rPr sz="1275" b="0" i="0" dirty="0" err="1">
-                <a:solidFill>
-                  <a:srgbClr val="1F3864"/>
-                </a:solidFill>
-                <a:latin typeface="Arial"/>
-                <a:ea typeface="Arial"/>
-                <a:cs typeface="Arial"/>
-              </a:rPr>
-              <a:t>observados</a:t>
-            </a:r>
-            <a:endParaRPr sz="1275" b="0" i="0" dirty="0">
-              <a:solidFill>
-                <a:srgbClr val="1F3864"/>
-              </a:solidFill>
-              <a:latin typeface="Arial"/>
-              <a:ea typeface="Arial"/>
-              <a:cs typeface="Arial"/>
-            </a:endParaRPr>
+              <a:rPr sz="1275" b="0" i="0">
+                <a:solidFill>
+                  <a:srgbClr val="1F3864"/>
+                </a:solidFill>
+                <a:latin typeface="Arial"/>
+                <a:ea typeface="Arial"/>
+                <a:cs typeface="Arial"/>
+              </a:rPr>
+              <a:t>• 1.200 viajes observados</a:t>
+            </a:r>
           </a:p>
           <a:p>
             <a:pPr algn="l">
@@ -9645,79 +8854,16 @@
               </a:defRPr>
             </a:pPr>
             <a:r>
-              <a:rPr sz="1275" b="0" i="0" dirty="0">
-                <a:solidFill>
-                  <a:srgbClr val="1F3864"/>
-                </a:solidFill>
-                <a:latin typeface="Arial"/>
-                <a:ea typeface="Arial"/>
-                <a:cs typeface="Arial"/>
-              </a:rPr>
-              <a:t>• </a:t>
-            </a:r>
-            <a:r>
-              <a:rPr sz="1275" b="0" i="0" dirty="0" err="1">
-                <a:solidFill>
-                  <a:srgbClr val="1F3864"/>
-                </a:solidFill>
-                <a:latin typeface="Arial"/>
-                <a:ea typeface="Arial"/>
-                <a:cs typeface="Arial"/>
-              </a:rPr>
-              <a:t>Temperatura</a:t>
-            </a:r>
-            <a:r>
-              <a:rPr sz="1275" b="0" i="0" dirty="0">
-                <a:solidFill>
-                  <a:srgbClr val="1F3864"/>
-                </a:solidFill>
-                <a:latin typeface="Arial"/>
-                <a:ea typeface="Arial"/>
-                <a:cs typeface="Arial"/>
-              </a:rPr>
-              <a:t> y </a:t>
-            </a:r>
-            <a:r>
-              <a:rPr sz="1275" b="0" i="0" dirty="0" err="1">
-                <a:solidFill>
-                  <a:srgbClr val="1F3864"/>
-                </a:solidFill>
-                <a:latin typeface="Arial"/>
-                <a:ea typeface="Arial"/>
-                <a:cs typeface="Arial"/>
-              </a:rPr>
-              <a:t>humedad</a:t>
-            </a:r>
-            <a:r>
-              <a:rPr sz="1275" b="0" i="0" dirty="0">
-                <a:solidFill>
-                  <a:srgbClr val="1F3864"/>
-                </a:solidFill>
-                <a:latin typeface="Arial"/>
-                <a:ea typeface="Arial"/>
-                <a:cs typeface="Arial"/>
-              </a:rPr>
-              <a:t> de </a:t>
-            </a:r>
-            <a:r>
-              <a:rPr sz="1275" b="0" i="0" dirty="0" err="1">
-                <a:solidFill>
-                  <a:srgbClr val="1F3864"/>
-                </a:solidFill>
-                <a:latin typeface="Arial"/>
-                <a:ea typeface="Arial"/>
-                <a:cs typeface="Arial"/>
-              </a:rPr>
-              <a:t>cabina</a:t>
-            </a:r>
-            <a:endParaRPr sz="1275" b="0" i="0" dirty="0">
-              <a:solidFill>
-                <a:srgbClr val="1F3864"/>
-              </a:solidFill>
-              <a:latin typeface="Arial"/>
-              <a:ea typeface="Arial"/>
-              <a:cs typeface="Arial"/>
-            </a:endParaRPr>
+              <a:rPr sz="1275" b="0" i="0">
+                <a:solidFill>
+                  <a:srgbClr val="1F3864"/>
+                </a:solidFill>
+                <a:latin typeface="Arial"/>
+                <a:ea typeface="Arial"/>
+                <a:cs typeface="Arial"/>
+              </a:rPr>
+              <a:t>• Temperatura y humedad de cabina</a:t>
+            </a:r>
           </a:p>
           <a:p>
             <a:pPr algn="l">
@@ -9732,101 +8878,16 @@
               </a:defRPr>
             </a:pPr>
             <a:r>
-              <a:rPr sz="1275" b="0" i="0" dirty="0">
-                <a:solidFill>
-                  <a:srgbClr val="1F3864"/>
-                </a:solidFill>
-                <a:latin typeface="Arial"/>
-                <a:ea typeface="Arial"/>
-                <a:cs typeface="Arial"/>
-              </a:rPr>
-              <a:t>• </a:t>
-            </a:r>
-            <a:r>
-              <a:rPr sz="1275" b="0" i="0" dirty="0" err="1">
-                <a:solidFill>
-                  <a:srgbClr val="1F3864"/>
-                </a:solidFill>
-                <a:latin typeface="Arial"/>
-                <a:ea typeface="Arial"/>
-                <a:cs typeface="Arial"/>
-              </a:rPr>
-              <a:t>Identificadores</a:t>
-            </a:r>
-            <a:r>
-              <a:rPr sz="1275" b="0" i="0" dirty="0">
-                <a:solidFill>
-                  <a:srgbClr val="1F3864"/>
-                </a:solidFill>
-                <a:latin typeface="Arial"/>
-                <a:ea typeface="Arial"/>
-                <a:cs typeface="Arial"/>
-              </a:rPr>
-              <a:t> </a:t>
-            </a:r>
-            <a:r>
-              <a:rPr sz="1275" b="0" i="0" dirty="0" err="1">
-                <a:solidFill>
-                  <a:srgbClr val="1F3864"/>
-                </a:solidFill>
-                <a:latin typeface="Arial"/>
-                <a:ea typeface="Arial"/>
-                <a:cs typeface="Arial"/>
-              </a:rPr>
-              <a:t>operativos</a:t>
-            </a:r>
-            <a:r>
-              <a:rPr sz="1275" b="0" i="0" dirty="0">
-                <a:solidFill>
-                  <a:srgbClr val="1F3864"/>
-                </a:solidFill>
-                <a:latin typeface="Arial"/>
-                <a:ea typeface="Arial"/>
-                <a:cs typeface="Arial"/>
-              </a:rPr>
-              <a:t>, sin </a:t>
-            </a:r>
-            <a:r>
-              <a:rPr sz="1275" b="0" i="0" dirty="0" err="1">
-                <a:solidFill>
-                  <a:srgbClr val="1F3864"/>
-                </a:solidFill>
-                <a:latin typeface="Arial"/>
-                <a:ea typeface="Arial"/>
-                <a:cs typeface="Arial"/>
-              </a:rPr>
-              <a:t>nombres</a:t>
-            </a:r>
-            <a:r>
-              <a:rPr sz="1275" b="0" i="0" dirty="0">
-                <a:solidFill>
-                  <a:srgbClr val="1F3864"/>
-                </a:solidFill>
-                <a:latin typeface="Arial"/>
-                <a:ea typeface="Arial"/>
-                <a:cs typeface="Arial"/>
-              </a:rPr>
-              <a:t> </a:t>
-            </a:r>
-            <a:r>
-              <a:rPr sz="1275" b="0" i="0" dirty="0" err="1">
-                <a:solidFill>
-                  <a:srgbClr val="1F3864"/>
-                </a:solidFill>
-                <a:latin typeface="Arial"/>
-                <a:ea typeface="Arial"/>
-                <a:cs typeface="Arial"/>
-              </a:rPr>
-              <a:t>personales</a:t>
-            </a:r>
-            <a:endParaRPr sz="1275" b="0" i="0" dirty="0">
-              <a:solidFill>
-                <a:srgbClr val="1F3864"/>
-              </a:solidFill>
-              <a:latin typeface="Arial"/>
-              <a:ea typeface="Arial"/>
-              <a:cs typeface="Arial"/>
-            </a:endParaRPr>
+              <a:rPr sz="1275" b="0" i="0">
+                <a:solidFill>
+                  <a:srgbClr val="1F3864"/>
+                </a:solidFill>
+                <a:latin typeface="Arial"/>
+                <a:ea typeface="Arial"/>
+                <a:cs typeface="Arial"/>
+              </a:rPr>
+              <a:t>• Identificadores operativos, sin nombres personales</a:t>
+            </a:r>
           </a:p>
         </p:txBody>
       </p:sp>
@@ -9888,7 +8949,7 @@
         </p:nvSpPr>
         <p:spPr>
           <a:xfrm>
-            <a:off x="914400" y="5133975"/>
+            <a:off x="914400" y="5076827"/>
             <a:ext cx="3048000" cy="209550"/>
           </a:xfrm>
           <a:prstGeom prst="rect">
@@ -10086,7 +9147,7 @@
                     <a:lstStyle/>
                     <a:p>
                       <a:r>
-                        <a:rPr sz="1050" dirty="0" err="1">
+                        <a:rPr sz="1050">
                           <a:solidFill>
                             <a:srgbClr val="1F3864"/>
                           </a:solidFill>
@@ -10096,14 +9157,6 @@
                         </a:rPr>
                         <a:t>Faltantes</a:t>
                       </a:r>
-                      <a:endParaRPr sz="1050" dirty="0">
-                        <a:solidFill>
-                          <a:srgbClr val="1F3864"/>
-                        </a:solidFill>
-                        <a:latin typeface="Arial"/>
-                        <a:ea typeface="Arial"/>
-                        <a:cs typeface="Arial"/>
-                      </a:endParaRPr>
                     </a:p>
                   </a:txBody>
                   <a:tcPr marL="95250" marR="95250" marT="66675" marB="66675" anchor="ctr">
@@ -10276,7 +9329,7 @@
                     <a:lstStyle/>
                     <a:p>
                       <a:r>
-                        <a:rPr sz="1050" dirty="0">
+                        <a:rPr sz="1050">
                           <a:solidFill>
                             <a:srgbClr val="1F3864"/>
                           </a:solidFill>
@@ -10284,71 +9337,8 @@
                           <a:ea typeface="Arial"/>
                           <a:cs typeface="Arial"/>
                         </a:rPr>
-                        <a:t>120 </a:t>
+                        <a:t>120 valores -999; 15 fechas; 15 humedades</a:t>
                       </a:r>
-                      <a:r>
-                        <a:rPr sz="1050" dirty="0" err="1">
-                          <a:solidFill>
-                            <a:srgbClr val="1F3864"/>
-                          </a:solidFill>
-                          <a:latin typeface="Arial"/>
-                          <a:ea typeface="Arial"/>
-                          <a:cs typeface="Arial"/>
-                        </a:rPr>
-                        <a:t>valores</a:t>
-                      </a:r>
-                      <a:r>
-                        <a:rPr sz="1050" dirty="0">
-                          <a:solidFill>
-                            <a:srgbClr val="1F3864"/>
-                          </a:solidFill>
-                          <a:latin typeface="Arial"/>
-                          <a:ea typeface="Arial"/>
-                          <a:cs typeface="Arial"/>
-                        </a:rPr>
-                        <a:t> -999; 15 </a:t>
-                      </a:r>
-                      <a:r>
-                        <a:rPr sz="1050" dirty="0" err="1">
-                          <a:solidFill>
-                            <a:srgbClr val="1F3864"/>
-                          </a:solidFill>
-                          <a:latin typeface="Arial"/>
-                          <a:ea typeface="Arial"/>
-                          <a:cs typeface="Arial"/>
-                        </a:rPr>
-                        <a:t>fechas</a:t>
-                      </a:r>
-                      <a:r>
-                        <a:rPr sz="1050" dirty="0">
-                          <a:solidFill>
-                            <a:srgbClr val="1F3864"/>
-                          </a:solidFill>
-                          <a:latin typeface="Arial"/>
-                          <a:ea typeface="Arial"/>
-                          <a:cs typeface="Arial"/>
-                        </a:rPr>
-                        <a:t>; 15 </a:t>
-                      </a:r>
-                      <a:r>
-                        <a:rPr sz="1050" dirty="0" err="1">
-                          <a:solidFill>
-                            <a:srgbClr val="1F3864"/>
-                          </a:solidFill>
-                          <a:latin typeface="Arial"/>
-                          <a:ea typeface="Arial"/>
-                          <a:cs typeface="Arial"/>
-                        </a:rPr>
-                        <a:t>humedades</a:t>
-                      </a:r>
-                      <a:endParaRPr sz="1050" dirty="0">
-                        <a:solidFill>
-                          <a:srgbClr val="1F3864"/>
-                        </a:solidFill>
-                        <a:latin typeface="Arial"/>
-                        <a:ea typeface="Arial"/>
-                        <a:cs typeface="Arial"/>
-                      </a:endParaRPr>
                     </a:p>
                   </a:txBody>
                   <a:tcPr marL="95250" marR="95250" marT="66675" marB="66675" anchor="ctr">
@@ -10363,7 +9353,7 @@
                     <a:lstStyle/>
                     <a:p>
                       <a:r>
-                        <a:rPr sz="1050" dirty="0" err="1">
+                        <a:rPr sz="1050">
                           <a:solidFill>
                             <a:srgbClr val="1F3864"/>
                           </a:solidFill>
@@ -10371,84 +9361,7 @@
                           <a:ea typeface="Arial"/>
                           <a:cs typeface="Arial"/>
                         </a:rPr>
-                        <a:t>Convertir</a:t>
-                      </a:r>
-                      <a:r>
-                        <a:rPr sz="1050" dirty="0">
-                          <a:solidFill>
-                            <a:srgbClr val="1F3864"/>
-                          </a:solidFill>
-                          <a:latin typeface="Arial"/>
-                          <a:ea typeface="Arial"/>
-                          <a:cs typeface="Arial"/>
-                        </a:rPr>
-                        <a:t> </a:t>
-                      </a:r>
-                      <a:r>
-                        <a:rPr sz="1050" dirty="0" err="1">
-                          <a:solidFill>
-                            <a:srgbClr val="1F3864"/>
-                          </a:solidFill>
-                          <a:latin typeface="Arial"/>
-                          <a:ea typeface="Arial"/>
-                          <a:cs typeface="Arial"/>
-                        </a:rPr>
-                        <a:t>unidades</a:t>
-                      </a:r>
-                      <a:r>
-                        <a:rPr sz="1050" dirty="0">
-                          <a:solidFill>
-                            <a:srgbClr val="1F3864"/>
-                          </a:solidFill>
-                          <a:latin typeface="Arial"/>
-                          <a:ea typeface="Arial"/>
-                          <a:cs typeface="Arial"/>
-                        </a:rPr>
-                        <a:t> </a:t>
-                      </a:r>
-                      <a:r>
-                        <a:rPr sz="1050" dirty="0" err="1">
-                          <a:solidFill>
-                            <a:srgbClr val="1F3864"/>
-                          </a:solidFill>
-                          <a:latin typeface="Arial"/>
-                          <a:ea typeface="Arial"/>
-                          <a:cs typeface="Arial"/>
-                        </a:rPr>
-                        <a:t>seguras</a:t>
-                      </a:r>
-                      <a:r>
-                        <a:rPr sz="1050" dirty="0">
-                          <a:solidFill>
-                            <a:srgbClr val="1F3864"/>
-                          </a:solidFill>
-                          <a:latin typeface="Arial"/>
-                          <a:ea typeface="Arial"/>
-                          <a:cs typeface="Arial"/>
-                        </a:rPr>
-                        <a:t>; </a:t>
-                      </a:r>
-                      <a:r>
-                        <a:rPr sz="1050" dirty="0" err="1">
-                          <a:solidFill>
-                            <a:srgbClr val="1F3864"/>
-                          </a:solidFill>
-                          <a:latin typeface="Arial"/>
-                          <a:ea typeface="Arial"/>
-                          <a:cs typeface="Arial"/>
-                        </a:rPr>
-                        <a:t>cuarentena</a:t>
-                      </a:r>
-                      <a:r>
-                        <a:rPr sz="1050" dirty="0">
-                          <a:solidFill>
-                            <a:srgbClr val="1F3864"/>
-                          </a:solidFill>
-                          <a:latin typeface="Arial"/>
-                          <a:ea typeface="Arial"/>
-                          <a:cs typeface="Arial"/>
-                        </a:rPr>
-                        <a:t> del resto</a:t>
+                        <a:t>Convertir unidades seguras; cuarentena del resto</a:t>
                       </a:r>
                     </a:p>
                   </a:txBody>
@@ -10519,7 +9432,7 @@
                     <a:lstStyle/>
                     <a:p>
                       <a:r>
-                        <a:rPr sz="1050" dirty="0" err="1">
+                        <a:rPr sz="1050">
                           <a:solidFill>
                             <a:srgbClr val="1F3864"/>
                           </a:solidFill>
@@ -10527,104 +9440,8 @@
                           <a:ea typeface="Arial"/>
                           <a:cs typeface="Arial"/>
                         </a:rPr>
-                        <a:t>Conservar</a:t>
+                        <a:t>Conservar en Gold; excluir del objetivo y modelo</a:t>
                       </a:r>
-                      <a:r>
-                        <a:rPr sz="1050" dirty="0">
-                          <a:solidFill>
-                            <a:srgbClr val="1F3864"/>
-                          </a:solidFill>
-                          <a:latin typeface="Arial"/>
-                          <a:ea typeface="Arial"/>
-                          <a:cs typeface="Arial"/>
-                        </a:rPr>
-                        <a:t> </a:t>
-                      </a:r>
-                      <a:r>
-                        <a:rPr sz="1050" dirty="0" err="1">
-                          <a:solidFill>
-                            <a:srgbClr val="1F3864"/>
-                          </a:solidFill>
-                          <a:latin typeface="Arial"/>
-                          <a:ea typeface="Arial"/>
-                          <a:cs typeface="Arial"/>
-                        </a:rPr>
-                        <a:t>en</a:t>
-                      </a:r>
-                      <a:r>
-                        <a:rPr sz="1050" dirty="0">
-                          <a:solidFill>
-                            <a:srgbClr val="1F3864"/>
-                          </a:solidFill>
-                          <a:latin typeface="Arial"/>
-                          <a:ea typeface="Arial"/>
-                          <a:cs typeface="Arial"/>
-                        </a:rPr>
-                        <a:t> Gold; </a:t>
-                      </a:r>
-                      <a:r>
-                        <a:rPr sz="1050" dirty="0" err="1">
-                          <a:solidFill>
-                            <a:srgbClr val="1F3864"/>
-                          </a:solidFill>
-                          <a:latin typeface="Arial"/>
-                          <a:ea typeface="Arial"/>
-                          <a:cs typeface="Arial"/>
-                        </a:rPr>
-                        <a:t>excluir</a:t>
-                      </a:r>
-                      <a:r>
-                        <a:rPr sz="1050" dirty="0">
-                          <a:solidFill>
-                            <a:srgbClr val="1F3864"/>
-                          </a:solidFill>
-                          <a:latin typeface="Arial"/>
-                          <a:ea typeface="Arial"/>
-                          <a:cs typeface="Arial"/>
-                        </a:rPr>
-                        <a:t> del </a:t>
-                      </a:r>
-                      <a:r>
-                        <a:rPr sz="1050" dirty="0" err="1">
-                          <a:solidFill>
-                            <a:srgbClr val="1F3864"/>
-                          </a:solidFill>
-                          <a:latin typeface="Arial"/>
-                          <a:ea typeface="Arial"/>
-                          <a:cs typeface="Arial"/>
-                        </a:rPr>
-                        <a:t>objetivo</a:t>
-                      </a:r>
-                      <a:r>
-                        <a:rPr sz="1050" dirty="0">
-                          <a:solidFill>
-                            <a:srgbClr val="1F3864"/>
-                          </a:solidFill>
-                          <a:latin typeface="Arial"/>
-                          <a:ea typeface="Arial"/>
-                          <a:cs typeface="Arial"/>
-                        </a:rPr>
-                        <a:t> y </a:t>
-                      </a:r>
-                      <a:r>
-                        <a:rPr sz="1050" dirty="0" err="1">
-                          <a:solidFill>
-                            <a:srgbClr val="1F3864"/>
-                          </a:solidFill>
-                          <a:latin typeface="Arial"/>
-                          <a:ea typeface="Arial"/>
-                          <a:cs typeface="Arial"/>
-                        </a:rPr>
-                        <a:t>modelo</a:t>
-                      </a:r>
-                      <a:endParaRPr sz="1050" dirty="0">
-                        <a:solidFill>
-                          <a:srgbClr val="1F3864"/>
-                        </a:solidFill>
-                        <a:latin typeface="Arial"/>
-                        <a:ea typeface="Arial"/>
-                        <a:cs typeface="Arial"/>
-                      </a:endParaRPr>
                     </a:p>
                   </a:txBody>
                   <a:tcPr marL="95250" marR="95250" marT="66675" marB="66675" anchor="ctr">
@@ -11336,35 +10153,16 @@
               </a:defRPr>
             </a:pPr>
             <a:r>
-              <a:rPr sz="1200" b="1" i="0" dirty="0">
-                <a:solidFill>
-                  <a:srgbClr val="1F3864"/>
-                </a:solidFill>
-                <a:latin typeface="Arial"/>
-                <a:ea typeface="Arial"/>
-                <a:cs typeface="Arial"/>
-              </a:rPr>
-              <a:t>Dato </a:t>
-            </a:r>
-            <a:r>
-              <a:rPr sz="1200" b="1" i="0" dirty="0" err="1">
-                <a:solidFill>
-                  <a:srgbClr val="1F3864"/>
-                </a:solidFill>
-                <a:latin typeface="Arial"/>
-                <a:ea typeface="Arial"/>
-                <a:cs typeface="Arial"/>
-              </a:rPr>
-              <a:t>recibido</a:t>
-            </a:r>
-            <a:endParaRPr sz="1200" b="1" i="0" dirty="0">
-              <a:solidFill>
-                <a:srgbClr val="1F3864"/>
-              </a:solidFill>
-              <a:latin typeface="Arial"/>
-              <a:ea typeface="Arial"/>
-              <a:cs typeface="Arial"/>
-            </a:endParaRPr>
+              <a:rPr sz="1200" b="1" i="0">
+                <a:solidFill>
+                  <a:srgbClr val="1F3864"/>
+                </a:solidFill>
+                <a:latin typeface="Arial"/>
+                <a:ea typeface="Arial"/>
+                <a:cs typeface="Arial"/>
+              </a:rPr>
+              <a:t>Dato recibido</a:t>
+            </a:r>
           </a:p>
         </p:txBody>
       </p:sp>
@@ -11493,7 +10291,7 @@
               </a:defRPr>
             </a:pPr>
             <a:r>
-              <a:rPr sz="900" b="1" i="0" dirty="0">
+              <a:rPr sz="900" b="1" i="0">
                 <a:solidFill>
                   <a:srgbClr val="2E5B8A"/>
                 </a:solidFill>
@@ -11689,7 +10487,7 @@
               </a:defRPr>
             </a:pPr>
             <a:r>
-              <a:rPr sz="900" b="1" i="0" dirty="0">
+              <a:rPr sz="900" b="1" i="0">
                 <a:solidFill>
                   <a:srgbClr val="2E5B8A"/>
                 </a:solidFill>
@@ -11747,57 +10545,16 @@
               </a:defRPr>
             </a:pPr>
             <a:r>
-              <a:rPr sz="1200" b="1" i="0" dirty="0">
-                <a:solidFill>
-                  <a:srgbClr val="1F3864"/>
-                </a:solidFill>
-                <a:latin typeface="Arial"/>
-                <a:ea typeface="Arial"/>
-                <a:cs typeface="Arial"/>
-              </a:rPr>
-              <a:t>Variables y </a:t>
-            </a:r>
-            <a:r>
-              <a:rPr sz="1200" b="1" i="0" dirty="0" err="1">
-                <a:solidFill>
-                  <a:srgbClr val="1F3864"/>
-                </a:solidFill>
-                <a:latin typeface="Arial"/>
-                <a:ea typeface="Arial"/>
-                <a:cs typeface="Arial"/>
-              </a:rPr>
-              <a:t>objetivo</a:t>
-            </a:r>
-            <a:r>
-              <a:rPr sz="1200" b="1" i="0" dirty="0">
-                <a:solidFill>
-                  <a:srgbClr val="1F3864"/>
-                </a:solidFill>
-                <a:latin typeface="Arial"/>
-                <a:ea typeface="Arial"/>
-                <a:cs typeface="Arial"/>
-              </a:rPr>
-              <a:t> </a:t>
-            </a:r>
-            <a:r>
-              <a:rPr sz="1200" b="1" i="0" dirty="0" err="1">
-                <a:solidFill>
-                  <a:srgbClr val="1F3864"/>
-                </a:solidFill>
-                <a:latin typeface="Arial"/>
-                <a:ea typeface="Arial"/>
-                <a:cs typeface="Arial"/>
-              </a:rPr>
-              <a:t>futuro</a:t>
-            </a:r>
-            <a:endParaRPr sz="1200" b="1" i="0" dirty="0">
-              <a:solidFill>
-                <a:srgbClr val="1F3864"/>
-              </a:solidFill>
-              <a:latin typeface="Arial"/>
-              <a:ea typeface="Arial"/>
-              <a:cs typeface="Arial"/>
-            </a:endParaRPr>
+              <a:rPr sz="1200" b="1" i="0">
+                <a:solidFill>
+                  <a:srgbClr val="1F3864"/>
+                </a:solidFill>
+                <a:latin typeface="Arial"/>
+                <a:ea typeface="Arial"/>
+                <a:cs typeface="Arial"/>
+              </a:rPr>
+              <a:t>Variables y objetivo futuro</a:t>
+            </a:r>
           </a:p>
         </p:txBody>
       </p:sp>
@@ -11940,68 +10697,16 @@
               </a:defRPr>
             </a:pPr>
             <a:r>
-              <a:rPr sz="1275" b="1" i="0" dirty="0" err="1">
-                <a:solidFill>
-                  <a:srgbClr val="1F3864"/>
-                </a:solidFill>
-                <a:latin typeface="Arial"/>
-                <a:ea typeface="Arial"/>
-                <a:cs typeface="Arial"/>
-              </a:rPr>
-              <a:t>Gráfico</a:t>
-            </a:r>
-            <a:r>
-              <a:rPr sz="1275" b="1" i="0" dirty="0">
-                <a:solidFill>
-                  <a:srgbClr val="1F3864"/>
-                </a:solidFill>
-                <a:latin typeface="Arial"/>
-                <a:ea typeface="Arial"/>
-                <a:cs typeface="Arial"/>
-              </a:rPr>
-              <a:t> 1 · </a:t>
-            </a:r>
-            <a:r>
-              <a:rPr sz="1275" b="1" i="0" dirty="0" err="1">
-                <a:solidFill>
-                  <a:srgbClr val="1F3864"/>
-                </a:solidFill>
-                <a:latin typeface="Arial"/>
-                <a:ea typeface="Arial"/>
-                <a:cs typeface="Arial"/>
-              </a:rPr>
-              <a:t>Frecuencia</a:t>
-            </a:r>
-            <a:r>
-              <a:rPr sz="1275" b="1" i="0" dirty="0">
-                <a:solidFill>
-                  <a:srgbClr val="1F3864"/>
-                </a:solidFill>
-                <a:latin typeface="Arial"/>
-                <a:ea typeface="Arial"/>
-                <a:cs typeface="Arial"/>
-              </a:rPr>
-              <a:t> del </a:t>
-            </a:r>
-            <a:r>
-              <a:rPr sz="1275" b="1" i="0" dirty="0" err="1">
-                <a:solidFill>
-                  <a:srgbClr val="1F3864"/>
-                </a:solidFill>
-                <a:latin typeface="Arial"/>
-                <a:ea typeface="Arial"/>
-                <a:cs typeface="Arial"/>
-              </a:rPr>
-              <a:t>objetivo</a:t>
-            </a:r>
-            <a:endParaRPr sz="1275" b="1" i="0" dirty="0">
-              <a:solidFill>
-                <a:srgbClr val="1F3864"/>
-              </a:solidFill>
-              <a:latin typeface="Arial"/>
-              <a:ea typeface="Arial"/>
-              <a:cs typeface="Arial"/>
-            </a:endParaRPr>
+              <a:rPr sz="1275" b="1" i="0">
+                <a:solidFill>
+                  <a:srgbClr val="1F3864"/>
+                </a:solidFill>
+                <a:latin typeface="Arial"/>
+                <a:ea typeface="Arial"/>
+                <a:cs typeface="Arial"/>
+              </a:rPr>
+              <a:t>Gráfico 1 · Frecuencia del objetivo</a:t>
+            </a:r>
           </a:p>
         </p:txBody>
       </p:sp>
@@ -12100,7 +10805,7 @@
                 <a:ea typeface="Arial"/>
                 <a:cs typeface="Arial"/>
               </a:rPr>
-              <a:t>Gráfico 2 · Desviación actual y riesgo futuro</a:t>
+              <a:t>Gráfico 2 · Riesgo por grupo térmico observado</a:t>
             </a:r>
           </a:p>
         </p:txBody>
@@ -12346,6 +11051,409 @@
               </a:defRPr>
             </a:pPr>
             <a:r>
+              <a:rPr sz="1125" b="0" i="0">
+                <a:solidFill>
+                  <a:srgbClr val="1F3864"/>
+                </a:solidFill>
+                <a:latin typeface="Arial"/>
+                <a:ea typeface="Arial"/>
+                <a:cs typeface="Arial"/>
+              </a:rPr>
+              <a:t>Eventos futuros: 5,02%</a:t>
+            </a:r>
+          </a:p>
+        </p:txBody>
+      </p:sp>
+      <p:sp>
+        <p:nvSpPr>
+          <p:cNvPr id="36" name="Rectangle: Rounded Corners 35">
+            <a:extLst>
+              <a:ext uri="{FF2B5EF4-FFF2-40B4-BE49-F238E27FC236}">
+                <a16:creationId xmlns:a16="http://schemas.microsoft.com/office/drawing/2014/main" id="{ECD1CB10-798D-4D7B-A47E-CB354ECB2C32}"/>
+              </a:ext>
+            </a:extLst>
+          </p:cNvPr>
+          <p:cNvSpPr>
+            <a:spLocks noGrp="1"/>
+          </p:cNvSpPr>
+          <p:nvPr/>
+        </p:nvSpPr>
+        <p:spPr>
+          <a:xfrm>
+            <a:off x="4238625" y="5334000"/>
+            <a:ext cx="3429000" cy="628650"/>
+          </a:xfrm>
+          <a:prstGeom prst="roundRect">
+            <a:avLst>
+              <a:gd name="adj" fmla="val 15152"/>
+            </a:avLst>
+          </a:prstGeom>
+          <a:solidFill>
+            <a:srgbClr val="FFFFFF"/>
+          </a:solidFill>
+          <a:ln w="9525">
+            <a:solidFill>
+              <a:srgbClr val="EDF2F7"/>
+            </a:solidFill>
+            <a:prstDash val="solid"/>
+          </a:ln>
+        </p:spPr>
+        <p:txBody>
+          <a:bodyPr/>
+          <a:lstStyle/>
+          <a:p>
+            <a:endParaRPr/>
+          </a:p>
+        </p:txBody>
+      </p:sp>
+      <p:sp>
+        <p:nvSpPr>
+          <p:cNvPr id="37" name="Rectangle 36">
+            <a:extLst>
+              <a:ext uri="{FF2B5EF4-FFF2-40B4-BE49-F238E27FC236}">
+                <a16:creationId xmlns:a16="http://schemas.microsoft.com/office/drawing/2014/main" id="{05C5F7D4-2D47-4300-8E8D-A6702F9BBC31}"/>
+              </a:ext>
+            </a:extLst>
+          </p:cNvPr>
+          <p:cNvSpPr>
+            <a:spLocks noGrp="1"/>
+          </p:cNvSpPr>
+          <p:nvPr/>
+        </p:nvSpPr>
+        <p:spPr>
+          <a:xfrm>
+            <a:off x="4238625" y="5334000"/>
+            <a:ext cx="57150" cy="628650"/>
+          </a:xfrm>
+          <a:prstGeom prst="rect">
+            <a:avLst/>
+          </a:prstGeom>
+          <a:solidFill>
+            <a:srgbClr val="2E5B8A"/>
+          </a:solidFill>
+          <a:ln w="0">
+            <a:noFill/>
+            <a:prstDash val="solid"/>
+          </a:ln>
+        </p:spPr>
+        <p:txBody>
+          <a:bodyPr/>
+          <a:lstStyle/>
+          <a:p>
+            <a:endParaRPr/>
+          </a:p>
+        </p:txBody>
+      </p:sp>
+      <p:sp>
+        <p:nvSpPr>
+          <p:cNvPr id="38" name="Rectangle 37">
+            <a:extLst>
+              <a:ext uri="{FF2B5EF4-FFF2-40B4-BE49-F238E27FC236}">
+                <a16:creationId xmlns:a16="http://schemas.microsoft.com/office/drawing/2014/main" id="{E9CCF00C-1C07-4DFD-A20B-5626FBE5ECE9}"/>
+              </a:ext>
+            </a:extLst>
+          </p:cNvPr>
+          <p:cNvSpPr>
+            <a:spLocks noGrp="1"/>
+          </p:cNvSpPr>
+          <p:nvPr/>
+        </p:nvSpPr>
+        <p:spPr>
+          <a:xfrm>
+            <a:off x="4410075" y="5429250"/>
+            <a:ext cx="3124200" cy="171450"/>
+          </a:xfrm>
+          <a:prstGeom prst="rect">
+            <a:avLst/>
+          </a:prstGeom>
+          <a:noFill/>
+          <a:ln w="0">
+            <a:noFill/>
+          </a:ln>
+        </p:spPr>
+        <p:txBody>
+          <a:bodyPr anchor="t">
+            <a:noAutofit/>
+          </a:bodyPr>
+          <a:lstStyle/>
+          <a:p>
+            <a:pPr algn="l">
+              <a:buNone/>
+              <a:defRPr sz="825" b="1" i="0">
+                <a:solidFill>
+                  <a:srgbClr val="2E5B8A"/>
+                </a:solidFill>
+                <a:latin typeface="Arial"/>
+                <a:ea typeface="Arial"/>
+                <a:cs typeface="Arial"/>
+              </a:defRPr>
+            </a:pPr>
+            <a:r>
+              <a:rPr sz="825" b="1" i="0">
+                <a:solidFill>
+                  <a:srgbClr val="2E5B8A"/>
+                </a:solidFill>
+                <a:latin typeface="Arial"/>
+                <a:ea typeface="Arial"/>
+                <a:cs typeface="Arial"/>
+              </a:rPr>
+              <a:t>2</a:t>
+            </a:r>
+          </a:p>
+        </p:txBody>
+      </p:sp>
+      <p:sp>
+        <p:nvSpPr>
+          <p:cNvPr id="39" name="Rectangle 38">
+            <a:extLst>
+              <a:ext uri="{FF2B5EF4-FFF2-40B4-BE49-F238E27FC236}">
+                <a16:creationId xmlns:a16="http://schemas.microsoft.com/office/drawing/2014/main" id="{82DB381A-0FAF-42AD-A2DC-D0756571892B}"/>
+              </a:ext>
+            </a:extLst>
+          </p:cNvPr>
+          <p:cNvSpPr>
+            <a:spLocks noGrp="1"/>
+          </p:cNvSpPr>
+          <p:nvPr/>
+        </p:nvSpPr>
+        <p:spPr>
+          <a:xfrm>
+            <a:off x="4410075" y="5610225"/>
+            <a:ext cx="3124200" cy="304800"/>
+          </a:xfrm>
+          <a:prstGeom prst="rect">
+            <a:avLst/>
+          </a:prstGeom>
+          <a:noFill/>
+          <a:ln w="0">
+            <a:noFill/>
+          </a:ln>
+        </p:spPr>
+        <p:txBody>
+          <a:bodyPr anchor="t">
+            <a:noAutofit/>
+          </a:bodyPr>
+          <a:lstStyle/>
+          <a:p>
+            <a:pPr algn="l">
+              <a:buNone/>
+              <a:defRPr sz="1125" b="0" i="0">
+                <a:solidFill>
+                  <a:srgbClr val="1F3864"/>
+                </a:solidFill>
+                <a:latin typeface="Arial"/>
+                <a:ea typeface="Arial"/>
+                <a:cs typeface="Arial"/>
+              </a:defRPr>
+            </a:pPr>
+            <a:r>
+              <a:rPr sz="1125" b="0" i="0">
+                <a:solidFill>
+                  <a:srgbClr val="1F3864"/>
+                </a:solidFill>
+                <a:latin typeface="Arial"/>
+                <a:ea typeface="Arial"/>
+                <a:cs typeface="Arial"/>
+              </a:rPr>
+              <a:t>Tres niveles: −18 °C, 4 °C y 20 °C</a:t>
+            </a:r>
+          </a:p>
+        </p:txBody>
+      </p:sp>
+      <p:sp>
+        <p:nvSpPr>
+          <p:cNvPr id="40" name="Rectangle: Rounded Corners 39">
+            <a:extLst>
+              <a:ext uri="{FF2B5EF4-FFF2-40B4-BE49-F238E27FC236}">
+                <a16:creationId xmlns:a16="http://schemas.microsoft.com/office/drawing/2014/main" id="{FF5DA023-D550-4414-BD9F-86F82AA9038D}"/>
+              </a:ext>
+            </a:extLst>
+          </p:cNvPr>
+          <p:cNvSpPr>
+            <a:spLocks noGrp="1"/>
+          </p:cNvSpPr>
+          <p:nvPr/>
+        </p:nvSpPr>
+        <p:spPr>
+          <a:xfrm>
+            <a:off x="7943850" y="5334000"/>
+            <a:ext cx="3429000" cy="628650"/>
+          </a:xfrm>
+          <a:prstGeom prst="roundRect">
+            <a:avLst>
+              <a:gd name="adj" fmla="val 15152"/>
+            </a:avLst>
+          </a:prstGeom>
+          <a:solidFill>
+            <a:srgbClr val="FFFFFF"/>
+          </a:solidFill>
+          <a:ln w="9525">
+            <a:solidFill>
+              <a:srgbClr val="EDF2F7"/>
+            </a:solidFill>
+            <a:prstDash val="solid"/>
+          </a:ln>
+        </p:spPr>
+        <p:txBody>
+          <a:bodyPr/>
+          <a:lstStyle/>
+          <a:p>
+            <a:endParaRPr/>
+          </a:p>
+        </p:txBody>
+      </p:sp>
+      <p:sp>
+        <p:nvSpPr>
+          <p:cNvPr id="41" name="Rectangle 40">
+            <a:extLst>
+              <a:ext uri="{FF2B5EF4-FFF2-40B4-BE49-F238E27FC236}">
+                <a16:creationId xmlns:a16="http://schemas.microsoft.com/office/drawing/2014/main" id="{F36DDB51-CFB7-4503-927D-3AD21CC78A88}"/>
+              </a:ext>
+            </a:extLst>
+          </p:cNvPr>
+          <p:cNvSpPr>
+            <a:spLocks noGrp="1"/>
+          </p:cNvSpPr>
+          <p:nvPr/>
+        </p:nvSpPr>
+        <p:spPr>
+          <a:xfrm>
+            <a:off x="7943850" y="5334000"/>
+            <a:ext cx="57150" cy="628650"/>
+          </a:xfrm>
+          <a:prstGeom prst="rect">
+            <a:avLst/>
+          </a:prstGeom>
+          <a:solidFill>
+            <a:srgbClr val="2E5B8A"/>
+          </a:solidFill>
+          <a:ln w="0">
+            <a:noFill/>
+            <a:prstDash val="solid"/>
+          </a:ln>
+        </p:spPr>
+        <p:txBody>
+          <a:bodyPr/>
+          <a:lstStyle/>
+          <a:p>
+            <a:endParaRPr/>
+          </a:p>
+        </p:txBody>
+      </p:sp>
+      <p:sp>
+        <p:nvSpPr>
+          <p:cNvPr id="42" name="Rectangle 41">
+            <a:extLst>
+              <a:ext uri="{FF2B5EF4-FFF2-40B4-BE49-F238E27FC236}">
+                <a16:creationId xmlns:a16="http://schemas.microsoft.com/office/drawing/2014/main" id="{1DCF2F3E-2150-4749-A9B3-DB318A51D37A}"/>
+              </a:ext>
+            </a:extLst>
+          </p:cNvPr>
+          <p:cNvSpPr>
+            <a:spLocks noGrp="1"/>
+          </p:cNvSpPr>
+          <p:nvPr/>
+        </p:nvSpPr>
+        <p:spPr>
+          <a:xfrm>
+            <a:off x="8115300" y="5429250"/>
+            <a:ext cx="3124200" cy="171450"/>
+          </a:xfrm>
+          <a:prstGeom prst="rect">
+            <a:avLst/>
+          </a:prstGeom>
+          <a:noFill/>
+          <a:ln w="0">
+            <a:noFill/>
+          </a:ln>
+        </p:spPr>
+        <p:txBody>
+          <a:bodyPr anchor="t">
+            <a:noAutofit/>
+          </a:bodyPr>
+          <a:lstStyle/>
+          <a:p>
+            <a:pPr algn="l">
+              <a:buNone/>
+              <a:defRPr sz="825" b="1" i="0">
+                <a:solidFill>
+                  <a:srgbClr val="2E5B8A"/>
+                </a:solidFill>
+                <a:latin typeface="Arial"/>
+                <a:ea typeface="Arial"/>
+                <a:cs typeface="Arial"/>
+              </a:defRPr>
+            </a:pPr>
+            <a:r>
+              <a:rPr sz="825" b="1" i="0">
+                <a:solidFill>
+                  <a:srgbClr val="2E5B8A"/>
+                </a:solidFill>
+                <a:latin typeface="Arial"/>
+                <a:ea typeface="Arial"/>
+                <a:cs typeface="Arial"/>
+              </a:rPr>
+              <a:t>3</a:t>
+            </a:r>
+          </a:p>
+        </p:txBody>
+      </p:sp>
+      <p:sp>
+        <p:nvSpPr>
+          <p:cNvPr id="43" name="Rectangle 42">
+            <a:extLst>
+              <a:ext uri="{FF2B5EF4-FFF2-40B4-BE49-F238E27FC236}">
+                <a16:creationId xmlns:a16="http://schemas.microsoft.com/office/drawing/2014/main" id="{EF4E876E-E31F-4134-8CCA-261D655E3F91}"/>
+              </a:ext>
+            </a:extLst>
+          </p:cNvPr>
+          <p:cNvSpPr>
+            <a:spLocks noGrp="1"/>
+          </p:cNvSpPr>
+          <p:nvPr/>
+        </p:nvSpPr>
+        <p:spPr>
+          <a:xfrm>
+            <a:off x="8115300" y="5610225"/>
+            <a:ext cx="3257550" cy="304800"/>
+          </a:xfrm>
+          <a:prstGeom prst="rect">
+            <a:avLst/>
+          </a:prstGeom>
+          <a:noFill/>
+          <a:ln w="0">
+            <a:noFill/>
+          </a:ln>
+        </p:spPr>
+        <p:txBody>
+          <a:bodyPr anchor="t">
+            <a:noAutofit/>
+          </a:bodyPr>
+          <a:lstStyle/>
+          <a:p>
+            <a:pPr algn="l">
+              <a:buNone/>
+              <a:defRPr sz="1125" b="0" i="0">
+                <a:solidFill>
+                  <a:srgbClr val="1F3864"/>
+                </a:solidFill>
+                <a:latin typeface="Arial"/>
+                <a:ea typeface="Arial"/>
+                <a:cs typeface="Arial"/>
+              </a:defRPr>
+            </a:pPr>
+            <a:r>
+              <a:rPr sz="1125" b="0" i="0" dirty="0">
+                <a:solidFill>
+                  <a:srgbClr val="1F3864"/>
+                </a:solidFill>
+                <a:latin typeface="Arial"/>
+                <a:ea typeface="Arial"/>
+                <a:cs typeface="Arial"/>
+              </a:rPr>
+              <a:t>Sin </a:t>
+            </a:r>
+            <a:r>
               <a:rPr sz="1125" b="0" i="0" dirty="0" err="1">
                 <a:solidFill>
                   <a:srgbClr val="1F3864"/>
@@ -12354,7 +11462,7 @@
                 <a:ea typeface="Arial"/>
                 <a:cs typeface="Arial"/>
               </a:rPr>
-              <a:t>Eventos</a:t>
+              <a:t>rangos</a:t>
             </a:r>
             <a:r>
               <a:rPr sz="1125" b="0" i="0" dirty="0">
@@ -12376,7 +11484,7 @@
                 <a:ea typeface="Arial"/>
                 <a:cs typeface="Arial"/>
               </a:rPr>
-              <a:t>futuros</a:t>
+              <a:t>oficiales</a:t>
             </a:r>
             <a:r>
               <a:rPr sz="1125" b="0" i="0" dirty="0">
@@ -12387,7 +11495,7 @@
                 <a:ea typeface="Arial"/>
                 <a:cs typeface="Arial"/>
               </a:rPr>
-              <a:t>: 5,02% de las </a:t>
+              <a:t> no se </a:t>
             </a:r>
             <a:r>
               <a:rPr sz="1125" b="0" i="0" dirty="0" err="1">
@@ -12398,7 +11506,7 @@
                 <a:ea typeface="Arial"/>
                 <a:cs typeface="Arial"/>
               </a:rPr>
-              <a:t>ventanas</a:t>
+              <a:t>afirma</a:t>
             </a:r>
             <a:r>
               <a:rPr sz="1125" b="0" i="0" dirty="0">
@@ -12420,7 +11528,7 @@
                 <a:ea typeface="Arial"/>
                 <a:cs typeface="Arial"/>
               </a:rPr>
-              <a:t>evaluables</a:t>
+              <a:t>cumplimiento</a:t>
             </a:r>
             <a:endParaRPr sz="1125" b="0" i="0" dirty="0">
               <a:solidFill>
@@ -12430,486 +11538,6 @@
               <a:ea typeface="Arial"/>
               <a:cs typeface="Arial"/>
             </a:endParaRPr>
-          </a:p>
-        </p:txBody>
-      </p:sp>
-      <p:sp>
-        <p:nvSpPr>
-          <p:cNvPr id="36" name="Rectangle: Rounded Corners 35">
-            <a:extLst>
-              <a:ext uri="{FF2B5EF4-FFF2-40B4-BE49-F238E27FC236}">
-                <a16:creationId xmlns:a16="http://schemas.microsoft.com/office/drawing/2014/main" id="{ECD1CB10-798D-4D7B-A47E-CB354ECB2C32}"/>
-              </a:ext>
-            </a:extLst>
-          </p:cNvPr>
-          <p:cNvSpPr>
-            <a:spLocks noGrp="1"/>
-          </p:cNvSpPr>
-          <p:nvPr/>
-        </p:nvSpPr>
-        <p:spPr>
-          <a:xfrm>
-            <a:off x="4238625" y="5334000"/>
-            <a:ext cx="3429000" cy="628650"/>
-          </a:xfrm>
-          <a:prstGeom prst="roundRect">
-            <a:avLst>
-              <a:gd name="adj" fmla="val 15152"/>
-            </a:avLst>
-          </a:prstGeom>
-          <a:solidFill>
-            <a:srgbClr val="FFFFFF"/>
-          </a:solidFill>
-          <a:ln w="9525">
-            <a:solidFill>
-              <a:srgbClr val="EDF2F7"/>
-            </a:solidFill>
-            <a:prstDash val="solid"/>
-          </a:ln>
-        </p:spPr>
-        <p:txBody>
-          <a:bodyPr/>
-          <a:lstStyle/>
-          <a:p>
-            <a:endParaRPr/>
-          </a:p>
-        </p:txBody>
-      </p:sp>
-      <p:sp>
-        <p:nvSpPr>
-          <p:cNvPr id="37" name="Rectangle 36">
-            <a:extLst>
-              <a:ext uri="{FF2B5EF4-FFF2-40B4-BE49-F238E27FC236}">
-                <a16:creationId xmlns:a16="http://schemas.microsoft.com/office/drawing/2014/main" id="{05C5F7D4-2D47-4300-8E8D-A6702F9BBC31}"/>
-              </a:ext>
-            </a:extLst>
-          </p:cNvPr>
-          <p:cNvSpPr>
-            <a:spLocks noGrp="1"/>
-          </p:cNvSpPr>
-          <p:nvPr/>
-        </p:nvSpPr>
-        <p:spPr>
-          <a:xfrm>
-            <a:off x="4238625" y="5334000"/>
-            <a:ext cx="57150" cy="628650"/>
-          </a:xfrm>
-          <a:prstGeom prst="rect">
-            <a:avLst/>
-          </a:prstGeom>
-          <a:solidFill>
-            <a:srgbClr val="2E5B8A"/>
-          </a:solidFill>
-          <a:ln w="0">
-            <a:noFill/>
-            <a:prstDash val="solid"/>
-          </a:ln>
-        </p:spPr>
-        <p:txBody>
-          <a:bodyPr/>
-          <a:lstStyle/>
-          <a:p>
-            <a:endParaRPr/>
-          </a:p>
-        </p:txBody>
-      </p:sp>
-      <p:sp>
-        <p:nvSpPr>
-          <p:cNvPr id="38" name="Rectangle 37">
-            <a:extLst>
-              <a:ext uri="{FF2B5EF4-FFF2-40B4-BE49-F238E27FC236}">
-                <a16:creationId xmlns:a16="http://schemas.microsoft.com/office/drawing/2014/main" id="{E9CCF00C-1C07-4DFD-A20B-5626FBE5ECE9}"/>
-              </a:ext>
-            </a:extLst>
-          </p:cNvPr>
-          <p:cNvSpPr>
-            <a:spLocks noGrp="1"/>
-          </p:cNvSpPr>
-          <p:nvPr/>
-        </p:nvSpPr>
-        <p:spPr>
-          <a:xfrm>
-            <a:off x="4410075" y="5429250"/>
-            <a:ext cx="3124200" cy="171450"/>
-          </a:xfrm>
-          <a:prstGeom prst="rect">
-            <a:avLst/>
-          </a:prstGeom>
-          <a:noFill/>
-          <a:ln w="0">
-            <a:noFill/>
-          </a:ln>
-        </p:spPr>
-        <p:txBody>
-          <a:bodyPr anchor="t">
-            <a:noAutofit/>
-          </a:bodyPr>
-          <a:lstStyle/>
-          <a:p>
-            <a:pPr algn="l">
-              <a:buNone/>
-              <a:defRPr sz="825" b="1" i="0">
-                <a:solidFill>
-                  <a:srgbClr val="2E5B8A"/>
-                </a:solidFill>
-                <a:latin typeface="Arial"/>
-                <a:ea typeface="Arial"/>
-                <a:cs typeface="Arial"/>
-              </a:defRPr>
-            </a:pPr>
-            <a:r>
-              <a:rPr sz="825" b="1" i="0">
-                <a:solidFill>
-                  <a:srgbClr val="2E5B8A"/>
-                </a:solidFill>
-                <a:latin typeface="Arial"/>
-                <a:ea typeface="Arial"/>
-                <a:cs typeface="Arial"/>
-              </a:rPr>
-              <a:t>2</a:t>
-            </a:r>
-          </a:p>
-        </p:txBody>
-      </p:sp>
-      <p:sp>
-        <p:nvSpPr>
-          <p:cNvPr id="39" name="Rectangle 38">
-            <a:extLst>
-              <a:ext uri="{FF2B5EF4-FFF2-40B4-BE49-F238E27FC236}">
-                <a16:creationId xmlns:a16="http://schemas.microsoft.com/office/drawing/2014/main" id="{82DB381A-0FAF-42AD-A2DC-D0756571892B}"/>
-              </a:ext>
-            </a:extLst>
-          </p:cNvPr>
-          <p:cNvSpPr>
-            <a:spLocks noGrp="1"/>
-          </p:cNvSpPr>
-          <p:nvPr/>
-        </p:nvSpPr>
-        <p:spPr>
-          <a:xfrm>
-            <a:off x="4410075" y="5610225"/>
-            <a:ext cx="3124200" cy="304800"/>
-          </a:xfrm>
-          <a:prstGeom prst="rect">
-            <a:avLst/>
-          </a:prstGeom>
-          <a:noFill/>
-          <a:ln w="0">
-            <a:noFill/>
-          </a:ln>
-        </p:spPr>
-        <p:txBody>
-          <a:bodyPr anchor="t">
-            <a:noAutofit/>
-          </a:bodyPr>
-          <a:lstStyle/>
-          <a:p>
-            <a:pPr algn="l">
-              <a:buNone/>
-              <a:defRPr sz="1125" b="0" i="0">
-                <a:solidFill>
-                  <a:srgbClr val="1F3864"/>
-                </a:solidFill>
-                <a:latin typeface="Arial"/>
-                <a:ea typeface="Arial"/>
-                <a:cs typeface="Arial"/>
-              </a:defRPr>
-            </a:pPr>
-            <a:r>
-              <a:rPr sz="1125" b="0" i="0" dirty="0">
-                <a:solidFill>
-                  <a:srgbClr val="1F3864"/>
-                </a:solidFill>
-                <a:latin typeface="Arial"/>
-                <a:ea typeface="Arial"/>
-                <a:cs typeface="Arial"/>
-              </a:rPr>
-              <a:t>Con </a:t>
-            </a:r>
-            <a:r>
-              <a:rPr sz="1125" b="0" i="0" dirty="0" err="1">
-                <a:solidFill>
-                  <a:srgbClr val="1F3864"/>
-                </a:solidFill>
-                <a:latin typeface="Arial"/>
-                <a:ea typeface="Arial"/>
-                <a:cs typeface="Arial"/>
-              </a:rPr>
-              <a:t>desviación</a:t>
-            </a:r>
-            <a:r>
-              <a:rPr sz="1125" b="0" i="0" dirty="0">
-                <a:solidFill>
-                  <a:srgbClr val="1F3864"/>
-                </a:solidFill>
-                <a:latin typeface="Arial"/>
-                <a:ea typeface="Arial"/>
-                <a:cs typeface="Arial"/>
-              </a:rPr>
-              <a:t> actual, el </a:t>
-            </a:r>
-            <a:r>
-              <a:rPr sz="1125" b="0" i="0" dirty="0" err="1">
-                <a:solidFill>
-                  <a:srgbClr val="1F3864"/>
-                </a:solidFill>
-                <a:latin typeface="Arial"/>
-                <a:ea typeface="Arial"/>
-                <a:cs typeface="Arial"/>
-              </a:rPr>
-              <a:t>riesgo</a:t>
-            </a:r>
-            <a:r>
-              <a:rPr sz="1125" b="0" i="0" dirty="0">
-                <a:solidFill>
-                  <a:srgbClr val="1F3864"/>
-                </a:solidFill>
-                <a:latin typeface="Arial"/>
-                <a:ea typeface="Arial"/>
-                <a:cs typeface="Arial"/>
-              </a:rPr>
-              <a:t> </a:t>
-            </a:r>
-            <a:r>
-              <a:rPr sz="1125" b="0" i="0" dirty="0" err="1">
-                <a:solidFill>
-                  <a:srgbClr val="1F3864"/>
-                </a:solidFill>
-                <a:latin typeface="Arial"/>
-                <a:ea typeface="Arial"/>
-                <a:cs typeface="Arial"/>
-              </a:rPr>
-              <a:t>futuro</a:t>
-            </a:r>
-            <a:r>
-              <a:rPr sz="1125" b="0" i="0" dirty="0">
-                <a:solidFill>
-                  <a:srgbClr val="1F3864"/>
-                </a:solidFill>
-                <a:latin typeface="Arial"/>
-                <a:ea typeface="Arial"/>
-                <a:cs typeface="Arial"/>
-              </a:rPr>
-              <a:t> </a:t>
-            </a:r>
-            <a:r>
-              <a:rPr sz="1125" b="0" i="0" dirty="0" err="1">
-                <a:solidFill>
-                  <a:srgbClr val="1F3864"/>
-                </a:solidFill>
-                <a:latin typeface="Arial"/>
-                <a:ea typeface="Arial"/>
-                <a:cs typeface="Arial"/>
-              </a:rPr>
-              <a:t>sube</a:t>
-            </a:r>
-            <a:r>
-              <a:rPr sz="1125" b="0" i="0" dirty="0">
-                <a:solidFill>
-                  <a:srgbClr val="1F3864"/>
-                </a:solidFill>
-                <a:latin typeface="Arial"/>
-                <a:ea typeface="Arial"/>
-                <a:cs typeface="Arial"/>
-              </a:rPr>
-              <a:t> a 59,41%</a:t>
-            </a:r>
-          </a:p>
-        </p:txBody>
-      </p:sp>
-      <p:sp>
-        <p:nvSpPr>
-          <p:cNvPr id="40" name="Rectangle: Rounded Corners 39">
-            <a:extLst>
-              <a:ext uri="{FF2B5EF4-FFF2-40B4-BE49-F238E27FC236}">
-                <a16:creationId xmlns:a16="http://schemas.microsoft.com/office/drawing/2014/main" id="{FF5DA023-D550-4414-BD9F-86F82AA9038D}"/>
-              </a:ext>
-            </a:extLst>
-          </p:cNvPr>
-          <p:cNvSpPr>
-            <a:spLocks noGrp="1"/>
-          </p:cNvSpPr>
-          <p:nvPr/>
-        </p:nvSpPr>
-        <p:spPr>
-          <a:xfrm>
-            <a:off x="7943850" y="5334000"/>
-            <a:ext cx="3429000" cy="628650"/>
-          </a:xfrm>
-          <a:prstGeom prst="roundRect">
-            <a:avLst>
-              <a:gd name="adj" fmla="val 15152"/>
-            </a:avLst>
-          </a:prstGeom>
-          <a:solidFill>
-            <a:srgbClr val="FFFFFF"/>
-          </a:solidFill>
-          <a:ln w="9525">
-            <a:solidFill>
-              <a:srgbClr val="EDF2F7"/>
-            </a:solidFill>
-            <a:prstDash val="solid"/>
-          </a:ln>
-        </p:spPr>
-        <p:txBody>
-          <a:bodyPr/>
-          <a:lstStyle/>
-          <a:p>
-            <a:endParaRPr/>
-          </a:p>
-        </p:txBody>
-      </p:sp>
-      <p:sp>
-        <p:nvSpPr>
-          <p:cNvPr id="41" name="Rectangle 40">
-            <a:extLst>
-              <a:ext uri="{FF2B5EF4-FFF2-40B4-BE49-F238E27FC236}">
-                <a16:creationId xmlns:a16="http://schemas.microsoft.com/office/drawing/2014/main" id="{F36DDB51-CFB7-4503-927D-3AD21CC78A88}"/>
-              </a:ext>
-            </a:extLst>
-          </p:cNvPr>
-          <p:cNvSpPr>
-            <a:spLocks noGrp="1"/>
-          </p:cNvSpPr>
-          <p:nvPr/>
-        </p:nvSpPr>
-        <p:spPr>
-          <a:xfrm>
-            <a:off x="7943850" y="5334000"/>
-            <a:ext cx="57150" cy="628650"/>
-          </a:xfrm>
-          <a:prstGeom prst="rect">
-            <a:avLst/>
-          </a:prstGeom>
-          <a:solidFill>
-            <a:srgbClr val="2E5B8A"/>
-          </a:solidFill>
-          <a:ln w="0">
-            <a:noFill/>
-            <a:prstDash val="solid"/>
-          </a:ln>
-        </p:spPr>
-        <p:txBody>
-          <a:bodyPr/>
-          <a:lstStyle/>
-          <a:p>
-            <a:endParaRPr/>
-          </a:p>
-        </p:txBody>
-      </p:sp>
-      <p:sp>
-        <p:nvSpPr>
-          <p:cNvPr id="42" name="Rectangle 41">
-            <a:extLst>
-              <a:ext uri="{FF2B5EF4-FFF2-40B4-BE49-F238E27FC236}">
-                <a16:creationId xmlns:a16="http://schemas.microsoft.com/office/drawing/2014/main" id="{1DCF2F3E-2150-4749-A9B3-DB318A51D37A}"/>
-              </a:ext>
-            </a:extLst>
-          </p:cNvPr>
-          <p:cNvSpPr>
-            <a:spLocks noGrp="1"/>
-          </p:cNvSpPr>
-          <p:nvPr/>
-        </p:nvSpPr>
-        <p:spPr>
-          <a:xfrm>
-            <a:off x="8115300" y="5429250"/>
-            <a:ext cx="3124200" cy="171450"/>
-          </a:xfrm>
-          <a:prstGeom prst="rect">
-            <a:avLst/>
-          </a:prstGeom>
-          <a:noFill/>
-          <a:ln w="0">
-            <a:noFill/>
-          </a:ln>
-        </p:spPr>
-        <p:txBody>
-          <a:bodyPr anchor="t">
-            <a:noAutofit/>
-          </a:bodyPr>
-          <a:lstStyle/>
-          <a:p>
-            <a:pPr algn="l">
-              <a:buNone/>
-              <a:defRPr sz="825" b="1" i="0">
-                <a:solidFill>
-                  <a:srgbClr val="2E5B8A"/>
-                </a:solidFill>
-                <a:latin typeface="Arial"/>
-                <a:ea typeface="Arial"/>
-                <a:cs typeface="Arial"/>
-              </a:defRPr>
-            </a:pPr>
-            <a:r>
-              <a:rPr sz="825" b="1" i="0">
-                <a:solidFill>
-                  <a:srgbClr val="2E5B8A"/>
-                </a:solidFill>
-                <a:latin typeface="Arial"/>
-                <a:ea typeface="Arial"/>
-                <a:cs typeface="Arial"/>
-              </a:rPr>
-              <a:t>3</a:t>
-            </a:r>
-          </a:p>
-        </p:txBody>
-      </p:sp>
-      <p:sp>
-        <p:nvSpPr>
-          <p:cNvPr id="43" name="Rectangle 42">
-            <a:extLst>
-              <a:ext uri="{FF2B5EF4-FFF2-40B4-BE49-F238E27FC236}">
-                <a16:creationId xmlns:a16="http://schemas.microsoft.com/office/drawing/2014/main" id="{EF4E876E-E31F-4134-8CCA-261D655E3F91}"/>
-              </a:ext>
-            </a:extLst>
-          </p:cNvPr>
-          <p:cNvSpPr>
-            <a:spLocks noGrp="1"/>
-          </p:cNvSpPr>
-          <p:nvPr/>
-        </p:nvSpPr>
-        <p:spPr>
-          <a:xfrm>
-            <a:off x="8115300" y="5610225"/>
-            <a:ext cx="3124200" cy="304800"/>
-          </a:xfrm>
-          <a:prstGeom prst="rect">
-            <a:avLst/>
-          </a:prstGeom>
-          <a:noFill/>
-          <a:ln w="0">
-            <a:noFill/>
-          </a:ln>
-        </p:spPr>
-        <p:txBody>
-          <a:bodyPr anchor="t">
-            <a:noAutofit/>
-          </a:bodyPr>
-          <a:lstStyle/>
-          <a:p>
-            <a:pPr algn="l">
-              <a:buNone/>
-              <a:defRPr sz="1125" b="0" i="0">
-                <a:solidFill>
-                  <a:srgbClr val="1F3864"/>
-                </a:solidFill>
-                <a:latin typeface="Arial"/>
-                <a:ea typeface="Arial"/>
-                <a:cs typeface="Arial"/>
-              </a:defRPr>
-            </a:pPr>
-            <a:r>
-              <a:rPr sz="1125" b="0" i="0">
-                <a:solidFill>
-                  <a:srgbClr val="1F3864"/>
-                </a:solidFill>
-                <a:latin typeface="Arial"/>
-                <a:ea typeface="Arial"/>
-                <a:cs typeface="Arial"/>
-              </a:rPr>
-              <a:t>Temperatura y humedad cambian, pero las clases se superponen</a:t>
-            </a:r>
           </a:p>
         </p:txBody>
       </p:sp>
@@ -13627,8 +12255,8 @@
         </p:nvSpPr>
         <p:spPr>
           <a:xfrm>
-            <a:off x="5734050" y="1647824"/>
-            <a:ext cx="5943600" cy="523875"/>
+            <a:off x="5962650" y="1647824"/>
+            <a:ext cx="5715000" cy="523875"/>
           </a:xfrm>
           <a:prstGeom prst="rect">
             <a:avLst/>
@@ -13656,16 +12284,123 @@
               </a:defRPr>
             </a:pPr>
             <a:r>
-              <a:rPr sz="1500" b="1" i="0">
-                <a:solidFill>
-                  <a:srgbClr val="1F3864"/>
-                </a:solidFill>
-                <a:latin typeface="Arial"/>
-                <a:ea typeface="Arial"/>
-                <a:cs typeface="Arial"/>
-              </a:rPr>
-              <a:t>División 80/20 por viaje: 960 viajes de entrenamiento y 240 de prueba</a:t>
-            </a:r>
+              <a:rPr sz="1500" b="1" i="0" dirty="0">
+                <a:solidFill>
+                  <a:srgbClr val="1F3864"/>
+                </a:solidFill>
+                <a:latin typeface="Arial"/>
+                <a:ea typeface="Arial"/>
+                <a:cs typeface="Arial"/>
+              </a:rPr>
+              <a:t>División 80/20 </a:t>
+            </a:r>
+            <a:r>
+              <a:rPr sz="1500" b="1" i="0" dirty="0" err="1">
+                <a:solidFill>
+                  <a:srgbClr val="1F3864"/>
+                </a:solidFill>
+                <a:latin typeface="Arial"/>
+                <a:ea typeface="Arial"/>
+                <a:cs typeface="Arial"/>
+              </a:rPr>
+              <a:t>por</a:t>
+            </a:r>
+            <a:r>
+              <a:rPr sz="1500" b="1" i="0" dirty="0">
+                <a:solidFill>
+                  <a:srgbClr val="1F3864"/>
+                </a:solidFill>
+                <a:latin typeface="Arial"/>
+                <a:ea typeface="Arial"/>
+                <a:cs typeface="Arial"/>
+              </a:rPr>
+              <a:t> </a:t>
+            </a:r>
+            <a:r>
+              <a:rPr sz="1500" b="1" i="0" dirty="0" err="1">
+                <a:solidFill>
+                  <a:srgbClr val="1F3864"/>
+                </a:solidFill>
+                <a:latin typeface="Arial"/>
+                <a:ea typeface="Arial"/>
+                <a:cs typeface="Arial"/>
+              </a:rPr>
+              <a:t>viaje</a:t>
+            </a:r>
+            <a:r>
+              <a:rPr sz="1500" b="1" i="0" dirty="0">
+                <a:solidFill>
+                  <a:srgbClr val="1F3864"/>
+                </a:solidFill>
+                <a:latin typeface="Arial"/>
+                <a:ea typeface="Arial"/>
+                <a:cs typeface="Arial"/>
+              </a:rPr>
+              <a:t>: 960 </a:t>
+            </a:r>
+            <a:r>
+              <a:rPr sz="1500" b="1" i="0" dirty="0" err="1">
+                <a:solidFill>
+                  <a:srgbClr val="1F3864"/>
+                </a:solidFill>
+                <a:latin typeface="Arial"/>
+                <a:ea typeface="Arial"/>
+                <a:cs typeface="Arial"/>
+              </a:rPr>
+              <a:t>viajes</a:t>
+            </a:r>
+            <a:r>
+              <a:rPr sz="1500" b="1" i="0" dirty="0">
+                <a:solidFill>
+                  <a:srgbClr val="1F3864"/>
+                </a:solidFill>
+                <a:latin typeface="Arial"/>
+                <a:ea typeface="Arial"/>
+                <a:cs typeface="Arial"/>
+              </a:rPr>
+              <a:t> de </a:t>
+            </a:r>
+            <a:r>
+              <a:rPr sz="1500" b="1" i="0" dirty="0" err="1">
+                <a:solidFill>
+                  <a:srgbClr val="1F3864"/>
+                </a:solidFill>
+                <a:latin typeface="Arial"/>
+                <a:ea typeface="Arial"/>
+                <a:cs typeface="Arial"/>
+              </a:rPr>
+              <a:t>entrenamiento</a:t>
+            </a:r>
+            <a:r>
+              <a:rPr sz="1500" b="1" i="0" dirty="0">
+                <a:solidFill>
+                  <a:srgbClr val="1F3864"/>
+                </a:solidFill>
+                <a:latin typeface="Arial"/>
+                <a:ea typeface="Arial"/>
+                <a:cs typeface="Arial"/>
+              </a:rPr>
+              <a:t> y 240 de </a:t>
+            </a:r>
+            <a:r>
+              <a:rPr sz="1500" b="1" i="0" dirty="0" err="1">
+                <a:solidFill>
+                  <a:srgbClr val="1F3864"/>
+                </a:solidFill>
+                <a:latin typeface="Arial"/>
+                <a:ea typeface="Arial"/>
+                <a:cs typeface="Arial"/>
+              </a:rPr>
+              <a:t>prueba</a:t>
+            </a:r>
+            <a:endParaRPr sz="1500" b="1" i="0" dirty="0">
+              <a:solidFill>
+                <a:srgbClr val="1F3864"/>
+              </a:solidFill>
+              <a:latin typeface="Arial"/>
+              <a:ea typeface="Arial"/>
+              <a:cs typeface="Arial"/>
+            </a:endParaRPr>
           </a:p>
         </p:txBody>
       </p:sp>
@@ -13789,13 +12524,7 @@
         <p:nvGraphicFramePr>
           <p:cNvPr id="36" name="Table 33"/>
           <p:cNvGraphicFramePr/>
-          <p:nvPr>
-            <p:extLst>
-              <p:ext uri="{D42A27DB-BD31-4B8C-83A1-F6EECF244321}">
-                <p14:modId xmlns:p14="http://schemas.microsoft.com/office/powerpoint/2010/main" val="2779402257"/>
-              </p:ext>
-            </p:extLst>
-          </p:nvPr>
+          <p:nvPr/>
         </p:nvGraphicFramePr>
         <p:xfrm>
           <a:off x="533400" y="3028950"/>
@@ -14048,7 +12777,7 @@
                     <a:lstStyle/>
                     <a:p>
                       <a:r>
-                        <a:rPr lang="en-US" sz="1125" dirty="0" err="1">
+                        <a:rPr sz="1125">
                           <a:solidFill>
                             <a:srgbClr val="1F3864"/>
                           </a:solidFill>
@@ -14056,60 +12785,8 @@
                           <a:ea typeface="Arial"/>
                           <a:cs typeface="Arial"/>
                         </a:rPr>
-                        <a:t>Candidato</a:t>
+                        <a:t>Regresión logística</a:t>
                       </a:r>
-                      <a:r>
-                        <a:rPr lang="en-US" sz="1125" dirty="0">
-                          <a:solidFill>
-                            <a:srgbClr val="1F3864"/>
-                          </a:solidFill>
-                          <a:latin typeface="Arial"/>
-                          <a:ea typeface="Arial"/>
-                          <a:cs typeface="Arial"/>
-                        </a:rPr>
-                        <a:t>: </a:t>
-                      </a:r>
-                      <a:r>
-                        <a:rPr sz="1125" dirty="0" err="1">
-                          <a:solidFill>
-                            <a:srgbClr val="1F3864"/>
-                          </a:solidFill>
-                          <a:latin typeface="Arial"/>
-                          <a:ea typeface="Arial"/>
-                          <a:cs typeface="Arial"/>
-                        </a:rPr>
-                        <a:t>Regresión</a:t>
-                      </a:r>
-                      <a:r>
-                        <a:rPr sz="1125" dirty="0">
-                          <a:solidFill>
-                            <a:srgbClr val="1F3864"/>
-                          </a:solidFill>
-                          <a:latin typeface="Arial"/>
-                          <a:ea typeface="Arial"/>
-                          <a:cs typeface="Arial"/>
-                        </a:rPr>
-                        <a:t> </a:t>
-                      </a:r>
-                      <a:r>
-                        <a:rPr sz="1125" dirty="0" err="1">
-                          <a:solidFill>
-                            <a:srgbClr val="1F3864"/>
-                          </a:solidFill>
-                          <a:latin typeface="Arial"/>
-                          <a:ea typeface="Arial"/>
-                          <a:cs typeface="Arial"/>
-                        </a:rPr>
-                        <a:t>logística</a:t>
-                      </a:r>
-                      <a:endParaRPr sz="1125" dirty="0">
-                        <a:solidFill>
-                          <a:srgbClr val="1F3864"/>
-                        </a:solidFill>
-                        <a:latin typeface="Arial"/>
-                        <a:ea typeface="Arial"/>
-                        <a:cs typeface="Arial"/>
-                      </a:endParaRPr>
                     </a:p>
                   </a:txBody>
                   <a:tcPr marL="95250" marR="95250" marT="66675" marB="66675" anchor="ctr">
@@ -14203,7 +12880,7 @@
                     <a:lstStyle/>
                     <a:p>
                       <a:r>
-                        <a:rPr sz="1125" dirty="0">
+                        <a:rPr sz="1125">
                           <a:solidFill>
                             <a:srgbClr val="1F3864"/>
                           </a:solidFill>
@@ -14211,27 +12888,8 @@
                           <a:ea typeface="Arial"/>
                           <a:cs typeface="Arial"/>
                         </a:rPr>
-                        <a:t>Modelo </a:t>
+                        <a:t>Modelo elegido</a:t>
                       </a:r>
-                      <a:r>
-                        <a:rPr sz="1125" dirty="0" err="1">
-                          <a:solidFill>
-                            <a:srgbClr val="1F3864"/>
-                          </a:solidFill>
-                          <a:latin typeface="Arial"/>
-                          <a:ea typeface="Arial"/>
-                          <a:cs typeface="Arial"/>
-                        </a:rPr>
-                        <a:t>elegido</a:t>
-                      </a:r>
-                      <a:endParaRPr sz="1125" dirty="0">
-                        <a:solidFill>
-                          <a:srgbClr val="1F3864"/>
-                        </a:solidFill>
-                        <a:latin typeface="Arial"/>
-                        <a:ea typeface="Arial"/>
-                        <a:cs typeface="Arial"/>
-                      </a:endParaRPr>
                     </a:p>
                   </a:txBody>
                   <a:tcPr marL="95250" marR="95250" marT="66675" marB="66675" anchor="ctr">
@@ -14294,7 +12952,7 @@
                     <a:lstStyle/>
                     <a:p>
                       <a:r>
-                        <a:rPr sz="1125" dirty="0" err="1">
+                        <a:rPr sz="1125">
                           <a:solidFill>
                             <a:srgbClr val="1F3864"/>
                           </a:solidFill>
@@ -14302,62 +12960,7 @@
                           <a:ea typeface="Arial"/>
                           <a:cs typeface="Arial"/>
                         </a:rPr>
-                        <a:t>Útil</a:t>
-                      </a:r>
-                      <a:r>
-                        <a:rPr sz="1125" dirty="0">
-                          <a:solidFill>
-                            <a:srgbClr val="1F3864"/>
-                          </a:solidFill>
-                          <a:latin typeface="Arial"/>
-                          <a:ea typeface="Arial"/>
-                          <a:cs typeface="Arial"/>
-                        </a:rPr>
-                        <a:t> para </a:t>
-                      </a:r>
-                      <a:r>
-                        <a:rPr sz="1125" dirty="0" err="1">
-                          <a:solidFill>
-                            <a:srgbClr val="1F3864"/>
-                          </a:solidFill>
-                          <a:latin typeface="Arial"/>
-                          <a:ea typeface="Arial"/>
-                          <a:cs typeface="Arial"/>
-                        </a:rPr>
-                        <a:t>priorizar</a:t>
-                      </a:r>
-                      <a:r>
-                        <a:rPr sz="1125" dirty="0">
-                          <a:solidFill>
-                            <a:srgbClr val="1F3864"/>
-                          </a:solidFill>
-                          <a:latin typeface="Arial"/>
-                          <a:ea typeface="Arial"/>
-                          <a:cs typeface="Arial"/>
-                        </a:rPr>
-                        <a:t>, con </a:t>
-                      </a:r>
-                      <a:r>
-                        <a:rPr sz="1125" dirty="0" err="1">
-                          <a:solidFill>
-                            <a:srgbClr val="1F3864"/>
-                          </a:solidFill>
-                          <a:latin typeface="Arial"/>
-                          <a:ea typeface="Arial"/>
-                          <a:cs typeface="Arial"/>
-                        </a:rPr>
-                        <a:t>supervisión</a:t>
-                      </a:r>
-                      <a:r>
-                        <a:rPr sz="1125" dirty="0">
-                          <a:solidFill>
-                            <a:srgbClr val="1F3864"/>
-                          </a:solidFill>
-                          <a:latin typeface="Arial"/>
-                          <a:ea typeface="Arial"/>
-                          <a:cs typeface="Arial"/>
-                        </a:rPr>
-                        <a:t> humana</a:t>
+                        <a:t>Útil para priorizar, con supervisión humana</a:t>
                       </a:r>
                     </a:p>
                   </a:txBody>
@@ -14604,7 +13207,7 @@
                 <a:ea typeface="Arial"/>
                 <a:cs typeface="Arial"/>
               </a:rPr>
-              <a:t>05 · VALIDACIÓN — CLASIFICACIÓN</a:t>
+              <a:t>04 · VALIDACIÓN DEL MODELO</a:t>
             </a:r>
           </a:p>
         </p:txBody>
@@ -16562,7 +15165,7 @@
                 <a:ea typeface="Arial"/>
                 <a:cs typeface="Arial"/>
               </a:rPr>
-              <a:t>06 · MÉTRICAS DEL MODELO</a:t>
+              <a:t>04 · MÉTRICAS DEL MODELO</a:t>
             </a:r>
           </a:p>
         </p:txBody>
@@ -18546,7 +17149,7 @@
                 <a:ea typeface="Arial"/>
                 <a:cs typeface="Arial"/>
               </a:rPr>
-              <a:t>07 · TRAZABILIDAD DEL PROYECTO</a:t>
+              <a:t>04 · VALIDACIÓN SEGMENTADA</a:t>
             </a:r>
           </a:p>
         </p:txBody>
@@ -18604,7 +17207,7 @@
                 <a:ea typeface="Arial"/>
                 <a:cs typeface="Arial"/>
               </a:rPr>
-              <a:t>Cómo se conserva la evidencia desde Bronze hasta el modelo</a:t>
+              <a:t>El promedio general oculta diferencias importantes</a:t>
             </a:r>
           </a:p>
         </p:txBody>
@@ -18864,7 +17467,7 @@
                 <a:ea typeface="Arial"/>
                 <a:cs typeface="Arial"/>
               </a:rPr>
-              <a:t>BRONZE</a:t>
+              <a:t>SIN DESVIACIÓN ACTUAL</a:t>
             </a:r>
           </a:p>
         </p:txBody>
@@ -18922,7 +17525,7 @@
                 <a:ea typeface="Arial"/>
                 <a:cs typeface="Arial"/>
               </a:rPr>
-              <a:t>28.920</a:t>
+              <a:t>6,33%</a:t>
             </a:r>
           </a:p>
         </p:txBody>
@@ -18980,7 +17583,7 @@
                 <a:ea typeface="Arial"/>
                 <a:cs typeface="Arial"/>
               </a:rPr>
-              <a:t>Lecturas recibidas sin depuración</a:t>
+              <a:t>Detecta 10 de 158 eventos nuevos</a:t>
             </a:r>
           </a:p>
         </p:txBody>
@@ -19078,7 +17681,7 @@
                 <a:ea typeface="Arial"/>
                 <a:cs typeface="Arial"/>
               </a:rPr>
-              <a:t>SILVER</a:t>
+              <a:t>CON DESVIACIÓN ACTUAL</a:t>
             </a:r>
           </a:p>
         </p:txBody>
@@ -19136,7 +17739,7 @@
                 <a:ea typeface="Arial"/>
                 <a:cs typeface="Arial"/>
               </a:rPr>
-              <a:t>28.465</a:t>
+              <a:t>100%</a:t>
             </a:r>
           </a:p>
         </p:txBody>
@@ -19194,7 +17797,7 @@
                 <a:ea typeface="Arial"/>
                 <a:cs typeface="Arial"/>
               </a:rPr>
-              <a:t>Lecturas aprobadas después de calidad</a:t>
+              <a:t>Detecta 120 de 120, pero alerta los 198 casos</a:t>
             </a:r>
           </a:p>
         </p:txBody>
@@ -19292,7 +17895,7 @@
                 <a:ea typeface="Arial"/>
                 <a:cs typeface="Arial"/>
               </a:rPr>
-              <a:t>GOLD</a:t>
+              <a:t>GRUPO CERCA DE 20 °C</a:t>
             </a:r>
           </a:p>
         </p:txBody>
@@ -19350,7 +17953,7 @@
                 <a:ea typeface="Arial"/>
                 <a:cs typeface="Arial"/>
               </a:rPr>
-              <a:t>28.465</a:t>
+              <a:t>18,07%</a:t>
             </a:r>
           </a:p>
         </p:txBody>
@@ -19408,7 +18011,7 @@
                 <a:ea typeface="Arial"/>
                 <a:cs typeface="Arial"/>
               </a:rPr>
-              <a:t>Una fila por lectura con variables temporales</a:t>
+              <a:t>Detecta 15 de 83 desviaciones reales</a:t>
             </a:r>
           </a:p>
         </p:txBody>
@@ -19466,7 +18069,7 @@
                 <a:ea typeface="Arial"/>
                 <a:cs typeface="Arial"/>
               </a:rPr>
-              <a:t>Controles aplicados en cada etapa</a:t>
+              <a:t>Desempeño por grupo térmico observado</a:t>
             </a:r>
           </a:p>
         </p:txBody>
@@ -19530,7 +18133,7 @@
                           <a:ea typeface="Arial"/>
                           <a:cs typeface="Arial"/>
                         </a:rPr>
-                        <a:t>Etapa</a:t>
+                        <a:t>Grupo observado</a:t>
                       </a:r>
                     </a:p>
                   </a:txBody>
@@ -19554,7 +18157,7 @@
                           <a:ea typeface="Arial"/>
                           <a:cs typeface="Arial"/>
                         </a:rPr>
-                        <a:t>Filas</a:t>
+                        <a:t>Positivos / detectados</a:t>
                       </a:r>
                     </a:p>
                   </a:txBody>
@@ -19578,7 +18181,7 @@
                           <a:ea typeface="Arial"/>
                           <a:cs typeface="Arial"/>
                         </a:rPr>
-                        <a:t>Control principal</a:t>
+                        <a:t>Recall</a:t>
                       </a:r>
                     </a:p>
                   </a:txBody>
@@ -19602,7 +18205,7 @@
                           <a:ea typeface="Arial"/>
                           <a:cs typeface="Arial"/>
                         </a:rPr>
-                        <a:t>Resultado</a:t>
+                        <a:t>Precisión</a:t>
                       </a:r>
                     </a:p>
                   </a:txBody>
@@ -19633,7 +18236,7 @@
                           <a:ea typeface="Arial"/>
                           <a:cs typeface="Arial"/>
                         </a:rPr>
-                        <a:t>Bronze</a:t>
+                        <a:t>Menor a 0 °C</a:t>
                       </a:r>
                     </a:p>
                   </a:txBody>
@@ -19657,7 +18260,7 @@
                           <a:ea typeface="Arial"/>
                           <a:cs typeface="Arial"/>
                         </a:rPr>
-                        <a:t>28.920</a:t>
+                        <a:t>62 / 39</a:t>
                       </a:r>
                     </a:p>
                   </a:txBody>
@@ -19681,7 +18284,7 @@
                           <a:ea typeface="Arial"/>
                           <a:cs typeface="Arial"/>
                         </a:rPr>
-                        <a:t>Conservar el archivo original</a:t>
+                        <a:t>62,90%</a:t>
                       </a:r>
                     </a:p>
                   </a:txBody>
@@ -19705,7 +18308,7 @@
                           <a:ea typeface="Arial"/>
                           <a:cs typeface="Arial"/>
                         </a:rPr>
-                        <a:t>Punto de partida reproducible</a:t>
+                        <a:t>15,48%</a:t>
                       </a:r>
                     </a:p>
                   </a:txBody>
@@ -19736,7 +18339,7 @@
                           <a:ea typeface="Arial"/>
                           <a:cs typeface="Arial"/>
                         </a:rPr>
-                        <a:t>Silver</a:t>
+                        <a:t>Entre 0 y 10 °C</a:t>
                       </a:r>
                     </a:p>
                   </a:txBody>
@@ -19760,7 +18363,7 @@
                           <a:ea typeface="Arial"/>
                           <a:cs typeface="Arial"/>
                         </a:rPr>
-                        <a:t>28.465</a:t>
+                        <a:t>133 / 76</a:t>
                       </a:r>
                     </a:p>
                   </a:txBody>
@@ -19784,7 +18387,7 @@
                           <a:ea typeface="Arial"/>
                           <a:cs typeface="Arial"/>
                         </a:rPr>
-                        <a:t>Separar errores y duplicados</a:t>
+                        <a:t>57,14%</a:t>
                       </a:r>
                     </a:p>
                   </a:txBody>
@@ -19808,7 +18411,7 @@
                           <a:ea typeface="Arial"/>
                           <a:cs typeface="Arial"/>
                         </a:rPr>
-                        <a:t>455 filas quedan en cuarentena</a:t>
+                        <a:t>47,50%</a:t>
                       </a:r>
                     </a:p>
                   </a:txBody>
@@ -19839,7 +18442,7 @@
                           <a:ea typeface="Arial"/>
                           <a:cs typeface="Arial"/>
                         </a:rPr>
-                        <a:t>Gold</a:t>
+                        <a:t>Mayor o igual a 10 °C</a:t>
                       </a:r>
                     </a:p>
                   </a:txBody>
@@ -19863,7 +18466,7 @@
                           <a:ea typeface="Arial"/>
                           <a:cs typeface="Arial"/>
                         </a:rPr>
-                        <a:t>28.465</a:t>
+                        <a:t>83 / 15</a:t>
                       </a:r>
                     </a:p>
                   </a:txBody>
@@ -19887,7 +18490,7 @@
                           <a:ea typeface="Arial"/>
                           <a:cs typeface="Arial"/>
                         </a:rPr>
-                        <a:t>Crear variables y objetivo futuro</a:t>
+                        <a:t>18,07%</a:t>
                       </a:r>
                     </a:p>
                   </a:txBody>
@@ -19911,7 +18514,7 @@
                           <a:ea typeface="Arial"/>
                           <a:cs typeface="Arial"/>
                         </a:rPr>
-                        <a:t>25.797 ventanas sirven para modelar</a:t>
+                        <a:t>30,61%</a:t>
                       </a:r>
                     </a:p>
                   </a:txBody>
@@ -20024,7 +18627,7 @@
                 <a:ea typeface="Arial"/>
                 <a:cs typeface="Arial"/>
               </a:rPr>
-              <a:t>CONCILIACIÓN FINAL</a:t>
+              <a:t>LECTURA DEL RESULTADO</a:t>
             </a:r>
           </a:p>
         </p:txBody>
@@ -20124,7 +18727,7 @@
                 <a:ea typeface="Arial"/>
                 <a:cs typeface="Arial"/>
               </a:rPr>
-              <a:t>Cuarentena</a:t>
+              <a:t>Evento nuevo</a:t>
             </a:r>
           </a:p>
         </p:txBody>
@@ -20182,7 +18785,7 @@
                 <a:ea typeface="Arial"/>
                 <a:cs typeface="Arial"/>
               </a:rPr>
-              <a:t>455 registros documentados</a:t>
+              <a:t>El modelo casi no lo anticipa</a:t>
             </a:r>
           </a:p>
         </p:txBody>
@@ -20282,7 +18885,7 @@
                 <a:ea typeface="Arial"/>
                 <a:cs typeface="Arial"/>
               </a:rPr>
-              <a:t>Evaluables</a:t>
+              <a:t>Problema existente</a:t>
             </a:r>
           </a:p>
         </p:txBody>
@@ -20340,7 +18943,7 @@
                 <a:ea typeface="Arial"/>
                 <a:cs typeface="Arial"/>
               </a:rPr>
-              <a:t>25.797 ventanas</a:t>
+              <a:t>El modelo alerta todos los casos</a:t>
             </a:r>
           </a:p>
         </p:txBody>
@@ -20440,7 +19043,7 @@
                 <a:ea typeface="Arial"/>
                 <a:cs typeface="Arial"/>
               </a:rPr>
-              <a:t>Sin futuro completo</a:t>
+              <a:t>Diferencia por producto</a:t>
             </a:r>
           </a:p>
         </p:txBody>
@@ -20498,7 +19101,7 @@
                 <a:ea typeface="Arial"/>
                 <a:cs typeface="Arial"/>
               </a:rPr>
-              <a:t>2.668 ventanas</a:t>
+              <a:t>El desempeño no es uniforme</a:t>
             </a:r>
           </a:p>
         </p:txBody>
@@ -20596,7 +19199,7 @@
                 <a:ea typeface="Arial"/>
                 <a:cs typeface="Arial"/>
               </a:rPr>
-              <a:t>Silver + cuarentena = Bronze</a:t>
+              <a:t>producto_id se usa solo para auditar</a:t>
             </a:r>
           </a:p>
         </p:txBody>
@@ -20694,7 +19297,7 @@
                 <a:ea typeface="Arial"/>
                 <a:cs typeface="Arial"/>
               </a:rPr>
-              <a:t>Conclusión: cada cifra del modelo puede rastrearse hasta la fuente y las exclusiones quedan documentadas.</a:t>
+              <a:t>Conclusión: el modelo reconoce mejor la continuidad de una desviación que la aparición temprana de un evento nuevo.</a:t>
             </a:r>
           </a:p>
         </p:txBody>
@@ -20828,7 +19431,7 @@
                 <a:ea typeface="Arial"/>
                 <a:cs typeface="Arial"/>
               </a:rPr>
-              <a:t>08 · DE LA EVIDENCIA A LA ACCIÓN</a:t>
+              <a:t>05 · INTERPRETACIÓN Y RECOMENDACIONES</a:t>
             </a:r>
           </a:p>
         </p:txBody>
@@ -21204,7 +19807,7 @@
                 <a:ea typeface="Arial"/>
                 <a:cs typeface="Arial"/>
               </a:rPr>
-              <a:t>El modelo ordena el riesgo futuro, pero necesita revisión humana porque omite eventos reales</a:t>
+              <a:t>El modelo reconoce mejor problemas existentes que desviaciones nuevas</a:t>
             </a:r>
           </a:p>
         </p:txBody>
@@ -21213,13 +19816,7 @@
         <p:nvGraphicFramePr>
           <p:cNvPr id="25" name="Table 22"/>
           <p:cNvGraphicFramePr/>
-          <p:nvPr>
-            <p:extLst>
-              <p:ext uri="{D42A27DB-BD31-4B8C-83A1-F6EECF244321}">
-                <p14:modId xmlns:p14="http://schemas.microsoft.com/office/powerpoint/2010/main" val="2666022863"/>
-              </p:ext>
-            </p:extLst>
-          </p:nvPr>
+          <p:nvPr/>
         </p:nvGraphicFramePr>
         <p:xfrm>
           <a:off x="533400" y="2381250"/>
@@ -21290,7 +19887,7 @@
                     <a:lstStyle/>
                     <a:p>
                       <a:r>
-                        <a:rPr sz="1125" b="1" dirty="0" err="1">
+                        <a:rPr sz="1125" b="1">
                           <a:solidFill>
                             <a:srgbClr val="FFFFFF"/>
                           </a:solidFill>
@@ -21298,38 +19895,8 @@
                           <a:ea typeface="Arial"/>
                           <a:cs typeface="Arial"/>
                         </a:rPr>
-                        <a:t>Acción</a:t>
+                        <a:t>Acción recomendada</a:t>
                       </a:r>
-                      <a:r>
-                        <a:rPr sz="1125" b="1" dirty="0">
-                          <a:solidFill>
-                            <a:srgbClr val="FFFFFF"/>
-                          </a:solidFill>
-                          <a:latin typeface="Arial"/>
-                          <a:ea typeface="Arial"/>
-                          <a:cs typeface="Arial"/>
-                        </a:rPr>
-                        <a:t> </a:t>
-                      </a:r>
-                      <a:r>
-                        <a:rPr sz="1125" b="1" dirty="0" err="1">
-                          <a:solidFill>
-                            <a:srgbClr val="FFFFFF"/>
-                          </a:solidFill>
-                          <a:latin typeface="Arial"/>
-                          <a:ea typeface="Arial"/>
-                          <a:cs typeface="Arial"/>
-                        </a:rPr>
-                        <a:t>recomendada</a:t>
-                      </a:r>
-                      <a:endParaRPr sz="1125" b="1" dirty="0">
-                        <a:solidFill>
-                          <a:srgbClr val="FFFFFF"/>
-                        </a:solidFill>
-                        <a:latin typeface="Arial"/>
-                        <a:ea typeface="Arial"/>
-                        <a:cs typeface="Arial"/>
-                      </a:endParaRPr>
                     </a:p>
                   </a:txBody>
                   <a:tcPr marL="95250" marR="95250" marT="66675" marB="66675" anchor="ctr">
@@ -21431,7 +19998,7 @@
                           <a:ea typeface="Arial"/>
                           <a:cs typeface="Arial"/>
                         </a:rPr>
-                        <a:t>Revisar primero las alertas del modelo</a:t>
+                        <a:t>Evaluar eventos que parten de estado normal</a:t>
                       </a:r>
                     </a:p>
                   </a:txBody>
@@ -21455,7 +20022,7 @@
                           <a:ea typeface="Arial"/>
                           <a:cs typeface="Arial"/>
                         </a:rPr>
-                        <a:t>130 eventos detectados; 331 falsas alertas</a:t>
+                        <a:t>Recall 6,33%; 148 eventos omitidos</a:t>
                       </a:r>
                     </a:p>
                   </a:txBody>
@@ -21479,7 +20046,7 @@
                           <a:ea typeface="Arial"/>
                           <a:cs typeface="Arial"/>
                         </a:rPr>
-                        <a:t>Operaciones de cadena de frío</a:t>
+                        <a:t>Analítica y operaciones</a:t>
                       </a:r>
                     </a:p>
                   </a:txBody>
@@ -21534,7 +20101,7 @@
                           <a:ea typeface="Arial"/>
                           <a:cs typeface="Arial"/>
                         </a:rPr>
-                        <a:t>Definir costos y validar otro umbral</a:t>
+                        <a:t>Validar por producto y grupo térmico</a:t>
                       </a:r>
                     </a:p>
                   </a:txBody>
@@ -21558,7 +20125,7 @@
                           <a:ea typeface="Arial"/>
                           <a:cs typeface="Arial"/>
                         </a:rPr>
-                        <a:t>148 falsos negativos; precisión 28,20%</a:t>
+                        <a:t>Recall 18,07% en el grupo cercano a 20 °C</a:t>
                       </a:r>
                     </a:p>
                   </a:txBody>
@@ -21582,7 +20149,7 @@
                           <a:ea typeface="Arial"/>
                           <a:cs typeface="Arial"/>
                         </a:rPr>
-                        <a:t>Operaciones, calidad y analítica</a:t>
+                        <a:t>Calidad y operaciones</a:t>
                       </a:r>
                     </a:p>
                   </a:txBody>
@@ -21629,7 +20196,7 @@
                     <a:lstStyle/>
                     <a:p>
                       <a:r>
-                        <a:rPr sz="1125" dirty="0" err="1">
+                        <a:rPr sz="1125">
                           <a:solidFill>
                             <a:srgbClr val="1F3864"/>
                           </a:solidFill>
@@ -21637,40 +20204,7 @@
                           <a:ea typeface="Arial"/>
                           <a:cs typeface="Arial"/>
                         </a:rPr>
-                        <a:t>Monitorear</a:t>
-                      </a:r>
-                      <a:r>
-                        <a:rPr sz="1125" dirty="0">
-                          <a:solidFill>
-                            <a:srgbClr val="1F3864"/>
-                          </a:solidFill>
-                          <a:latin typeface="Arial"/>
-                          <a:ea typeface="Arial"/>
-                          <a:cs typeface="Arial"/>
-                        </a:rPr>
-                        <a:t> recall, </a:t>
-                      </a:r>
-                      <a:r>
-                        <a:rPr sz="1125" dirty="0" err="1">
-                          <a:solidFill>
-                            <a:srgbClr val="1F3864"/>
-                          </a:solidFill>
-                          <a:latin typeface="Arial"/>
-                          <a:ea typeface="Arial"/>
-                          <a:cs typeface="Arial"/>
-                        </a:rPr>
-                        <a:t>precisión</a:t>
-                      </a:r>
-                      <a:r>
-                        <a:rPr sz="1125" dirty="0">
-                          <a:solidFill>
-                            <a:srgbClr val="1F3864"/>
-                          </a:solidFill>
-                          <a:latin typeface="Arial"/>
-                          <a:ea typeface="Arial"/>
-                          <a:cs typeface="Arial"/>
-                        </a:rPr>
-                        <a:t> y PR AUC</a:t>
+                        <a:t>Definir costos y revisar el umbral</a:t>
                       </a:r>
                     </a:p>
                   </a:txBody>
@@ -21694,7 +20228,7 @@
                           <a:ea typeface="Arial"/>
                           <a:cs typeface="Arial"/>
                         </a:rPr>
-                        <a:t>Clase positiva 5,02%</a:t>
+                        <a:t>331 falsas alertas; precisión 28,20%</a:t>
                       </a:r>
                     </a:p>
                   </a:txBody>
@@ -21710,7 +20244,7 @@
                     <a:lstStyle/>
                     <a:p>
                       <a:r>
-                        <a:rPr sz="1125" dirty="0">
+                        <a:rPr sz="1125">
                           <a:solidFill>
                             <a:srgbClr val="1F3864"/>
                           </a:solidFill>
@@ -21718,71 +20252,8 @@
                           <a:ea typeface="Arial"/>
                           <a:cs typeface="Arial"/>
                         </a:rPr>
-                        <a:t>Equipo </a:t>
+                        <a:t>Operaciones y analítica</a:t>
                       </a:r>
-                      <a:r>
-                        <a:rPr sz="1125" dirty="0" err="1">
-                          <a:solidFill>
-                            <a:srgbClr val="1F3864"/>
-                          </a:solidFill>
-                          <a:latin typeface="Arial"/>
-                          <a:ea typeface="Arial"/>
-                          <a:cs typeface="Arial"/>
-                        </a:rPr>
-                        <a:t>analítico</a:t>
-                      </a:r>
-                      <a:r>
-                        <a:rPr sz="1125" dirty="0">
-                          <a:solidFill>
-                            <a:srgbClr val="1F3864"/>
-                          </a:solidFill>
-                          <a:latin typeface="Arial"/>
-                          <a:ea typeface="Arial"/>
-                          <a:cs typeface="Arial"/>
-                        </a:rPr>
-                        <a:t> </a:t>
-                      </a:r>
-                      <a:r>
-                        <a:rPr sz="1125" dirty="0" err="1">
-                          <a:solidFill>
-                            <a:srgbClr val="1F3864"/>
-                          </a:solidFill>
-                          <a:latin typeface="Arial"/>
-                          <a:ea typeface="Arial"/>
-                          <a:cs typeface="Arial"/>
-                        </a:rPr>
-                        <a:t>por</a:t>
-                      </a:r>
-                      <a:r>
-                        <a:rPr sz="1125" dirty="0">
-                          <a:solidFill>
-                            <a:srgbClr val="1F3864"/>
-                          </a:solidFill>
-                          <a:latin typeface="Arial"/>
-                          <a:ea typeface="Arial"/>
-                          <a:cs typeface="Arial"/>
-                        </a:rPr>
-                        <a:t> </a:t>
-                      </a:r>
-                      <a:r>
-                        <a:rPr sz="1125" dirty="0" err="1">
-                          <a:solidFill>
-                            <a:srgbClr val="1F3864"/>
-                          </a:solidFill>
-                          <a:latin typeface="Arial"/>
-                          <a:ea typeface="Arial"/>
-                          <a:cs typeface="Arial"/>
-                        </a:rPr>
-                        <a:t>periodo</a:t>
-                      </a:r>
-                      <a:endParaRPr sz="1125" dirty="0">
-                        <a:solidFill>
-                          <a:srgbClr val="1F3864"/>
-                        </a:solidFill>
-                        <a:latin typeface="Arial"/>
-                        <a:ea typeface="Arial"/>
-                        <a:cs typeface="Arial"/>
-                      </a:endParaRPr>
                     </a:p>
                   </a:txBody>
                   <a:tcPr marL="95250" marR="95250" marT="66675" marB="66675" anchor="ctr">
@@ -21952,7 +20423,7 @@
                 <a:ea typeface="Arial"/>
                 <a:cs typeface="Arial"/>
               </a:rPr>
-              <a:t>Los resultados muestran asociaciones predictivas, no causas. El umbral requiere validación separada antes del uso operativo.</a:t>
+              <a:t>Uso recomendado: priorización supervisada. Se necesitan rangos térmicos oficiales y validación con viajes nuevos antes del uso operativo.</a:t>
             </a:r>
           </a:p>
         </p:txBody>

</xml_diff>